<commit_message>
Fix Crimson presentation: 1 image per slide, readable text, Japanese base
- 各スライド画像1枚のみに修正
- 背景画像使用時はPillowで明度を下げて文字が沈まないように
- 本文を日本語ベースに統一（タイトル系は英語OK）
- 「画像横+テキスト」か「暗い背景画像+テキスト」の2パターンで統一

https://claude.ai/code/session_01Pt9LYytkm79mcRSuRrKMQn
</commit_message>
<xml_diff>
--- a/crimson_presentation.pptx
+++ b/crimson_presentation.pptx
@@ -3094,7 +3094,7 @@
     <p:bg>
       <p:bgPr>
         <a:solidFill>
-          <a:srgbClr val="0C0808"/>
+          <a:srgbClr val="120C0C"/>
         </a:solidFill>
         <a:effectLst/>
       </p:bgPr>
@@ -3122,8 +3122,8 @@
         </p:blipFill>
         <p:spPr>
           <a:xfrm>
-            <a:off x="6858000" y="0"/>
-            <a:ext cx="7009726" cy="6858000"/>
+            <a:off x="731520" y="731520"/>
+            <a:ext cx="5420855" cy="5303520"/>
           </a:xfrm>
           <a:prstGeom prst="rect">
             <a:avLst/>
@@ -3138,16 +3138,14 @@
         </p:nvSpPr>
         <p:spPr>
           <a:xfrm>
-            <a:off x="0" y="0"/>
-            <a:ext cx="7772400" cy="6858000"/>
+            <a:off x="5303520" y="457200"/>
+            <a:ext cx="45720" cy="5943600"/>
           </a:xfrm>
           <a:prstGeom prst="rect">
             <a:avLst/>
           </a:prstGeom>
           <a:solidFill>
-            <a:srgbClr val="000000">
-              <a:alpha val="60000"/>
-            </a:srgbClr>
+            <a:srgbClr val="D4AF37"/>
           </a:solidFill>
           <a:ln>
             <a:noFill/>
@@ -3183,8 +3181,8 @@
         </p:nvSpPr>
         <p:spPr>
           <a:xfrm>
-            <a:off x="914400" y="1645920"/>
-            <a:ext cx="4114800" cy="36576"/>
+            <a:off x="5760720" y="1828800"/>
+            <a:ext cx="5029200" cy="36576"/>
           </a:xfrm>
           <a:prstGeom prst="rect">
             <a:avLst/>
@@ -3220,14 +3218,122 @@
       </p:sp>
       <p:sp>
         <p:nvSpPr>
-          <p:cNvPr id="5" name="Rectangle 4"/>
+          <p:cNvPr id="5" name="TextBox 4"/>
+          <p:cNvSpPr txBox="1"/>
+          <p:nvPr/>
+        </p:nvSpPr>
+        <p:spPr>
+          <a:xfrm>
+            <a:off x="5760720" y="2103120"/>
+            <a:ext cx="5486400" cy="1371600"/>
+          </a:xfrm>
+          <a:prstGeom prst="rect">
+            <a:avLst/>
+          </a:prstGeom>
+          <a:noFill/>
+        </p:spPr>
+        <p:txBody>
+          <a:bodyPr wrap="square">
+            <a:spAutoFit/>
+          </a:bodyPr>
+          <a:lstStyle/>
+          <a:p>
+            <a:pPr algn="ctr">
+              <a:defRPr sz="7600" b="1">
+                <a:solidFill>
+                  <a:srgbClr val="B41E1E"/>
+                </a:solidFill>
+                <a:latin typeface="Arial"/>
+              </a:defRPr>
+            </a:pPr>
+            <a:r>
+              <a:t>CRIMSON</a:t>
+            </a:r>
+          </a:p>
+        </p:txBody>
+      </p:sp>
+      <p:sp>
+        <p:nvSpPr>
+          <p:cNvPr id="6" name="TextBox 5"/>
+          <p:cNvSpPr txBox="1"/>
+          <p:nvPr/>
+        </p:nvSpPr>
+        <p:spPr>
+          <a:xfrm>
+            <a:off x="5760720" y="3291840"/>
+            <a:ext cx="5486400" cy="640080"/>
+          </a:xfrm>
+          <a:prstGeom prst="rect">
+            <a:avLst/>
+          </a:prstGeom>
+          <a:noFill/>
+        </p:spPr>
+        <p:txBody>
+          <a:bodyPr wrap="square">
+            <a:spAutoFit/>
+          </a:bodyPr>
+          <a:lstStyle/>
+          <a:p>
+            <a:pPr algn="ctr">
+              <a:defRPr sz="3600" b="0">
+                <a:solidFill>
+                  <a:srgbClr val="D4AF37"/>
+                </a:solidFill>
+                <a:latin typeface="Arial"/>
+              </a:defRPr>
+            </a:pPr>
+            <a:r>
+              <a:t>Knolastname</a:t>
+            </a:r>
+          </a:p>
+        </p:txBody>
+      </p:sp>
+      <p:sp>
+        <p:nvSpPr>
+          <p:cNvPr id="7" name="TextBox 6"/>
+          <p:cNvSpPr txBox="1"/>
+          <p:nvPr/>
+        </p:nvSpPr>
+        <p:spPr>
+          <a:xfrm>
+            <a:off x="5760720" y="4023360"/>
+            <a:ext cx="5486400" cy="640080"/>
+          </a:xfrm>
+          <a:prstGeom prst="rect">
+            <a:avLst/>
+          </a:prstGeom>
+          <a:noFill/>
+        </p:spPr>
+        <p:txBody>
+          <a:bodyPr wrap="square">
+            <a:spAutoFit/>
+          </a:bodyPr>
+          <a:lstStyle/>
+          <a:p>
+            <a:pPr algn="ctr">
+              <a:defRPr sz="2000" b="0">
+                <a:solidFill>
+                  <a:srgbClr val="BEB9B4"/>
+                </a:solidFill>
+                <a:latin typeface="Arial"/>
+              </a:defRPr>
+            </a:pPr>
+            <a:r>
+              <a:t>Greed Ring's Most Feared Mafia Boss</a:t>
+            </a:r>
+          </a:p>
+        </p:txBody>
+      </p:sp>
+      <p:sp>
+        <p:nvSpPr>
+          <p:cNvPr id="8" name="Rectangle 7"/>
           <p:cNvSpPr/>
           <p:nvPr/>
         </p:nvSpPr>
         <p:spPr>
           <a:xfrm>
-            <a:off x="914400" y="4754880"/>
-            <a:ext cx="4114800" cy="36576"/>
+            <a:off x="5760720" y="4846320"/>
+            <a:ext cx="5029200" cy="36576"/>
           </a:xfrm>
           <a:prstGeom prst="rect">
             <a:avLst/>
@@ -3263,122 +3369,14 @@
       </p:sp>
       <p:sp>
         <p:nvSpPr>
-          <p:cNvPr id="6" name="TextBox 5"/>
-          <p:cNvSpPr txBox="1"/>
-          <p:nvPr/>
-        </p:nvSpPr>
-        <p:spPr>
-          <a:xfrm>
-            <a:off x="914400" y="1920240"/>
-            <a:ext cx="5029200" cy="1371600"/>
-          </a:xfrm>
-          <a:prstGeom prst="rect">
-            <a:avLst/>
-          </a:prstGeom>
-          <a:noFill/>
-        </p:spPr>
-        <p:txBody>
-          <a:bodyPr wrap="square">
-            <a:spAutoFit/>
-          </a:bodyPr>
-          <a:lstStyle/>
-          <a:p>
-            <a:pPr algn="ctr">
-              <a:defRPr sz="7200" b="1">
-                <a:solidFill>
-                  <a:srgbClr val="A51919"/>
-                </a:solidFill>
-                <a:latin typeface="Arial"/>
-              </a:defRPr>
-            </a:pPr>
-            <a:r>
-              <a:t>CRIMSON</a:t>
-            </a:r>
-          </a:p>
-        </p:txBody>
-      </p:sp>
-      <p:sp>
-        <p:nvSpPr>
-          <p:cNvPr id="7" name="TextBox 6"/>
-          <p:cNvSpPr txBox="1"/>
-          <p:nvPr/>
-        </p:nvSpPr>
-        <p:spPr>
-          <a:xfrm>
-            <a:off x="914400" y="3108960"/>
-            <a:ext cx="5029200" cy="731520"/>
-          </a:xfrm>
-          <a:prstGeom prst="rect">
-            <a:avLst/>
-          </a:prstGeom>
-          <a:noFill/>
-        </p:spPr>
-        <p:txBody>
-          <a:bodyPr wrap="square">
-            <a:spAutoFit/>
-          </a:bodyPr>
-          <a:lstStyle/>
-          <a:p>
-            <a:pPr algn="ctr">
-              <a:defRPr sz="3600" b="0">
-                <a:solidFill>
-                  <a:srgbClr val="D4AF37"/>
-                </a:solidFill>
-                <a:latin typeface="Arial"/>
-              </a:defRPr>
-            </a:pPr>
-            <a:r>
-              <a:t>Knolastname</a:t>
-            </a:r>
-          </a:p>
-        </p:txBody>
-      </p:sp>
-      <p:sp>
-        <p:nvSpPr>
-          <p:cNvPr id="8" name="TextBox 7"/>
-          <p:cNvSpPr txBox="1"/>
-          <p:nvPr/>
-        </p:nvSpPr>
-        <p:spPr>
-          <a:xfrm>
-            <a:off x="914400" y="3840480"/>
-            <a:ext cx="5029200" cy="731520"/>
-          </a:xfrm>
-          <a:prstGeom prst="rect">
-            <a:avLst/>
-          </a:prstGeom>
-          <a:noFill/>
-        </p:spPr>
-        <p:txBody>
-          <a:bodyPr wrap="square">
-            <a:spAutoFit/>
-          </a:bodyPr>
-          <a:lstStyle/>
-          <a:p>
-            <a:pPr algn="ctr">
-              <a:defRPr sz="2000" b="0">
-                <a:solidFill>
-                  <a:srgbClr val="B4AFAA"/>
-                </a:solidFill>
-                <a:latin typeface="Arial"/>
-              </a:defRPr>
-            </a:pPr>
-            <a:r>
-              <a:t>Greed Ring's Most Feared Mafia Boss</a:t>
-            </a:r>
-          </a:p>
-        </p:txBody>
-      </p:sp>
-      <p:sp>
-        <p:nvSpPr>
           <p:cNvPr id="9" name="TextBox 8"/>
           <p:cNvSpPr txBox="1"/>
           <p:nvPr/>
         </p:nvSpPr>
         <p:spPr>
           <a:xfrm>
-            <a:off x="914400" y="5486400"/>
-            <a:ext cx="5029200" cy="457200"/>
+            <a:off x="5760720" y="5669280"/>
+            <a:ext cx="5486400" cy="457200"/>
           </a:xfrm>
           <a:prstGeom prst="rect">
             <a:avLst/>
@@ -3419,7 +3417,7 @@
     <p:bg>
       <p:bgPr>
         <a:solidFill>
-          <a:srgbClr val="08050C"/>
+          <a:srgbClr val="120C12"/>
         </a:solidFill>
         <a:effectLst/>
       </p:bgPr>
@@ -3433,7 +3431,7 @@
       <p:grpSpPr/>
       <p:pic>
         <p:nvPicPr>
-          <p:cNvPr id="2" name="Picture 1" descr="crimson-8.JPG"/>
+          <p:cNvPr id="2" name="Picture 1" descr="crimson-2.PNG"/>
           <p:cNvPicPr>
             <a:picLocks noChangeAspect="1"/>
           </p:cNvPicPr>
@@ -3447,8 +3445,8 @@
         </p:blipFill>
         <p:spPr>
           <a:xfrm>
-            <a:off x="0" y="0"/>
-            <a:ext cx="6400800" cy="3598651"/>
+            <a:off x="457200" y="914400"/>
+            <a:ext cx="5899355" cy="5486400"/>
           </a:xfrm>
           <a:prstGeom prst="rect">
             <a:avLst/>
@@ -3463,16 +3461,14 @@
         </p:nvSpPr>
         <p:spPr>
           <a:xfrm>
-            <a:off x="0" y="0"/>
-            <a:ext cx="6400800" cy="6858000"/>
+            <a:off x="4389120" y="0"/>
+            <a:ext cx="45720" cy="6858000"/>
           </a:xfrm>
           <a:prstGeom prst="rect">
             <a:avLst/>
           </a:prstGeom>
           <a:solidFill>
-            <a:srgbClr val="000000">
-              <a:alpha val="30000"/>
-            </a:srgbClr>
+            <a:srgbClr val="D4AF37"/>
           </a:solidFill>
           <a:ln>
             <a:noFill/>
@@ -3502,14 +3498,86 @@
       </p:sp>
       <p:sp>
         <p:nvSpPr>
-          <p:cNvPr id="4" name="Rectangle 3"/>
+          <p:cNvPr id="4" name="TextBox 3"/>
+          <p:cNvSpPr txBox="1"/>
+          <p:nvPr/>
+        </p:nvSpPr>
+        <p:spPr>
+          <a:xfrm>
+            <a:off x="4846320" y="457200"/>
+            <a:ext cx="6858000" cy="548640"/>
+          </a:xfrm>
+          <a:prstGeom prst="rect">
+            <a:avLst/>
+          </a:prstGeom>
+          <a:noFill/>
+        </p:spPr>
+        <p:txBody>
+          <a:bodyPr wrap="square">
+            <a:spAutoFit/>
+          </a:bodyPr>
+          <a:lstStyle/>
+          <a:p>
+            <a:pPr algn="ctr">
+              <a:defRPr sz="2800" b="0">
+                <a:solidFill>
+                  <a:srgbClr val="BEB9B4"/>
+                </a:solidFill>
+                <a:latin typeface="Arial"/>
+              </a:defRPr>
+            </a:pPr>
+            <a:r>
+              <a:t>WHY WE</a:t>
+            </a:r>
+          </a:p>
+        </p:txBody>
+      </p:sp>
+      <p:sp>
+        <p:nvSpPr>
+          <p:cNvPr id="5" name="TextBox 4"/>
+          <p:cNvSpPr txBox="1"/>
+          <p:nvPr/>
+        </p:nvSpPr>
+        <p:spPr>
+          <a:xfrm>
+            <a:off x="4846320" y="914400"/>
+            <a:ext cx="6858000" cy="822960"/>
+          </a:xfrm>
+          <a:prstGeom prst="rect">
+            <a:avLst/>
+          </a:prstGeom>
+          <a:noFill/>
+        </p:spPr>
+        <p:txBody>
+          <a:bodyPr wrap="square">
+            <a:spAutoFit/>
+          </a:bodyPr>
+          <a:lstStyle/>
+          <a:p>
+            <a:pPr algn="ctr">
+              <a:defRPr sz="5200" b="1">
+                <a:solidFill>
+                  <a:srgbClr val="B41E1E"/>
+                </a:solidFill>
+                <a:latin typeface="Arial"/>
+              </a:defRPr>
+            </a:pPr>
+            <a:r>
+              <a:t>LOVE HIM</a:t>
+            </a:r>
+          </a:p>
+        </p:txBody>
+      </p:sp>
+      <p:sp>
+        <p:nvSpPr>
+          <p:cNvPr id="6" name="Rectangle 5"/>
           <p:cNvSpPr/>
           <p:nvPr/>
         </p:nvSpPr>
         <p:spPr>
           <a:xfrm>
-            <a:off x="6217920" y="0"/>
-            <a:ext cx="54864" cy="6858000"/>
+            <a:off x="4846320" y="1737360"/>
+            <a:ext cx="5029200" cy="36576"/>
           </a:xfrm>
           <a:prstGeom prst="rect">
             <a:avLst/>
@@ -3545,59 +3613,14 @@
       </p:sp>
       <p:sp>
         <p:nvSpPr>
-          <p:cNvPr id="5" name="Rectangle 4"/>
-          <p:cNvSpPr/>
-          <p:nvPr/>
-        </p:nvSpPr>
-        <p:spPr>
-          <a:xfrm>
-            <a:off x="6272784" y="0"/>
-            <a:ext cx="5943600" cy="6858000"/>
-          </a:xfrm>
-          <a:prstGeom prst="rect">
-            <a:avLst/>
-          </a:prstGeom>
-          <a:solidFill>
-            <a:srgbClr val="0C0808">
-              <a:alpha val="85000"/>
-            </a:srgbClr>
-          </a:solidFill>
-          <a:ln>
-            <a:noFill/>
-          </a:ln>
-        </p:spPr>
-        <p:style>
-          <a:lnRef idx="1">
-            <a:schemeClr val="accent1"/>
-          </a:lnRef>
-          <a:fillRef idx="3">
-            <a:schemeClr val="accent1"/>
-          </a:fillRef>
-          <a:effectRef idx="2">
-            <a:schemeClr val="accent1"/>
-          </a:effectRef>
-          <a:fontRef idx="minor">
-            <a:schemeClr val="lt1"/>
-          </a:fontRef>
-        </p:style>
-        <p:txBody>
-          <a:bodyPr rtlCol="0" anchor="ctr"/>
-          <a:lstStyle/>
-          <a:p>
-            <a:pPr algn="ctr"/>
-          </a:p>
-        </p:txBody>
-      </p:sp>
-      <p:sp>
-        <p:nvSpPr>
-          <p:cNvPr id="6" name="TextBox 5"/>
+          <p:cNvPr id="7" name="TextBox 6"/>
           <p:cNvSpPr txBox="1"/>
           <p:nvPr/>
         </p:nvSpPr>
         <p:spPr>
           <a:xfrm>
-            <a:off x="6583680" y="365760"/>
-            <a:ext cx="5029200" cy="914400"/>
+            <a:off x="5029200" y="2103120"/>
+            <a:ext cx="5943600" cy="4572000"/>
           </a:xfrm>
           <a:prstGeom prst="rect">
             <a:avLst/>
@@ -3610,126 +3633,11 @@
           </a:bodyPr>
           <a:lstStyle/>
           <a:p>
-            <a:pPr algn="ctr">
-              <a:defRPr sz="2800" b="0">
-                <a:solidFill>
-                  <a:srgbClr val="B4AFAA"/>
-                </a:solidFill>
-                <a:latin typeface="Arial"/>
-              </a:defRPr>
-            </a:pPr>
-            <a:r>
-              <a:t>WHY WE</a:t>
-            </a:r>
-          </a:p>
-        </p:txBody>
-      </p:sp>
-      <p:sp>
-        <p:nvSpPr>
-          <p:cNvPr id="7" name="TextBox 6"/>
-          <p:cNvSpPr txBox="1"/>
-          <p:nvPr/>
-        </p:nvSpPr>
-        <p:spPr>
-          <a:xfrm>
-            <a:off x="6583680" y="822960"/>
-            <a:ext cx="5029200" cy="914400"/>
-          </a:xfrm>
-          <a:prstGeom prst="rect">
-            <a:avLst/>
-          </a:prstGeom>
-          <a:noFill/>
-        </p:spPr>
-        <p:txBody>
-          <a:bodyPr wrap="square">
-            <a:spAutoFit/>
-          </a:bodyPr>
-          <a:lstStyle/>
-          <a:p>
-            <a:pPr algn="ctr">
-              <a:defRPr sz="4800" b="1">
-                <a:solidFill>
-                  <a:srgbClr val="A51919"/>
-                </a:solidFill>
-                <a:latin typeface="Arial"/>
-              </a:defRPr>
-            </a:pPr>
-            <a:r>
-              <a:t>LOVE HIM</a:t>
-            </a:r>
-          </a:p>
-        </p:txBody>
-      </p:sp>
-      <p:sp>
-        <p:nvSpPr>
-          <p:cNvPr id="8" name="Rectangle 7"/>
-          <p:cNvSpPr/>
-          <p:nvPr/>
-        </p:nvSpPr>
-        <p:spPr>
-          <a:xfrm>
-            <a:off x="6583680" y="1645920"/>
-            <a:ext cx="4114800" cy="36576"/>
-          </a:xfrm>
-          <a:prstGeom prst="rect">
-            <a:avLst/>
-          </a:prstGeom>
-          <a:solidFill>
-            <a:srgbClr val="D4AF37"/>
-          </a:solidFill>
-          <a:ln>
-            <a:noFill/>
-          </a:ln>
-        </p:spPr>
-        <p:style>
-          <a:lnRef idx="1">
-            <a:schemeClr val="accent1"/>
-          </a:lnRef>
-          <a:fillRef idx="3">
-            <a:schemeClr val="accent1"/>
-          </a:fillRef>
-          <a:effectRef idx="2">
-            <a:schemeClr val="accent1"/>
-          </a:effectRef>
-          <a:fontRef idx="minor">
-            <a:schemeClr val="lt1"/>
-          </a:fontRef>
-        </p:style>
-        <p:txBody>
-          <a:bodyPr rtlCol="0" anchor="ctr"/>
-          <a:lstStyle/>
-          <a:p>
-            <a:pPr algn="ctr"/>
-          </a:p>
-        </p:txBody>
-      </p:sp>
-      <p:sp>
-        <p:nvSpPr>
-          <p:cNvPr id="9" name="TextBox 8"/>
-          <p:cNvSpPr txBox="1"/>
-          <p:nvPr/>
-        </p:nvSpPr>
-        <p:spPr>
-          <a:xfrm>
-            <a:off x="6766560" y="2011680"/>
-            <a:ext cx="4846320" cy="4572000"/>
-          </a:xfrm>
-          <a:prstGeom prst="rect">
-            <a:avLst/>
-          </a:prstGeom>
-          <a:noFill/>
-        </p:spPr>
-        <p:txBody>
-          <a:bodyPr wrap="square">
-            <a:spAutoFit/>
-          </a:bodyPr>
-          <a:lstStyle/>
-          <a:p>
             <a:pPr algn="l">
               <a:spcAft>
-                <a:spcPts val="190"/>
+                <a:spcPts val="200"/>
               </a:spcAft>
-              <a:defRPr sz="1900" b="0">
+              <a:defRPr sz="2000" b="0">
                 <a:solidFill>
                   <a:srgbClr val="F5F0EB"/>
                 </a:solidFill>
@@ -3743,9 +3651,9 @@
           <a:p>
             <a:pPr algn="l">
               <a:spcAft>
-                <a:spcPts val="190"/>
+                <a:spcPts val="200"/>
               </a:spcAft>
-              <a:defRPr sz="1900" b="0">
+              <a:defRPr sz="2000" b="0">
                 <a:solidFill>
                   <a:srgbClr val="F5F0EB"/>
                 </a:solidFill>
@@ -3756,9 +3664,9 @@
           <a:p>
             <a:pPr algn="l">
               <a:spcAft>
-                <a:spcPts val="190"/>
+                <a:spcPts val="200"/>
               </a:spcAft>
-              <a:defRPr sz="1900" b="0">
+              <a:defRPr sz="2000" b="0">
                 <a:solidFill>
                   <a:srgbClr val="F5F0EB"/>
                 </a:solidFill>
@@ -3772,9 +3680,9 @@
           <a:p>
             <a:pPr algn="l">
               <a:spcAft>
-                <a:spcPts val="190"/>
+                <a:spcPts val="200"/>
               </a:spcAft>
-              <a:defRPr sz="1900" b="0">
+              <a:defRPr sz="2000" b="0">
                 <a:solidFill>
                   <a:srgbClr val="F5F0EB"/>
                 </a:solidFill>
@@ -3785,9 +3693,9 @@
           <a:p>
             <a:pPr algn="l">
               <a:spcAft>
-                <a:spcPts val="190"/>
+                <a:spcPts val="200"/>
               </a:spcAft>
-              <a:defRPr sz="1900" b="0">
+              <a:defRPr sz="2000" b="0">
                 <a:solidFill>
                   <a:srgbClr val="F5F0EB"/>
                 </a:solidFill>
@@ -3801,9 +3709,9 @@
           <a:p>
             <a:pPr algn="l">
               <a:spcAft>
-                <a:spcPts val="190"/>
+                <a:spcPts val="200"/>
               </a:spcAft>
-              <a:defRPr sz="1900" b="0">
+              <a:defRPr sz="2000" b="0">
                 <a:solidFill>
                   <a:srgbClr val="F5F0EB"/>
                 </a:solidFill>
@@ -3814,9 +3722,9 @@
           <a:p>
             <a:pPr algn="l">
               <a:spcAft>
-                <a:spcPts val="190"/>
+                <a:spcPts val="200"/>
               </a:spcAft>
-              <a:defRPr sz="1900" b="0">
+              <a:defRPr sz="2000" b="0">
                 <a:solidFill>
                   <a:srgbClr val="F5F0EB"/>
                 </a:solidFill>
@@ -3824,15 +3732,15 @@
               </a:defRPr>
             </a:pPr>
             <a:r>
-              <a:t>PTSDを抱えながらも足掻き続ける強さ</a:t>
+              <a:t>傷を抱えながらも足掻き続ける強さ</a:t>
             </a:r>
           </a:p>
           <a:p>
             <a:pPr algn="l">
               <a:spcAft>
-                <a:spcPts val="190"/>
+                <a:spcPts val="200"/>
               </a:spcAft>
-              <a:defRPr sz="1900" b="0">
+              <a:defRPr sz="2000" b="0">
                 <a:solidFill>
                   <a:srgbClr val="F5F0EB"/>
                 </a:solidFill>
@@ -3843,9 +3751,9 @@
           <a:p>
             <a:pPr algn="l">
               <a:spcAft>
-                <a:spcPts val="190"/>
+                <a:spcPts val="200"/>
               </a:spcAft>
-              <a:defRPr sz="1900" b="0">
+              <a:defRPr sz="2000" b="0">
                 <a:solidFill>
                   <a:srgbClr val="F5F0EB"/>
                 </a:solidFill>
@@ -3859,9 +3767,9 @@
           <a:p>
             <a:pPr algn="l">
               <a:spcAft>
-                <a:spcPts val="190"/>
+                <a:spcPts val="200"/>
               </a:spcAft>
-              <a:defRPr sz="1900" b="0">
+              <a:defRPr sz="2000" b="0">
                 <a:solidFill>
                   <a:srgbClr val="F5F0EB"/>
                 </a:solidFill>
@@ -3872,9 +3780,9 @@
           <a:p>
             <a:pPr algn="l">
               <a:spcAft>
-                <a:spcPts val="190"/>
+                <a:spcPts val="200"/>
               </a:spcAft>
-              <a:defRPr sz="1900" b="0">
+              <a:defRPr sz="2000" b="0">
                 <a:solidFill>
                   <a:srgbClr val="F5F0EB"/>
                 </a:solidFill>
@@ -3888,9 +3796,9 @@
           <a:p>
             <a:pPr algn="l">
               <a:spcAft>
-                <a:spcPts val="190"/>
+                <a:spcPts val="200"/>
               </a:spcAft>
-              <a:defRPr sz="1900" b="0">
+              <a:defRPr sz="2000" b="0">
                 <a:solidFill>
                   <a:srgbClr val="F5F0EB"/>
                 </a:solidFill>
@@ -3917,7 +3825,7 @@
     <p:bg>
       <p:bgPr>
         <a:solidFill>
-          <a:srgbClr val="0C0808"/>
+          <a:srgbClr val="120C0C"/>
         </a:solidFill>
         <a:effectLst/>
       </p:bgPr>
@@ -3961,14 +3869,14 @@
         </p:nvSpPr>
         <p:spPr>
           <a:xfrm>
-            <a:off x="0" y="5669280"/>
-            <a:ext cx="12191695" cy="1188720"/>
+            <a:off x="0" y="5577840"/>
+            <a:ext cx="12191695" cy="1280160"/>
           </a:xfrm>
           <a:prstGeom prst="rect">
             <a:avLst/>
           </a:prstGeom>
           <a:solidFill>
-            <a:srgbClr val="0C0808"/>
+            <a:srgbClr val="120C0C"/>
           </a:solidFill>
           <a:ln>
             <a:noFill/>
@@ -4004,7 +3912,7 @@
         </p:nvSpPr>
         <p:spPr>
           <a:xfrm>
-            <a:off x="0" y="5669280"/>
+            <a:off x="0" y="5577840"/>
             <a:ext cx="12191695" cy="36576"/>
           </a:xfrm>
           <a:prstGeom prst="rect">
@@ -4047,7 +3955,7 @@
         </p:nvSpPr>
         <p:spPr>
           <a:xfrm>
-            <a:off x="457200" y="5806440"/>
+            <a:off x="457200" y="5715000"/>
             <a:ext cx="7315200" cy="457200"/>
           </a:xfrm>
           <a:prstGeom prst="rect">
@@ -4070,7 +3978,7 @@
               </a:defRPr>
             </a:pPr>
             <a:r>
-              <a:t>Fanart by the presentation creator</a:t>
+              <a:t>このパワーポイントの製作者が描いたファンアートです</a:t>
             </a:r>
           </a:p>
         </p:txBody>
@@ -4100,13 +4008,13 @@
             <a:pPr algn="l">
               <a:defRPr sz="1600" b="0">
                 <a:solidFill>
-                  <a:srgbClr val="B4AFAA"/>
-                </a:solidFill>
-                <a:latin typeface="Arial"/>
-              </a:defRPr>
-            </a:pPr>
-            <a:r>
-              <a:t>Thank you for watching.</a:t>
+                  <a:srgbClr val="BEB9B4"/>
+                </a:solidFill>
+                <a:latin typeface="Arial"/>
+              </a:defRPr>
+            </a:pPr>
+            <a:r>
+              <a:t>ご覧頂きありがとうございました。</a:t>
             </a:r>
           </a:p>
         </p:txBody>
@@ -4119,7 +4027,7 @@
         </p:nvSpPr>
         <p:spPr>
           <a:xfrm>
-            <a:off x="6400800" y="5806440"/>
+            <a:off x="6400800" y="6172200"/>
             <a:ext cx="5303520" cy="457200"/>
           </a:xfrm>
           <a:prstGeom prst="rect">
@@ -4134,7 +4042,7 @@
           <a:lstStyle/>
           <a:p>
             <a:pPr algn="r">
-              <a:defRPr sz="1400" b="0">
+              <a:defRPr sz="1300" b="0">
                 <a:solidFill>
                   <a:srgbClr val="A08228"/>
                 </a:solidFill>
@@ -4142,43 +4050,7 @@
               </a:defRPr>
             </a:pPr>
             <a:r>
-              <a:t>CRIMSON  -  Character Presentation</a:t>
-            </a:r>
-          </a:p>
-        </p:txBody>
-      </p:sp>
-      <p:sp>
-        <p:nvSpPr>
-          <p:cNvPr id="8" name="TextBox 7"/>
-          <p:cNvSpPr txBox="1"/>
-          <p:nvPr/>
-        </p:nvSpPr>
-        <p:spPr>
-          <a:xfrm>
-            <a:off x="6400800" y="6172200"/>
-            <a:ext cx="5303520" cy="457200"/>
-          </a:xfrm>
-          <a:prstGeom prst="rect">
-            <a:avLst/>
-          </a:prstGeom>
-          <a:noFill/>
-        </p:spPr>
-        <p:txBody>
-          <a:bodyPr wrap="square">
-            <a:spAutoFit/>
-          </a:bodyPr>
-          <a:lstStyle/>
-          <a:p>
-            <a:pPr algn="r">
-              <a:defRPr sz="1200" b="0">
-                <a:solidFill>
-                  <a:srgbClr val="B4AFAA"/>
-                </a:solidFill>
-                <a:latin typeface="Arial"/>
-              </a:defRPr>
-            </a:pPr>
-            <a:r>
-              <a:t>Helluva Boss  |  Vivziepop</a:t>
+              <a:t>CRIMSON  —  Helluva Boss  |  Vivziepop</a:t>
             </a:r>
           </a:p>
         </p:txBody>
@@ -4197,7 +4069,7 @@
     <p:bg>
       <p:bgPr>
         <a:solidFill>
-          <a:srgbClr val="0F0A0A"/>
+          <a:srgbClr val="120C0C"/>
         </a:solidFill>
         <a:effectLst/>
       </p:bgPr>
@@ -4389,7 +4261,7 @@
               </a:defRPr>
             </a:pPr>
             <a:r>
-              <a:t>Name :  Crimson (Knolastname)</a:t>
+              <a:t>名前 :  Crimson（クリムゾン）</a:t>
             </a:r>
           </a:p>
           <a:p>
@@ -4405,7 +4277,7 @@
               </a:defRPr>
             </a:pPr>
             <a:r>
-              <a:t>Species :  Imp Demon</a:t>
+              <a:t>種族 :  インプ</a:t>
             </a:r>
           </a:p>
           <a:p>
@@ -4421,7 +4293,7 @@
               </a:defRPr>
             </a:pPr>
             <a:r>
-              <a:t>Ring :  Greed</a:t>
+              <a:t>リング :  強欲の環（Greed Ring）</a:t>
             </a:r>
           </a:p>
           <a:p>
@@ -4437,7 +4309,7 @@
               </a:defRPr>
             </a:pPr>
             <a:r>
-              <a:t>Role :  Mafia Boss / Crime Lord</a:t>
+              <a:t>役割 :  マフィアボス / 犯罪王</a:t>
             </a:r>
           </a:p>
           <a:p>
@@ -4453,7 +4325,7 @@
               </a:defRPr>
             </a:pPr>
             <a:r>
-              <a:t>Family :  Moxxie (Son)</a:t>
+              <a:t>家族 :  モクシー（息子）</a:t>
             </a:r>
           </a:p>
           <a:p>
@@ -4469,7 +4341,7 @@
               </a:defRPr>
             </a:pPr>
             <a:r>
-              <a:t>VA :  Richard Steven Horvitz</a:t>
+              <a:t>声優 :  Richard Steven Horvitz</a:t>
             </a:r>
           </a:p>
           <a:p>
@@ -4485,7 +4357,7 @@
               </a:defRPr>
             </a:pPr>
             <a:r>
-              <a:t>Debut :  "Exes and Oohs" (S2E6)</a:t>
+              <a:t>初登場 :  "Exes and Oohs"（S2E6）</a:t>
             </a:r>
           </a:p>
         </p:txBody>
@@ -4515,13 +4387,13 @@
             <a:pPr algn="l">
               <a:defRPr sz="1600" b="0">
                 <a:solidFill>
-                  <a:srgbClr val="B4AFAA"/>
-                </a:solidFill>
-                <a:latin typeface="Arial"/>
-              </a:defRPr>
-            </a:pPr>
-            <a:r>
-              <a:t>Greed Ring of Hellを支配するマフィアの頂点に立つインプ。</a:t>
+                  <a:srgbClr val="BEB9B4"/>
+                </a:solidFill>
+                <a:latin typeface="Arial"/>
+              </a:defRPr>
+            </a:pPr>
+            <a:r>
+              <a:t>強欲の環を支配するマフィアの頂点に立つインプ。</a:t>
             </a:r>
           </a:p>
         </p:txBody>
@@ -4540,7 +4412,7 @@
     <p:bg>
       <p:bgPr>
         <a:solidFill>
-          <a:srgbClr val="0A0A12"/>
+          <a:srgbClr val="120F14"/>
         </a:solidFill>
         <a:effectLst/>
       </p:bgPr>
@@ -4567,7 +4439,7 @@
             <a:avLst/>
           </a:prstGeom>
           <a:solidFill>
-            <a:srgbClr val="141628"/>
+            <a:srgbClr val="640F0F"/>
           </a:solidFill>
           <a:ln>
             <a:noFill/>
@@ -4626,7 +4498,7 @@
               </a:defRPr>
             </a:pPr>
             <a:r>
-              <a:t>APPEARANCE</a:t>
+              <a:t>外見</a:t>
             </a:r>
           </a:p>
         </p:txBody>
@@ -4698,40 +4570,16 @@
           </a:prstGeom>
         </p:spPr>
       </p:pic>
-      <p:pic>
-        <p:nvPicPr>
-          <p:cNvPr id="6" name="Picture 5" descr="crimson-2.PNG"/>
-          <p:cNvPicPr>
-            <a:picLocks noChangeAspect="1"/>
-          </p:cNvPicPr>
-          <p:nvPr/>
-        </p:nvPicPr>
-        <p:blipFill>
-          <a:blip r:embed="rId3"/>
-          <a:stretch>
-            <a:fillRect/>
-          </a:stretch>
-        </p:blipFill>
-        <p:spPr>
-          <a:xfrm>
-            <a:off x="4114800" y="1828800"/>
-            <a:ext cx="4424516" cy="4114800"/>
-          </a:xfrm>
-          <a:prstGeom prst="rect">
-            <a:avLst/>
-          </a:prstGeom>
-        </p:spPr>
-      </p:pic>
-      <p:sp>
-        <p:nvSpPr>
-          <p:cNvPr id="7" name="TextBox 6"/>
+      <p:sp>
+        <p:nvSpPr>
+          <p:cNvPr id="6" name="TextBox 5"/>
           <p:cNvSpPr txBox="1"/>
           <p:nvPr/>
         </p:nvSpPr>
         <p:spPr>
           <a:xfrm>
-            <a:off x="7315200" y="1645920"/>
-            <a:ext cx="4389120" cy="4572000"/>
+            <a:off x="5943600" y="1645920"/>
+            <a:ext cx="5760720" cy="4572000"/>
           </a:xfrm>
           <a:prstGeom prst="rect">
             <a:avLst/>
@@ -4746,9 +4594,9 @@
           <a:p>
             <a:pPr algn="l">
               <a:spcAft>
-                <a:spcPts val="1200"/>
+                <a:spcPts val="1260"/>
               </a:spcAft>
-              <a:defRPr sz="2000" b="0">
+              <a:defRPr sz="2100" b="0">
                 <a:solidFill>
                   <a:srgbClr val="F5F0EB"/>
                 </a:solidFill>
@@ -4762,9 +4610,9 @@
           <a:p>
             <a:pPr algn="l">
               <a:spcAft>
-                <a:spcPts val="1200"/>
+                <a:spcPts val="1260"/>
               </a:spcAft>
-              <a:defRPr sz="2000" b="0">
+              <a:defRPr sz="2100" b="0">
                 <a:solidFill>
                   <a:srgbClr val="F5F0EB"/>
                 </a:solidFill>
@@ -4778,9 +4626,9 @@
           <a:p>
             <a:pPr algn="l">
               <a:spcAft>
-                <a:spcPts val="1200"/>
+                <a:spcPts val="1260"/>
               </a:spcAft>
-              <a:defRPr sz="2000" b="0">
+              <a:defRPr sz="2100" b="0">
                 <a:solidFill>
                   <a:srgbClr val="F5F0EB"/>
                 </a:solidFill>
@@ -4788,15 +4636,15 @@
               </a:defRPr>
             </a:pPr>
             <a:r>
-              <a:t>黄色い強膜、金の牙（右）</a:t>
+              <a:t>黄色い強膜に金の牙（右側）</a:t>
             </a:r>
           </a:p>
           <a:p>
             <a:pPr algn="l">
               <a:spcAft>
-                <a:spcPts val="1200"/>
+                <a:spcPts val="1260"/>
               </a:spcAft>
-              <a:defRPr sz="2000" b="0">
+              <a:defRPr sz="2100" b="0">
                 <a:solidFill>
                   <a:srgbClr val="F5F0EB"/>
                 </a:solidFill>
@@ -4810,9 +4658,9 @@
           <a:p>
             <a:pPr algn="l">
               <a:spcAft>
-                <a:spcPts val="1200"/>
+                <a:spcPts val="1260"/>
               </a:spcAft>
-              <a:defRPr sz="2000" b="0">
+              <a:defRPr sz="2100" b="0">
                 <a:solidFill>
                   <a:srgbClr val="F5F0EB"/>
                 </a:solidFill>
@@ -4820,15 +4668,15 @@
               </a:defRPr>
             </a:pPr>
             <a:r>
-              <a:t>黒いフェドーラ帽（赤白バンド）</a:t>
+              <a:t>黒いフェドーラ帽（赤白バンド付き）</a:t>
             </a:r>
           </a:p>
           <a:p>
             <a:pPr algn="l">
               <a:spcAft>
-                <a:spcPts val="1200"/>
+                <a:spcPts val="1260"/>
               </a:spcAft>
-              <a:defRPr sz="2000" b="0">
+              <a:defRPr sz="2100" b="0">
                 <a:solidFill>
                   <a:srgbClr val="F5F0EB"/>
                 </a:solidFill>
@@ -4836,15 +4684,15 @@
               </a:defRPr>
             </a:pPr>
             <a:r>
-              <a:t>ネイビーブルーのコート＋赤いシャツ</a:t>
+              <a:t>ネイビーブルーのコートに赤いシャツ</a:t>
             </a:r>
           </a:p>
           <a:p>
             <a:pPr algn="l">
               <a:spcAft>
-                <a:spcPts val="1200"/>
+                <a:spcPts val="1260"/>
               </a:spcAft>
-              <a:defRPr sz="2000" b="0">
+              <a:defRPr sz="2100" b="0">
                 <a:solidFill>
                   <a:srgbClr val="F5F0EB"/>
                 </a:solidFill>
@@ -4852,7 +4700,7 @@
               </a:defRPr>
             </a:pPr>
             <a:r>
-              <a:t>趾行性ではなく蹠行性の脚</a:t>
+              <a:t>蹠行性（かかとを地面につける）の脚</a:t>
             </a:r>
           </a:p>
         </p:txBody>
@@ -4871,7 +4719,7 @@
     <p:bg>
       <p:bgPr>
         <a:solidFill>
-          <a:srgbClr val="050303"/>
+          <a:srgbClr val="0A0606"/>
         </a:solidFill>
         <a:effectLst/>
       </p:bgPr>
@@ -4885,7 +4733,7 @@
       <p:grpSpPr/>
       <p:pic>
         <p:nvPicPr>
-          <p:cNvPr id="2" name="Picture 1" descr="crimson-7.JPG"/>
+          <p:cNvPr id="2" name="Picture 1" descr="_dark_crimson7.jpg"/>
           <p:cNvPicPr>
             <a:picLocks noChangeAspect="1"/>
           </p:cNvPicPr>
@@ -4909,22 +4757,56 @@
       </p:pic>
       <p:sp>
         <p:nvSpPr>
-          <p:cNvPr id="3" name="Rectangle 2"/>
+          <p:cNvPr id="3" name="TextBox 2"/>
+          <p:cNvSpPr txBox="1"/>
+          <p:nvPr/>
+        </p:nvSpPr>
+        <p:spPr>
+          <a:xfrm>
+            <a:off x="457200" y="365760"/>
+            <a:ext cx="10972800" cy="914400"/>
+          </a:xfrm>
+          <a:prstGeom prst="rect">
+            <a:avLst/>
+          </a:prstGeom>
+          <a:noFill/>
+        </p:spPr>
+        <p:txBody>
+          <a:bodyPr wrap="square">
+            <a:spAutoFit/>
+          </a:bodyPr>
+          <a:lstStyle/>
+          <a:p>
+            <a:pPr algn="ctr">
+              <a:defRPr sz="4800" b="1">
+                <a:solidFill>
+                  <a:srgbClr val="B41E1E"/>
+                </a:solidFill>
+                <a:latin typeface="Arial"/>
+              </a:defRPr>
+            </a:pPr>
+            <a:r>
+              <a:t>性格</a:t>
+            </a:r>
+          </a:p>
+        </p:txBody>
+      </p:sp>
+      <p:sp>
+        <p:nvSpPr>
+          <p:cNvPr id="4" name="Rectangle 3"/>
           <p:cNvSpPr/>
           <p:nvPr/>
         </p:nvSpPr>
         <p:spPr>
           <a:xfrm>
-            <a:off x="0" y="0"/>
-            <a:ext cx="12191695" cy="6858000"/>
+            <a:off x="457200" y="1188720"/>
+            <a:ext cx="4572000" cy="36576"/>
           </a:xfrm>
           <a:prstGeom prst="rect">
             <a:avLst/>
           </a:prstGeom>
           <a:solidFill>
-            <a:srgbClr val="000000">
-              <a:alpha val="55000"/>
-            </a:srgbClr>
+            <a:srgbClr val="D4AF37"/>
           </a:solidFill>
           <a:ln>
             <a:noFill/>
@@ -4954,14 +4836,14 @@
       </p:sp>
       <p:sp>
         <p:nvSpPr>
-          <p:cNvPr id="4" name="TextBox 3"/>
+          <p:cNvPr id="5" name="TextBox 4"/>
           <p:cNvSpPr txBox="1"/>
           <p:nvPr/>
         </p:nvSpPr>
         <p:spPr>
           <a:xfrm>
-            <a:off x="457200" y="365760"/>
-            <a:ext cx="10972800" cy="914400"/>
+            <a:off x="731520" y="1645920"/>
+            <a:ext cx="6858000" cy="4572000"/>
           </a:xfrm>
           <a:prstGeom prst="rect">
             <a:avLst/>
@@ -4974,36 +4856,145 @@
           </a:bodyPr>
           <a:lstStyle/>
           <a:p>
-            <a:pPr algn="ctr">
-              <a:defRPr sz="4800" b="1">
-                <a:solidFill>
-                  <a:srgbClr val="A51919"/>
-                </a:solidFill>
-                <a:latin typeface="Arial"/>
-              </a:defRPr>
-            </a:pPr>
-            <a:r>
-              <a:t>PERSONALITY</a:t>
-            </a:r>
-          </a:p>
-        </p:txBody>
-      </p:sp>
-      <p:sp>
-        <p:nvSpPr>
-          <p:cNvPr id="5" name="Rectangle 4"/>
+            <a:pPr algn="l">
+              <a:spcAft>
+                <a:spcPts val="1200"/>
+              </a:spcAft>
+              <a:defRPr sz="2400" b="1">
+                <a:solidFill>
+                  <a:srgbClr val="F5F0EB"/>
+                </a:solidFill>
+                <a:latin typeface="Arial"/>
+              </a:defRPr>
+            </a:pPr>
+            <a:r>
+              <a:t>◆ 残忍かつ冷酷なマフィアのボス</a:t>
+            </a:r>
+          </a:p>
+          <a:p>
+            <a:pPr algn="l">
+              <a:spcAft>
+                <a:spcPts val="1200"/>
+              </a:spcAft>
+              <a:defRPr sz="2400" b="1">
+                <a:solidFill>
+                  <a:srgbClr val="F5F0EB"/>
+                </a:solidFill>
+                <a:latin typeface="Arial"/>
+              </a:defRPr>
+            </a:pPr>
+            <a:r>
+              <a:t>◆ 絶対的な恐怖で組織を支配する</a:t>
+            </a:r>
+          </a:p>
+          <a:p>
+            <a:pPr algn="l">
+              <a:spcAft>
+                <a:spcPts val="1200"/>
+              </a:spcAft>
+              <a:defRPr sz="2400" b="1">
+                <a:solidFill>
+                  <a:srgbClr val="F5F0EB"/>
+                </a:solidFill>
+                <a:latin typeface="Arial"/>
+              </a:defRPr>
+            </a:pPr>
+            <a:r>
+              <a:t>◆ しかし必要な時には魅力的で温厚な顔も見せる</a:t>
+            </a:r>
+          </a:p>
+          <a:p>
+            <a:pPr algn="l">
+              <a:spcAft>
+                <a:spcPts val="1200"/>
+              </a:spcAft>
+              <a:defRPr sz="2400" b="1">
+                <a:solidFill>
+                  <a:srgbClr val="F5F0EB"/>
+                </a:solidFill>
+                <a:latin typeface="Arial"/>
+              </a:defRPr>
+            </a:pPr>
+            <a:r>
+              <a:t>◆ サメ悪魔のギャング軍団を統率</a:t>
+            </a:r>
+          </a:p>
+          <a:p>
+            <a:pPr algn="l">
+              <a:spcAft>
+                <a:spcPts val="1200"/>
+              </a:spcAft>
+              <a:defRPr sz="2400" b="1">
+                <a:solidFill>
+                  <a:srgbClr val="F5F0EB"/>
+                </a:solidFill>
+                <a:latin typeface="Arial"/>
+              </a:defRPr>
+            </a:pPr>
+            <a:r>
+              <a:t>◆ 脅迫・暴力・心理操作を駆使する策略家</a:t>
+            </a:r>
+          </a:p>
+          <a:p>
+            <a:pPr algn="l">
+              <a:spcAft>
+                <a:spcPts val="1200"/>
+              </a:spcAft>
+              <a:defRPr sz="2400" b="1">
+                <a:solidFill>
+                  <a:srgbClr val="F5F0EB"/>
+                </a:solidFill>
+                <a:latin typeface="Arial"/>
+              </a:defRPr>
+            </a:pPr>
+            <a:r>
+              <a:t>◆ 冷酷と魅力のギャップに満ちた男</a:t>
+            </a:r>
+          </a:p>
+        </p:txBody>
+      </p:sp>
+    </p:spTree>
+  </p:cSld>
+  <p:clrMapOvr>
+    <a:masterClrMapping/>
+  </p:clrMapOvr>
+</p:sld>
+</file>
+
+<file path=ppt/slides/slide5.xml><?xml version="1.0" encoding="utf-8"?>
+<p:sld xmlns:a="http://schemas.openxmlformats.org/drawingml/2006/main" xmlns:p="http://schemas.openxmlformats.org/presentationml/2006/main" xmlns:r="http://schemas.openxmlformats.org/officeDocument/2006/relationships">
+  <p:cSld>
+    <p:bg>
+      <p:bgPr>
+        <a:solidFill>
+          <a:srgbClr val="120C0C"/>
+        </a:solidFill>
+        <a:effectLst/>
+      </p:bgPr>
+    </p:bg>
+    <p:spTree>
+      <p:nvGrpSpPr>
+        <p:cNvPr id="1" name=""/>
+        <p:cNvGrpSpPr/>
+        <p:nvPr/>
+      </p:nvGrpSpPr>
+      <p:grpSpPr/>
+      <p:sp>
+        <p:nvSpPr>
+          <p:cNvPr id="2" name="Rectangle 1"/>
           <p:cNvSpPr/>
           <p:nvPr/>
         </p:nvSpPr>
         <p:spPr>
           <a:xfrm>
-            <a:off x="457200" y="1188720"/>
-            <a:ext cx="4572000" cy="36576"/>
+            <a:off x="0" y="0"/>
+            <a:ext cx="5943600" cy="6858000"/>
           </a:xfrm>
           <a:prstGeom prst="rect">
             <a:avLst/>
           </a:prstGeom>
           <a:solidFill>
-            <a:srgbClr val="D4AF37"/>
+            <a:srgbClr val="120C0C"/>
           </a:solidFill>
           <a:ln>
             <a:noFill/>
@@ -5033,182 +5024,13 @@
       </p:sp>
       <p:sp>
         <p:nvSpPr>
-          <p:cNvPr id="6" name="TextBox 5"/>
-          <p:cNvSpPr txBox="1"/>
-          <p:nvPr/>
-        </p:nvSpPr>
-        <p:spPr>
-          <a:xfrm>
-            <a:off x="731520" y="1645920"/>
-            <a:ext cx="5943600" cy="4572000"/>
-          </a:xfrm>
-          <a:prstGeom prst="rect">
-            <a:avLst/>
-          </a:prstGeom>
-          <a:noFill/>
-        </p:spPr>
-        <p:txBody>
-          <a:bodyPr wrap="square">
-            <a:spAutoFit/>
-          </a:bodyPr>
-          <a:lstStyle/>
-          <a:p>
-            <a:pPr algn="l">
-              <a:spcAft>
-                <a:spcPts val="1100"/>
-              </a:spcAft>
-              <a:defRPr sz="2200" b="0">
-                <a:solidFill>
-                  <a:srgbClr val="F5F0EB"/>
-                </a:solidFill>
-                <a:latin typeface="Arial"/>
-              </a:defRPr>
-            </a:pPr>
-            <a:r>
-              <a:t>残忍かつ冷酷なマフィアのボス</a:t>
-            </a:r>
-          </a:p>
-          <a:p>
-            <a:pPr algn="l">
-              <a:spcAft>
-                <a:spcPts val="1100"/>
-              </a:spcAft>
-              <a:defRPr sz="2200" b="0">
-                <a:solidFill>
-                  <a:srgbClr val="F5F0EB"/>
-                </a:solidFill>
-                <a:latin typeface="Arial"/>
-              </a:defRPr>
-            </a:pPr>
-            <a:r>
-              <a:t>絶対的な恐怖で組織を支配</a:t>
-            </a:r>
-          </a:p>
-          <a:p>
-            <a:pPr algn="l">
-              <a:spcAft>
-                <a:spcPts val="1100"/>
-              </a:spcAft>
-              <a:defRPr sz="2200" b="0">
-                <a:solidFill>
-                  <a:srgbClr val="F5F0EB"/>
-                </a:solidFill>
-                <a:latin typeface="Arial"/>
-              </a:defRPr>
-            </a:pPr>
-            <a:r>
-              <a:t>しかし、必要な時には魅力的で温厚な顔も見せる</a:t>
-            </a:r>
-          </a:p>
-          <a:p>
-            <a:pPr algn="l">
-              <a:spcAft>
-                <a:spcPts val="1100"/>
-              </a:spcAft>
-              <a:defRPr sz="2200" b="0">
-                <a:solidFill>
-                  <a:srgbClr val="F5F0EB"/>
-                </a:solidFill>
-                <a:latin typeface="Arial"/>
-              </a:defRPr>
-            </a:pPr>
-            <a:r>
-              <a:t>サメ悪魔のギャング軍団を統率</a:t>
-            </a:r>
-          </a:p>
-          <a:p>
-            <a:pPr algn="l">
-              <a:spcAft>
-                <a:spcPts val="1100"/>
-              </a:spcAft>
-              <a:defRPr sz="2200" b="0">
-                <a:solidFill>
-                  <a:srgbClr val="F5F0EB"/>
-                </a:solidFill>
-                <a:latin typeface="Arial"/>
-              </a:defRPr>
-            </a:pPr>
-            <a:r>
-              <a:t>脅迫・暴力・心理操作を駆使</a:t>
-            </a:r>
-          </a:p>
-          <a:p>
-            <a:pPr algn="l">
-              <a:spcAft>
-                <a:spcPts val="1100"/>
-              </a:spcAft>
-              <a:defRPr sz="2200" b="0">
-                <a:solidFill>
-                  <a:srgbClr val="F5F0EB"/>
-                </a:solidFill>
-                <a:latin typeface="Arial"/>
-              </a:defRPr>
-            </a:pPr>
-            <a:r>
-              <a:t>金の牙のような凶悪なギャップに満ちている</a:t>
-            </a:r>
-          </a:p>
-        </p:txBody>
-      </p:sp>
-    </p:spTree>
-  </p:cSld>
-  <p:clrMapOvr>
-    <a:masterClrMapping/>
-  </p:clrMapOvr>
-</p:sld>
-</file>
-
-<file path=ppt/slides/slide5.xml><?xml version="1.0" encoding="utf-8"?>
-<p:sld xmlns:a="http://schemas.openxmlformats.org/drawingml/2006/main" xmlns:p="http://schemas.openxmlformats.org/presentationml/2006/main" xmlns:r="http://schemas.openxmlformats.org/officeDocument/2006/relationships">
-  <p:cSld>
-    <p:bg>
-      <p:bgPr>
-        <a:solidFill>
-          <a:srgbClr val="080C08"/>
-        </a:solidFill>
-        <a:effectLst/>
-      </p:bgPr>
-    </p:bg>
-    <p:spTree>
-      <p:nvGrpSpPr>
-        <p:cNvPr id="1" name=""/>
-        <p:cNvGrpSpPr/>
-        <p:nvPr/>
-      </p:nvGrpSpPr>
-      <p:grpSpPr/>
-      <p:pic>
-        <p:nvPicPr>
-          <p:cNvPr id="2" name="Picture 1" descr="crimson-6.JPG"/>
-          <p:cNvPicPr>
-            <a:picLocks noChangeAspect="1"/>
-          </p:cNvPicPr>
-          <p:nvPr/>
-        </p:nvPicPr>
-        <p:blipFill>
-          <a:blip r:embed="rId2"/>
-          <a:stretch>
-            <a:fillRect/>
-          </a:stretch>
-        </p:blipFill>
-        <p:spPr>
-          <a:xfrm>
-            <a:off x="5943600" y="457200"/>
-            <a:ext cx="6990418" cy="5943600"/>
-          </a:xfrm>
-          <a:prstGeom prst="rect">
-            <a:avLst/>
-          </a:prstGeom>
-        </p:spPr>
-      </p:pic>
-      <p:sp>
-        <p:nvSpPr>
           <p:cNvPr id="3" name="Rectangle 2"/>
           <p:cNvSpPr/>
           <p:nvPr/>
         </p:nvSpPr>
         <p:spPr>
           <a:xfrm>
-            <a:off x="5486400" y="0"/>
+            <a:off x="5852160" y="0"/>
             <a:ext cx="54864" cy="6858000"/>
           </a:xfrm>
           <a:prstGeom prst="rect">
@@ -5243,24 +5065,82 @@
           </a:p>
         </p:txBody>
       </p:sp>
-      <p:sp>
-        <p:nvSpPr>
-          <p:cNvPr id="4" name="Rectangle 3"/>
+      <p:pic>
+        <p:nvPicPr>
+          <p:cNvPr id="4" name="Picture 3" descr="crimson-6.JPG"/>
+          <p:cNvPicPr>
+            <a:picLocks noChangeAspect="1"/>
+          </p:cNvPicPr>
+          <p:nvPr/>
+        </p:nvPicPr>
+        <p:blipFill>
+          <a:blip r:embed="rId2"/>
+          <a:stretch>
+            <a:fillRect/>
+          </a:stretch>
+        </p:blipFill>
+        <p:spPr>
+          <a:xfrm>
+            <a:off x="6217920" y="274320"/>
+            <a:ext cx="7420598" cy="6309360"/>
+          </a:xfrm>
+          <a:prstGeom prst="rect">
+            <a:avLst/>
+          </a:prstGeom>
+        </p:spPr>
+      </p:pic>
+      <p:sp>
+        <p:nvSpPr>
+          <p:cNvPr id="5" name="TextBox 4"/>
+          <p:cNvSpPr txBox="1"/>
+          <p:nvPr/>
+        </p:nvSpPr>
+        <p:spPr>
+          <a:xfrm>
+            <a:off x="457200" y="365760"/>
+            <a:ext cx="5029200" cy="914400"/>
+          </a:xfrm>
+          <a:prstGeom prst="rect">
+            <a:avLst/>
+          </a:prstGeom>
+          <a:noFill/>
+        </p:spPr>
+        <p:txBody>
+          <a:bodyPr wrap="square">
+            <a:spAutoFit/>
+          </a:bodyPr>
+          <a:lstStyle/>
+          <a:p>
+            <a:pPr algn="ctr">
+              <a:defRPr sz="5200" b="1">
+                <a:solidFill>
+                  <a:srgbClr val="D4AF37"/>
+                </a:solidFill>
+                <a:latin typeface="Arial"/>
+              </a:defRPr>
+            </a:pPr>
+            <a:r>
+              <a:t>THE DON</a:t>
+            </a:r>
+          </a:p>
+        </p:txBody>
+      </p:sp>
+      <p:sp>
+        <p:nvSpPr>
+          <p:cNvPr id="6" name="Rectangle 5"/>
           <p:cNvSpPr/>
           <p:nvPr/>
         </p:nvSpPr>
         <p:spPr>
           <a:xfrm>
-            <a:off x="0" y="0"/>
-            <a:ext cx="5669280" cy="6858000"/>
+            <a:off x="457200" y="1188720"/>
+            <a:ext cx="4572000" cy="36576"/>
           </a:xfrm>
           <a:prstGeom prst="rect">
             <a:avLst/>
           </a:prstGeom>
           <a:solidFill>
-            <a:srgbClr val="0C0808">
-              <a:alpha val="85000"/>
-            </a:srgbClr>
+            <a:srgbClr val="D4AF37"/>
           </a:solidFill>
           <a:ln>
             <a:noFill/>
@@ -5290,14 +5170,14 @@
       </p:sp>
       <p:sp>
         <p:nvSpPr>
-          <p:cNvPr id="5" name="TextBox 4"/>
+          <p:cNvPr id="7" name="TextBox 6"/>
           <p:cNvSpPr txBox="1"/>
           <p:nvPr/>
         </p:nvSpPr>
         <p:spPr>
           <a:xfrm>
-            <a:off x="457200" y="365760"/>
-            <a:ext cx="5029200" cy="914400"/>
+            <a:off x="731520" y="1645920"/>
+            <a:ext cx="4754880" cy="5029200"/>
           </a:xfrm>
           <a:prstGeom prst="rect">
             <a:avLst/>
@@ -5310,36 +5190,216 @@
           </a:bodyPr>
           <a:lstStyle/>
           <a:p>
-            <a:pPr algn="ctr">
-              <a:defRPr sz="5200" b="1">
-                <a:solidFill>
-                  <a:srgbClr val="D4AF37"/>
-                </a:solidFill>
-                <a:latin typeface="Arial"/>
-              </a:defRPr>
-            </a:pPr>
-            <a:r>
-              <a:t>THE DON</a:t>
-            </a:r>
-          </a:p>
-        </p:txBody>
-      </p:sp>
-      <p:sp>
-        <p:nvSpPr>
-          <p:cNvPr id="6" name="Rectangle 5"/>
+            <a:pPr algn="l">
+              <a:spcAft>
+                <a:spcPts val="299"/>
+              </a:spcAft>
+              <a:defRPr sz="2000" b="0">
+                <a:solidFill>
+                  <a:srgbClr val="F5F0EB"/>
+                </a:solidFill>
+                <a:latin typeface="Arial"/>
+              </a:defRPr>
+            </a:pPr>
+            <a:r>
+              <a:t>強欲の環を牛耳る犯罪帝国の長。</a:t>
+            </a:r>
+          </a:p>
+          <a:p>
+            <a:pPr algn="l">
+              <a:spcAft>
+                <a:spcPts val="299"/>
+              </a:spcAft>
+              <a:defRPr sz="2000" b="0">
+                <a:solidFill>
+                  <a:srgbClr val="F5F0EB"/>
+                </a:solidFill>
+                <a:latin typeface="Arial"/>
+              </a:defRPr>
+            </a:pPr>
+          </a:p>
+          <a:p>
+            <a:pPr algn="l">
+              <a:spcAft>
+                <a:spcPts val="299"/>
+              </a:spcAft>
+              <a:defRPr sz="2000" b="0">
+                <a:solidFill>
+                  <a:srgbClr val="F5F0EB"/>
+                </a:solidFill>
+                <a:latin typeface="Arial"/>
+              </a:defRPr>
+            </a:pPr>
+            <a:r>
+              <a:t>サメ悪魔の大軍を従え、</a:t>
+            </a:r>
+          </a:p>
+          <a:p>
+            <a:pPr algn="l">
+              <a:spcAft>
+                <a:spcPts val="299"/>
+              </a:spcAft>
+              <a:defRPr sz="2000" b="0">
+                <a:solidFill>
+                  <a:srgbClr val="F5F0EB"/>
+                </a:solidFill>
+                <a:latin typeface="Arial"/>
+              </a:defRPr>
+            </a:pPr>
+            <a:r>
+              <a:t>恐喝と暴力で勢力を拡大する。</a:t>
+            </a:r>
+          </a:p>
+          <a:p>
+            <a:pPr algn="l">
+              <a:spcAft>
+                <a:spcPts val="299"/>
+              </a:spcAft>
+              <a:defRPr sz="2000" b="0">
+                <a:solidFill>
+                  <a:srgbClr val="F5F0EB"/>
+                </a:solidFill>
+                <a:latin typeface="Arial"/>
+              </a:defRPr>
+            </a:pPr>
+          </a:p>
+          <a:p>
+            <a:pPr algn="l">
+              <a:spcAft>
+                <a:spcPts val="299"/>
+              </a:spcAft>
+              <a:defRPr sz="2000" b="0">
+                <a:solidFill>
+                  <a:srgbClr val="F5F0EB"/>
+                </a:solidFill>
+                <a:latin typeface="Arial"/>
+              </a:defRPr>
+            </a:pPr>
+            <a:r>
+              <a:t>財政危機に際しては</a:t>
+            </a:r>
+          </a:p>
+          <a:p>
+            <a:pPr algn="l">
+              <a:spcAft>
+                <a:spcPts val="299"/>
+              </a:spcAft>
+              <a:defRPr sz="2000" b="0">
+                <a:solidFill>
+                  <a:srgbClr val="F5F0EB"/>
+                </a:solidFill>
+                <a:latin typeface="Arial"/>
+              </a:defRPr>
+            </a:pPr>
+            <a:r>
+              <a:t>チャズとの政略結婚すら画策する野心家。</a:t>
+            </a:r>
+          </a:p>
+          <a:p>
+            <a:pPr algn="l">
+              <a:spcAft>
+                <a:spcPts val="299"/>
+              </a:spcAft>
+              <a:defRPr sz="2000" b="0">
+                <a:solidFill>
+                  <a:srgbClr val="F5F0EB"/>
+                </a:solidFill>
+                <a:latin typeface="Arial"/>
+              </a:defRPr>
+            </a:pPr>
+          </a:p>
+          <a:p>
+            <a:pPr algn="l">
+              <a:spcAft>
+                <a:spcPts val="299"/>
+              </a:spcAft>
+              <a:defRPr sz="2000" b="0">
+                <a:solidFill>
+                  <a:srgbClr val="F5F0EB"/>
+                </a:solidFill>
+                <a:latin typeface="Arial"/>
+              </a:defRPr>
+            </a:pPr>
+            <a:r>
+              <a:t>ストライカーを雇い、</a:t>
+            </a:r>
+          </a:p>
+          <a:p>
+            <a:pPr algn="l">
+              <a:spcAft>
+                <a:spcPts val="299"/>
+              </a:spcAft>
+              <a:defRPr sz="2000" b="0">
+                <a:solidFill>
+                  <a:srgbClr val="F5F0EB"/>
+                </a:solidFill>
+                <a:latin typeface="Arial"/>
+              </a:defRPr>
+            </a:pPr>
+            <a:r>
+              <a:t>フィズロリを人質にアスモデウス</a:t>
+            </a:r>
+          </a:p>
+          <a:p>
+            <a:pPr algn="l">
+              <a:spcAft>
+                <a:spcPts val="299"/>
+              </a:spcAft>
+              <a:defRPr sz="2000" b="0">
+                <a:solidFill>
+                  <a:srgbClr val="F5F0EB"/>
+                </a:solidFill>
+                <a:latin typeface="Arial"/>
+              </a:defRPr>
+            </a:pPr>
+            <a:r>
+              <a:t>すら脅迫する大胆さ。</a:t>
+            </a:r>
+          </a:p>
+        </p:txBody>
+      </p:sp>
+    </p:spTree>
+  </p:cSld>
+  <p:clrMapOvr>
+    <a:masterClrMapping/>
+  </p:clrMapOvr>
+</p:sld>
+</file>
+
+<file path=ppt/slides/slide6.xml><?xml version="1.0" encoding="utf-8"?>
+<p:sld xmlns:a="http://schemas.openxmlformats.org/drawingml/2006/main" xmlns:p="http://schemas.openxmlformats.org/presentationml/2006/main" xmlns:r="http://schemas.openxmlformats.org/officeDocument/2006/relationships">
+  <p:cSld>
+    <p:bg>
+      <p:bgPr>
+        <a:solidFill>
+          <a:srgbClr val="120C0C"/>
+        </a:solidFill>
+        <a:effectLst/>
+      </p:bgPr>
+    </p:bg>
+    <p:spTree>
+      <p:nvGrpSpPr>
+        <p:cNvPr id="1" name=""/>
+        <p:cNvGrpSpPr/>
+        <p:nvPr/>
+      </p:nvGrpSpPr>
+      <p:grpSpPr/>
+      <p:sp>
+        <p:nvSpPr>
+          <p:cNvPr id="2" name="Rectangle 1"/>
           <p:cNvSpPr/>
           <p:nvPr/>
         </p:nvSpPr>
         <p:spPr>
           <a:xfrm>
-            <a:off x="457200" y="1188720"/>
-            <a:ext cx="4114800" cy="36576"/>
+            <a:off x="0" y="0"/>
+            <a:ext cx="12191695" cy="1097280"/>
           </a:xfrm>
           <a:prstGeom prst="rect">
             <a:avLst/>
           </a:prstGeom>
           <a:solidFill>
-            <a:srgbClr val="A51919"/>
+            <a:srgbClr val="640F0F"/>
           </a:solidFill>
           <a:ln>
             <a:noFill/>
@@ -5369,14 +5429,14 @@
       </p:sp>
       <p:sp>
         <p:nvSpPr>
-          <p:cNvPr id="7" name="TextBox 6"/>
+          <p:cNvPr id="3" name="TextBox 2"/>
           <p:cNvSpPr txBox="1"/>
           <p:nvPr/>
         </p:nvSpPr>
         <p:spPr>
           <a:xfrm>
-            <a:off x="731520" y="1645920"/>
-            <a:ext cx="4572000" cy="5029200"/>
+            <a:off x="457200" y="137160"/>
+            <a:ext cx="10972800" cy="822960"/>
           </a:xfrm>
           <a:prstGeom prst="rect">
             <a:avLst/>
@@ -5389,11 +5449,8 @@
           </a:bodyPr>
           <a:lstStyle/>
           <a:p>
-            <a:pPr algn="l">
-              <a:spcAft>
-                <a:spcPts val="379"/>
-              </a:spcAft>
-              <a:defRPr sz="1900" b="0">
+            <a:pPr algn="ctr">
+              <a:defRPr sz="4200" b="1">
                 <a:solidFill>
                   <a:srgbClr val="F5F0EB"/>
                 </a:solidFill>
@@ -5401,204 +5458,27 @@
               </a:defRPr>
             </a:pPr>
             <a:r>
-              <a:t>Greed Ringを牛耳る犯罪帝国の長</a:t>
-            </a:r>
-          </a:p>
-          <a:p>
-            <a:pPr algn="l">
-              <a:spcAft>
-                <a:spcPts val="379"/>
-              </a:spcAft>
-              <a:defRPr sz="1900" b="0">
-                <a:solidFill>
-                  <a:srgbClr val="F5F0EB"/>
-                </a:solidFill>
-                <a:latin typeface="Arial"/>
-              </a:defRPr>
-            </a:pPr>
-          </a:p>
-          <a:p>
-            <a:pPr algn="l">
-              <a:spcAft>
-                <a:spcPts val="379"/>
-              </a:spcAft>
-              <a:defRPr sz="1900" b="0">
-                <a:solidFill>
-                  <a:srgbClr val="F5F0EB"/>
-                </a:solidFill>
-                <a:latin typeface="Arial"/>
-              </a:defRPr>
-            </a:pPr>
-            <a:r>
-              <a:t>サメ悪魔の大軍を従え、</a:t>
-            </a:r>
-          </a:p>
-          <a:p>
-            <a:pPr algn="l">
-              <a:spcAft>
-                <a:spcPts val="379"/>
-              </a:spcAft>
-              <a:defRPr sz="1900" b="0">
-                <a:solidFill>
-                  <a:srgbClr val="F5F0EB"/>
-                </a:solidFill>
-                <a:latin typeface="Arial"/>
-              </a:defRPr>
-            </a:pPr>
-            <a:r>
-              <a:t>恐喝と暴力で勢力を拡大。</a:t>
-            </a:r>
-          </a:p>
-          <a:p>
-            <a:pPr algn="l">
-              <a:spcAft>
-                <a:spcPts val="379"/>
-              </a:spcAft>
-              <a:defRPr sz="1900" b="0">
-                <a:solidFill>
-                  <a:srgbClr val="F5F0EB"/>
-                </a:solidFill>
-                <a:latin typeface="Arial"/>
-              </a:defRPr>
-            </a:pPr>
-          </a:p>
-          <a:p>
-            <a:pPr algn="l">
-              <a:spcAft>
-                <a:spcPts val="379"/>
-              </a:spcAft>
-              <a:defRPr sz="1900" b="0">
-                <a:solidFill>
-                  <a:srgbClr val="F5F0EB"/>
-                </a:solidFill>
-                <a:latin typeface="Arial"/>
-              </a:defRPr>
-            </a:pPr>
-            <a:r>
-              <a:t>財政危機に際してはチャズとの</a:t>
-            </a:r>
-          </a:p>
-          <a:p>
-            <a:pPr algn="l">
-              <a:spcAft>
-                <a:spcPts val="379"/>
-              </a:spcAft>
-              <a:defRPr sz="1900" b="0">
-                <a:solidFill>
-                  <a:srgbClr val="F5F0EB"/>
-                </a:solidFill>
-                <a:latin typeface="Arial"/>
-              </a:defRPr>
-            </a:pPr>
-            <a:r>
-              <a:t>政略結婚すら画策する野心家。</a:t>
-            </a:r>
-          </a:p>
-          <a:p>
-            <a:pPr algn="l">
-              <a:spcAft>
-                <a:spcPts val="379"/>
-              </a:spcAft>
-              <a:defRPr sz="1900" b="0">
-                <a:solidFill>
-                  <a:srgbClr val="F5F0EB"/>
-                </a:solidFill>
-                <a:latin typeface="Arial"/>
-              </a:defRPr>
-            </a:pPr>
-          </a:p>
-          <a:p>
-            <a:pPr algn="l">
-              <a:spcAft>
-                <a:spcPts val="379"/>
-              </a:spcAft>
-              <a:defRPr sz="1900" b="0">
-                <a:solidFill>
-                  <a:srgbClr val="F5F0EB"/>
-                </a:solidFill>
-                <a:latin typeface="Arial"/>
-              </a:defRPr>
-            </a:pPr>
-            <a:r>
-              <a:t>Strikerとその一味を雇い、</a:t>
-            </a:r>
-          </a:p>
-          <a:p>
-            <a:pPr algn="l">
-              <a:spcAft>
-                <a:spcPts val="379"/>
-              </a:spcAft>
-              <a:defRPr sz="1900" b="0">
-                <a:solidFill>
-                  <a:srgbClr val="F5F0EB"/>
-                </a:solidFill>
-                <a:latin typeface="Arial"/>
-              </a:defRPr>
-            </a:pPr>
-            <a:r>
-              <a:t>Fizzarolliを人質にAsmodeus</a:t>
-            </a:r>
-          </a:p>
-          <a:p>
-            <a:pPr algn="l">
-              <a:spcAft>
-                <a:spcPts val="379"/>
-              </a:spcAft>
-              <a:defRPr sz="1900" b="0">
-                <a:solidFill>
-                  <a:srgbClr val="F5F0EB"/>
-                </a:solidFill>
-                <a:latin typeface="Arial"/>
-              </a:defRPr>
-            </a:pPr>
-            <a:r>
-              <a:t>すら脅迫する大胆さ。</a:t>
-            </a:r>
-          </a:p>
-        </p:txBody>
-      </p:sp>
-    </p:spTree>
-  </p:cSld>
-  <p:clrMapOvr>
-    <a:masterClrMapping/>
-  </p:clrMapOvr>
-</p:sld>
-</file>
-
-<file path=ppt/slides/slide6.xml><?xml version="1.0" encoding="utf-8"?>
-<p:sld xmlns:a="http://schemas.openxmlformats.org/drawingml/2006/main" xmlns:p="http://schemas.openxmlformats.org/presentationml/2006/main" xmlns:r="http://schemas.openxmlformats.org/officeDocument/2006/relationships">
-  <p:cSld>
-    <p:bg>
-      <p:bgPr>
-        <a:solidFill>
-          <a:srgbClr val="0F0A0A"/>
-        </a:solidFill>
-        <a:effectLst/>
-      </p:bgPr>
-    </p:bg>
-    <p:spTree>
-      <p:nvGrpSpPr>
-        <p:cNvPr id="1" name=""/>
-        <p:cNvGrpSpPr/>
-        <p:nvPr/>
-      </p:nvGrpSpPr>
-      <p:grpSpPr/>
-      <p:sp>
-        <p:nvSpPr>
-          <p:cNvPr id="2" name="Rectangle 1"/>
+              <a:t>能力</a:t>
+            </a:r>
+          </a:p>
+        </p:txBody>
+      </p:sp>
+      <p:sp>
+        <p:nvSpPr>
+          <p:cNvPr id="4" name="Rectangle 3"/>
           <p:cNvSpPr/>
           <p:nvPr/>
         </p:nvSpPr>
         <p:spPr>
           <a:xfrm>
-            <a:off x="0" y="0"/>
-            <a:ext cx="12191695" cy="1097280"/>
+            <a:off x="457200" y="1097280"/>
+            <a:ext cx="11277295" cy="36576"/>
           </a:xfrm>
           <a:prstGeom prst="rect">
             <a:avLst/>
           </a:prstGeom>
           <a:solidFill>
-            <a:srgbClr val="640F0F"/>
+            <a:srgbClr val="D4AF37"/>
           </a:solidFill>
           <a:ln>
             <a:noFill/>
@@ -5626,16 +5506,40 @@
           </a:p>
         </p:txBody>
       </p:sp>
-      <p:sp>
-        <p:nvSpPr>
-          <p:cNvPr id="3" name="TextBox 2"/>
+      <p:pic>
+        <p:nvPicPr>
+          <p:cNvPr id="5" name="Picture 4" descr="crimson-8.JPG"/>
+          <p:cNvPicPr>
+            <a:picLocks noChangeAspect="1"/>
+          </p:cNvPicPr>
+          <p:nvPr/>
+        </p:nvPicPr>
+        <p:blipFill>
+          <a:blip r:embed="rId2"/>
+          <a:stretch>
+            <a:fillRect/>
+          </a:stretch>
+        </p:blipFill>
+        <p:spPr>
+          <a:xfrm>
+            <a:off x="6858000" y="1371600"/>
+            <a:ext cx="4846320" cy="2724693"/>
+          </a:xfrm>
+          <a:prstGeom prst="rect">
+            <a:avLst/>
+          </a:prstGeom>
+        </p:spPr>
+      </p:pic>
+      <p:sp>
+        <p:nvSpPr>
+          <p:cNvPr id="6" name="TextBox 5"/>
           <p:cNvSpPr txBox="1"/>
           <p:nvPr/>
         </p:nvSpPr>
         <p:spPr>
           <a:xfrm>
-            <a:off x="457200" y="137160"/>
-            <a:ext cx="10972800" cy="822960"/>
+            <a:off x="731520" y="1463040"/>
+            <a:ext cx="5486400" cy="457200"/>
           </a:xfrm>
           <a:prstGeom prst="rect">
             <a:avLst/>
@@ -5648,36 +5552,322 @@
           </a:bodyPr>
           <a:lstStyle/>
           <a:p>
-            <a:pPr algn="ctr">
-              <a:defRPr sz="4200" b="1">
-                <a:solidFill>
-                  <a:srgbClr val="F5F0EB"/>
-                </a:solidFill>
-                <a:latin typeface="Arial"/>
-              </a:defRPr>
-            </a:pPr>
-            <a:r>
-              <a:t>ABILITIES</a:t>
-            </a:r>
-          </a:p>
-        </p:txBody>
-      </p:sp>
-      <p:sp>
-        <p:nvSpPr>
-          <p:cNvPr id="4" name="Rectangle 3"/>
+            <a:pPr algn="l">
+              <a:defRPr sz="2400" b="1">
+                <a:solidFill>
+                  <a:srgbClr val="D4AF37"/>
+                </a:solidFill>
+                <a:latin typeface="Arial"/>
+              </a:defRPr>
+            </a:pPr>
+            <a:r>
+              <a:t>統率力</a:t>
+            </a:r>
+          </a:p>
+        </p:txBody>
+      </p:sp>
+      <p:sp>
+        <p:nvSpPr>
+          <p:cNvPr id="7" name="TextBox 6"/>
+          <p:cNvSpPr txBox="1"/>
+          <p:nvPr/>
+        </p:nvSpPr>
+        <p:spPr>
+          <a:xfrm>
+            <a:off x="731520" y="1874520"/>
+            <a:ext cx="5486400" cy="731520"/>
+          </a:xfrm>
+          <a:prstGeom prst="rect">
+            <a:avLst/>
+          </a:prstGeom>
+          <a:noFill/>
+        </p:spPr>
+        <p:txBody>
+          <a:bodyPr wrap="square">
+            <a:spAutoFit/>
+          </a:bodyPr>
+          <a:lstStyle/>
+          <a:p>
+            <a:pPr algn="l">
+              <a:defRPr sz="1700" b="0">
+                <a:solidFill>
+                  <a:srgbClr val="BEB9B4"/>
+                </a:solidFill>
+                <a:latin typeface="Arial"/>
+              </a:defRPr>
+            </a:pPr>
+            <a:r>
+              <a:t>絶対的なカリスマで巨大組織を率いる</a:t>
+            </a:r>
+          </a:p>
+        </p:txBody>
+      </p:sp>
+      <p:sp>
+        <p:nvSpPr>
+          <p:cNvPr id="8" name="TextBox 7"/>
+          <p:cNvSpPr txBox="1"/>
+          <p:nvPr/>
+        </p:nvSpPr>
+        <p:spPr>
+          <a:xfrm>
+            <a:off x="731520" y="2697480"/>
+            <a:ext cx="5486400" cy="457200"/>
+          </a:xfrm>
+          <a:prstGeom prst="rect">
+            <a:avLst/>
+          </a:prstGeom>
+          <a:noFill/>
+        </p:spPr>
+        <p:txBody>
+          <a:bodyPr wrap="square">
+            <a:spAutoFit/>
+          </a:bodyPr>
+          <a:lstStyle/>
+          <a:p>
+            <a:pPr algn="l">
+              <a:defRPr sz="2400" b="1">
+                <a:solidFill>
+                  <a:srgbClr val="D4AF37"/>
+                </a:solidFill>
+                <a:latin typeface="Arial"/>
+              </a:defRPr>
+            </a:pPr>
+            <a:r>
+              <a:t>心理操作</a:t>
+            </a:r>
+          </a:p>
+        </p:txBody>
+      </p:sp>
+      <p:sp>
+        <p:nvSpPr>
+          <p:cNvPr id="9" name="TextBox 8"/>
+          <p:cNvSpPr txBox="1"/>
+          <p:nvPr/>
+        </p:nvSpPr>
+        <p:spPr>
+          <a:xfrm>
+            <a:off x="731520" y="3108960"/>
+            <a:ext cx="5486400" cy="731520"/>
+          </a:xfrm>
+          <a:prstGeom prst="rect">
+            <a:avLst/>
+          </a:prstGeom>
+          <a:noFill/>
+        </p:spPr>
+        <p:txBody>
+          <a:bodyPr wrap="square">
+            <a:spAutoFit/>
+          </a:bodyPr>
+          <a:lstStyle/>
+          <a:p>
+            <a:pPr algn="l">
+              <a:defRPr sz="1700" b="0">
+                <a:solidFill>
+                  <a:srgbClr val="BEB9B4"/>
+                </a:solidFill>
+                <a:latin typeface="Arial"/>
+              </a:defRPr>
+            </a:pPr>
+            <a:r>
+              <a:t>長年にわたりモクシーの精神を支配し、</a:t>
+            </a:r>
+            <a:br/>
+            <a:r>
+              <a:t>脅迫と心理戦で周囲を操る</a:t>
+            </a:r>
+          </a:p>
+        </p:txBody>
+      </p:sp>
+      <p:sp>
+        <p:nvSpPr>
+          <p:cNvPr id="10" name="TextBox 9"/>
+          <p:cNvSpPr txBox="1"/>
+          <p:nvPr/>
+        </p:nvSpPr>
+        <p:spPr>
+          <a:xfrm>
+            <a:off x="731520" y="3931920"/>
+            <a:ext cx="5486400" cy="457200"/>
+          </a:xfrm>
+          <a:prstGeom prst="rect">
+            <a:avLst/>
+          </a:prstGeom>
+          <a:noFill/>
+        </p:spPr>
+        <p:txBody>
+          <a:bodyPr wrap="square">
+            <a:spAutoFit/>
+          </a:bodyPr>
+          <a:lstStyle/>
+          <a:p>
+            <a:pPr algn="l">
+              <a:defRPr sz="2400" b="1">
+                <a:solidFill>
+                  <a:srgbClr val="D4AF37"/>
+                </a:solidFill>
+                <a:latin typeface="Arial"/>
+              </a:defRPr>
+            </a:pPr>
+            <a:r>
+              <a:t>武器の扱い</a:t>
+            </a:r>
+          </a:p>
+        </p:txBody>
+      </p:sp>
+      <p:sp>
+        <p:nvSpPr>
+          <p:cNvPr id="11" name="TextBox 10"/>
+          <p:cNvSpPr txBox="1"/>
+          <p:nvPr/>
+        </p:nvSpPr>
+        <p:spPr>
+          <a:xfrm>
+            <a:off x="731520" y="4343400"/>
+            <a:ext cx="5486400" cy="731520"/>
+          </a:xfrm>
+          <a:prstGeom prst="rect">
+            <a:avLst/>
+          </a:prstGeom>
+          <a:noFill/>
+        </p:spPr>
+        <p:txBody>
+          <a:bodyPr wrap="square">
+            <a:spAutoFit/>
+          </a:bodyPr>
+          <a:lstStyle/>
+          <a:p>
+            <a:pPr algn="l">
+              <a:defRPr sz="1700" b="0">
+                <a:solidFill>
+                  <a:srgbClr val="BEB9B4"/>
+                </a:solidFill>
+                <a:latin typeface="Arial"/>
+              </a:defRPr>
+            </a:pPr>
+            <a:r>
+              <a:t>ナイフの投擲に秀でた腕前を持つ</a:t>
+            </a:r>
+          </a:p>
+        </p:txBody>
+      </p:sp>
+      <p:sp>
+        <p:nvSpPr>
+          <p:cNvPr id="12" name="TextBox 11"/>
+          <p:cNvSpPr txBox="1"/>
+          <p:nvPr/>
+        </p:nvSpPr>
+        <p:spPr>
+          <a:xfrm>
+            <a:off x="731520" y="5166360"/>
+            <a:ext cx="5486400" cy="457200"/>
+          </a:xfrm>
+          <a:prstGeom prst="rect">
+            <a:avLst/>
+          </a:prstGeom>
+          <a:noFill/>
+        </p:spPr>
+        <p:txBody>
+          <a:bodyPr wrap="square">
+            <a:spAutoFit/>
+          </a:bodyPr>
+          <a:lstStyle/>
+          <a:p>
+            <a:pPr algn="l">
+              <a:defRPr sz="2400" b="1">
+                <a:solidFill>
+                  <a:srgbClr val="D4AF37"/>
+                </a:solidFill>
+                <a:latin typeface="Arial"/>
+              </a:defRPr>
+            </a:pPr>
+            <a:r>
+              <a:t>演技力</a:t>
+            </a:r>
+          </a:p>
+        </p:txBody>
+      </p:sp>
+      <p:sp>
+        <p:nvSpPr>
+          <p:cNvPr id="13" name="TextBox 12"/>
+          <p:cNvSpPr txBox="1"/>
+          <p:nvPr/>
+        </p:nvSpPr>
+        <p:spPr>
+          <a:xfrm>
+            <a:off x="731520" y="5577840"/>
+            <a:ext cx="5486400" cy="731520"/>
+          </a:xfrm>
+          <a:prstGeom prst="rect">
+            <a:avLst/>
+          </a:prstGeom>
+          <a:noFill/>
+        </p:spPr>
+        <p:txBody>
+          <a:bodyPr wrap="square">
+            <a:spAutoFit/>
+          </a:bodyPr>
+          <a:lstStyle/>
+          <a:p>
+            <a:pPr algn="l">
+              <a:defRPr sz="1700" b="0">
+                <a:solidFill>
+                  <a:srgbClr val="BEB9B4"/>
+                </a:solidFill>
+                <a:latin typeface="Arial"/>
+              </a:defRPr>
+            </a:pPr>
+            <a:r>
+              <a:t>温厚な紳士から冷酷な暴君まで、</a:t>
+            </a:r>
+            <a:br/>
+            <a:r>
+              <a:t>自在に顔を使い分ける</a:t>
+            </a:r>
+          </a:p>
+        </p:txBody>
+      </p:sp>
+    </p:spTree>
+  </p:cSld>
+  <p:clrMapOvr>
+    <a:masterClrMapping/>
+  </p:clrMapOvr>
+</p:sld>
+</file>
+
+<file path=ppt/slides/slide7.xml><?xml version="1.0" encoding="utf-8"?>
+<p:sld xmlns:a="http://schemas.openxmlformats.org/drawingml/2006/main" xmlns:p="http://schemas.openxmlformats.org/presentationml/2006/main" xmlns:r="http://schemas.openxmlformats.org/officeDocument/2006/relationships">
+  <p:cSld>
+    <p:bg>
+      <p:bgPr>
+        <a:solidFill>
+          <a:srgbClr val="12120F"/>
+        </a:solidFill>
+        <a:effectLst/>
+      </p:bgPr>
+    </p:bg>
+    <p:spTree>
+      <p:nvGrpSpPr>
+        <p:cNvPr id="1" name=""/>
+        <p:cNvGrpSpPr/>
+        <p:nvPr/>
+      </p:nvGrpSpPr>
+      <p:grpSpPr/>
+      <p:sp>
+        <p:nvSpPr>
+          <p:cNvPr id="2" name="Rectangle 1"/>
           <p:cNvSpPr/>
           <p:nvPr/>
         </p:nvSpPr>
         <p:spPr>
           <a:xfrm>
-            <a:off x="457200" y="1097280"/>
-            <a:ext cx="11277295" cy="36576"/>
+            <a:off x="0" y="0"/>
+            <a:ext cx="12191695" cy="1097280"/>
           </a:xfrm>
           <a:prstGeom prst="rect">
             <a:avLst/>
           </a:prstGeom>
           <a:solidFill>
-            <a:srgbClr val="D4AF37"/>
+            <a:srgbClr val="640F0F"/>
           </a:solidFill>
           <a:ln>
             <a:noFill/>
@@ -5705,40 +5895,16 @@
           </a:p>
         </p:txBody>
       </p:sp>
-      <p:pic>
-        <p:nvPicPr>
-          <p:cNvPr id="5" name="Picture 4" descr="crimson-8.JPG"/>
-          <p:cNvPicPr>
-            <a:picLocks noChangeAspect="1"/>
-          </p:cNvPicPr>
-          <p:nvPr/>
-        </p:nvPicPr>
-        <p:blipFill>
-          <a:blip r:embed="rId2"/>
-          <a:stretch>
-            <a:fillRect/>
-          </a:stretch>
-        </p:blipFill>
-        <p:spPr>
-          <a:xfrm>
-            <a:off x="6858000" y="1371600"/>
-            <a:ext cx="4846320" cy="2724693"/>
-          </a:xfrm>
-          <a:prstGeom prst="rect">
-            <a:avLst/>
-          </a:prstGeom>
-        </p:spPr>
-      </p:pic>
-      <p:sp>
-        <p:nvSpPr>
-          <p:cNvPr id="6" name="TextBox 5"/>
+      <p:sp>
+        <p:nvSpPr>
+          <p:cNvPr id="3" name="TextBox 2"/>
           <p:cNvSpPr txBox="1"/>
           <p:nvPr/>
         </p:nvSpPr>
         <p:spPr>
           <a:xfrm>
-            <a:off x="731520" y="1463040"/>
-            <a:ext cx="5486400" cy="457200"/>
+            <a:off x="457200" y="137160"/>
+            <a:ext cx="10972800" cy="822960"/>
           </a:xfrm>
           <a:prstGeom prst="rect">
             <a:avLst/>
@@ -5751,348 +5917,36 @@
           </a:bodyPr>
           <a:lstStyle/>
           <a:p>
-            <a:pPr algn="l">
-              <a:defRPr sz="2400" b="1">
-                <a:solidFill>
-                  <a:srgbClr val="D4AF37"/>
-                </a:solidFill>
-                <a:latin typeface="Arial"/>
-              </a:defRPr>
-            </a:pPr>
-            <a:r>
-              <a:t>Leadership</a:t>
-            </a:r>
-          </a:p>
-        </p:txBody>
-      </p:sp>
-      <p:sp>
-        <p:nvSpPr>
-          <p:cNvPr id="7" name="TextBox 6"/>
-          <p:cNvSpPr txBox="1"/>
-          <p:nvPr/>
-        </p:nvSpPr>
-        <p:spPr>
-          <a:xfrm>
-            <a:off x="731520" y="1874520"/>
-            <a:ext cx="5486400" cy="731520"/>
-          </a:xfrm>
-          <a:prstGeom prst="rect">
-            <a:avLst/>
-          </a:prstGeom>
-          <a:noFill/>
-        </p:spPr>
-        <p:txBody>
-          <a:bodyPr wrap="square">
-            <a:spAutoFit/>
-          </a:bodyPr>
-          <a:lstStyle/>
-          <a:p>
-            <a:pPr algn="l">
-              <a:defRPr sz="1700" b="0">
-                <a:solidFill>
-                  <a:srgbClr val="B4AFAA"/>
-                </a:solidFill>
-                <a:latin typeface="Arial"/>
-              </a:defRPr>
-            </a:pPr>
-            <a:r>
-              <a:t>絶対的なカリスマで大組織を統率</a:t>
-            </a:r>
-          </a:p>
-        </p:txBody>
-      </p:sp>
-      <p:sp>
-        <p:nvSpPr>
-          <p:cNvPr id="8" name="TextBox 7"/>
-          <p:cNvSpPr txBox="1"/>
-          <p:nvPr/>
-        </p:nvSpPr>
-        <p:spPr>
-          <a:xfrm>
-            <a:off x="731520" y="2697480"/>
-            <a:ext cx="5486400" cy="457200"/>
-          </a:xfrm>
-          <a:prstGeom prst="rect">
-            <a:avLst/>
-          </a:prstGeom>
-          <a:noFill/>
-        </p:spPr>
-        <p:txBody>
-          <a:bodyPr wrap="square">
-            <a:spAutoFit/>
-          </a:bodyPr>
-          <a:lstStyle/>
-          <a:p>
-            <a:pPr algn="l">
-              <a:defRPr sz="2400" b="1">
-                <a:solidFill>
-                  <a:srgbClr val="D4AF37"/>
-                </a:solidFill>
-                <a:latin typeface="Arial"/>
-              </a:defRPr>
-            </a:pPr>
-            <a:r>
-              <a:t>Manipulation</a:t>
-            </a:r>
-          </a:p>
-        </p:txBody>
-      </p:sp>
-      <p:sp>
-        <p:nvSpPr>
-          <p:cNvPr id="9" name="TextBox 8"/>
-          <p:cNvSpPr txBox="1"/>
-          <p:nvPr/>
-        </p:nvSpPr>
-        <p:spPr>
-          <a:xfrm>
-            <a:off x="731520" y="3108960"/>
-            <a:ext cx="5486400" cy="731520"/>
-          </a:xfrm>
-          <a:prstGeom prst="rect">
-            <a:avLst/>
-          </a:prstGeom>
-          <a:noFill/>
-        </p:spPr>
-        <p:txBody>
-          <a:bodyPr wrap="square">
-            <a:spAutoFit/>
-          </a:bodyPr>
-          <a:lstStyle/>
-          <a:p>
-            <a:pPr algn="l">
-              <a:defRPr sz="1700" b="0">
-                <a:solidFill>
-                  <a:srgbClr val="B4AFAA"/>
-                </a:solidFill>
-                <a:latin typeface="Arial"/>
-              </a:defRPr>
-            </a:pPr>
-            <a:r>
-              <a:t>長年にわたりモクシーの精神を支配</a:t>
-            </a:r>
-            <a:br/>
-            <a:r>
-              <a:t>脅迫と心理戦で周囲を操る</a:t>
-            </a:r>
-          </a:p>
-        </p:txBody>
-      </p:sp>
-      <p:sp>
-        <p:nvSpPr>
-          <p:cNvPr id="10" name="TextBox 9"/>
-          <p:cNvSpPr txBox="1"/>
-          <p:nvPr/>
-        </p:nvSpPr>
-        <p:spPr>
-          <a:xfrm>
-            <a:off x="731520" y="3931920"/>
-            <a:ext cx="5486400" cy="457200"/>
-          </a:xfrm>
-          <a:prstGeom prst="rect">
-            <a:avLst/>
-          </a:prstGeom>
-          <a:noFill/>
-        </p:spPr>
-        <p:txBody>
-          <a:bodyPr wrap="square">
-            <a:spAutoFit/>
-          </a:bodyPr>
-          <a:lstStyle/>
-          <a:p>
-            <a:pPr algn="l">
-              <a:defRPr sz="2400" b="1">
-                <a:solidFill>
-                  <a:srgbClr val="D4AF37"/>
-                </a:solidFill>
-                <a:latin typeface="Arial"/>
-              </a:defRPr>
-            </a:pPr>
-            <a:r>
-              <a:t>Weapon Proficiency</a:t>
-            </a:r>
-          </a:p>
-        </p:txBody>
-      </p:sp>
-      <p:sp>
-        <p:nvSpPr>
-          <p:cNvPr id="11" name="TextBox 10"/>
-          <p:cNvSpPr txBox="1"/>
-          <p:nvPr/>
-        </p:nvSpPr>
-        <p:spPr>
-          <a:xfrm>
-            <a:off x="731520" y="4343400"/>
-            <a:ext cx="5486400" cy="731520"/>
-          </a:xfrm>
-          <a:prstGeom prst="rect">
-            <a:avLst/>
-          </a:prstGeom>
-          <a:noFill/>
-        </p:spPr>
-        <p:txBody>
-          <a:bodyPr wrap="square">
-            <a:spAutoFit/>
-          </a:bodyPr>
-          <a:lstStyle/>
-          <a:p>
-            <a:pPr algn="l">
-              <a:defRPr sz="1700" b="0">
-                <a:solidFill>
-                  <a:srgbClr val="B4AFAA"/>
-                </a:solidFill>
-                <a:latin typeface="Arial"/>
-              </a:defRPr>
-            </a:pPr>
-            <a:r>
-              <a:t>ナイフの投擲に秀でた腕前</a:t>
-            </a:r>
-          </a:p>
-        </p:txBody>
-      </p:sp>
-      <p:sp>
-        <p:nvSpPr>
-          <p:cNvPr id="12" name="TextBox 11"/>
-          <p:cNvSpPr txBox="1"/>
-          <p:nvPr/>
-        </p:nvSpPr>
-        <p:spPr>
-          <a:xfrm>
-            <a:off x="731520" y="5166360"/>
-            <a:ext cx="5486400" cy="457200"/>
-          </a:xfrm>
-          <a:prstGeom prst="rect">
-            <a:avLst/>
-          </a:prstGeom>
-          <a:noFill/>
-        </p:spPr>
-        <p:txBody>
-          <a:bodyPr wrap="square">
-            <a:spAutoFit/>
-          </a:bodyPr>
-          <a:lstStyle/>
-          <a:p>
-            <a:pPr algn="l">
-              <a:defRPr sz="2400" b="1">
-                <a:solidFill>
-                  <a:srgbClr val="D4AF37"/>
-                </a:solidFill>
-                <a:latin typeface="Arial"/>
-              </a:defRPr>
-            </a:pPr>
-            <a:r>
-              <a:t>Acting</a:t>
-            </a:r>
-          </a:p>
-        </p:txBody>
-      </p:sp>
-      <p:sp>
-        <p:nvSpPr>
-          <p:cNvPr id="13" name="TextBox 12"/>
-          <p:cNvSpPr txBox="1"/>
-          <p:nvPr/>
-        </p:nvSpPr>
-        <p:spPr>
-          <a:xfrm>
-            <a:off x="731520" y="5577840"/>
-            <a:ext cx="5486400" cy="731520"/>
-          </a:xfrm>
-          <a:prstGeom prst="rect">
-            <a:avLst/>
-          </a:prstGeom>
-          <a:noFill/>
-        </p:spPr>
-        <p:txBody>
-          <a:bodyPr wrap="square">
-            <a:spAutoFit/>
-          </a:bodyPr>
-          <a:lstStyle/>
-          <a:p>
-            <a:pPr algn="l">
-              <a:defRPr sz="1700" b="0">
-                <a:solidFill>
-                  <a:srgbClr val="B4AFAA"/>
-                </a:solidFill>
-                <a:latin typeface="Arial"/>
-              </a:defRPr>
-            </a:pPr>
-            <a:r>
-              <a:t>温厚な紳士から冷酷な暴君まで</a:t>
-            </a:r>
-            <a:br/>
-            <a:r>
-              <a:t>自在に顔を使い分ける</a:t>
-            </a:r>
-          </a:p>
-        </p:txBody>
-      </p:sp>
-    </p:spTree>
-  </p:cSld>
-  <p:clrMapOvr>
-    <a:masterClrMapping/>
-  </p:clrMapOvr>
-</p:sld>
-</file>
-
-<file path=ppt/slides/slide7.xml><?xml version="1.0" encoding="utf-8"?>
-<p:sld xmlns:a="http://schemas.openxmlformats.org/drawingml/2006/main" xmlns:p="http://schemas.openxmlformats.org/presentationml/2006/main" xmlns:r="http://schemas.openxmlformats.org/officeDocument/2006/relationships">
-  <p:cSld>
-    <p:bg>
-      <p:bgPr>
-        <a:solidFill>
-          <a:srgbClr val="0A0F0A"/>
-        </a:solidFill>
-        <a:effectLst/>
-      </p:bgPr>
-    </p:bg>
-    <p:spTree>
-      <p:nvGrpSpPr>
-        <p:cNvPr id="1" name=""/>
-        <p:cNvGrpSpPr/>
-        <p:nvPr/>
-      </p:nvGrpSpPr>
-      <p:grpSpPr/>
-      <p:pic>
-        <p:nvPicPr>
-          <p:cNvPr id="2" name="Picture 1" descr="crimson-love.jpg"/>
-          <p:cNvPicPr>
-            <a:picLocks noChangeAspect="1"/>
-          </p:cNvPicPr>
-          <p:nvPr/>
-        </p:nvPicPr>
-        <p:blipFill>
-          <a:blip r:embed="rId2"/>
-          <a:stretch>
-            <a:fillRect/>
-          </a:stretch>
-        </p:blipFill>
-        <p:spPr>
-          <a:xfrm>
-            <a:off x="0" y="0"/>
-            <a:ext cx="12191695" cy="11233134"/>
-          </a:xfrm>
-          <a:prstGeom prst="rect">
-            <a:avLst/>
-          </a:prstGeom>
-        </p:spPr>
-      </p:pic>
-      <p:sp>
-        <p:nvSpPr>
-          <p:cNvPr id="3" name="Rectangle 2"/>
+            <a:pPr algn="ctr">
+              <a:defRPr sz="4200" b="1">
+                <a:solidFill>
+                  <a:srgbClr val="F5F0EB"/>
+                </a:solidFill>
+                <a:latin typeface="Arial"/>
+              </a:defRPr>
+            </a:pPr>
+            <a:r>
+              <a:t>クリムゾンとモクシー</a:t>
+            </a:r>
+          </a:p>
+        </p:txBody>
+      </p:sp>
+      <p:sp>
+        <p:nvSpPr>
+          <p:cNvPr id="4" name="Rectangle 3"/>
           <p:cNvSpPr/>
           <p:nvPr/>
         </p:nvSpPr>
         <p:spPr>
           <a:xfrm>
-            <a:off x="0" y="0"/>
-            <a:ext cx="12191695" cy="6858000"/>
+            <a:off x="457200" y="1097280"/>
+            <a:ext cx="11277295" cy="36576"/>
           </a:xfrm>
           <a:prstGeom prst="rect">
             <a:avLst/>
           </a:prstGeom>
           <a:solidFill>
-            <a:srgbClr val="000000">
-              <a:alpha val="50000"/>
-            </a:srgbClr>
+            <a:srgbClr val="D4AF37"/>
           </a:solidFill>
           <a:ln>
             <a:noFill/>
@@ -6120,16 +5974,40 @@
           </a:p>
         </p:txBody>
       </p:sp>
-      <p:sp>
-        <p:nvSpPr>
-          <p:cNvPr id="4" name="TextBox 3"/>
+      <p:pic>
+        <p:nvPicPr>
+          <p:cNvPr id="5" name="Picture 4" descr="crimson-love.jpg"/>
+          <p:cNvPicPr>
+            <a:picLocks noChangeAspect="1"/>
+          </p:cNvPicPr>
+          <p:nvPr/>
+        </p:nvPicPr>
+        <p:blipFill>
+          <a:blip r:embed="rId2"/>
+          <a:stretch>
+            <a:fillRect/>
+          </a:stretch>
+        </p:blipFill>
+        <p:spPr>
+          <a:xfrm>
+            <a:off x="548640" y="1463040"/>
+            <a:ext cx="5160630" cy="4754880"/>
+          </a:xfrm>
+          <a:prstGeom prst="rect">
+            <a:avLst/>
+          </a:prstGeom>
+        </p:spPr>
+      </p:pic>
+      <p:sp>
+        <p:nvSpPr>
+          <p:cNvPr id="6" name="TextBox 5"/>
           <p:cNvSpPr txBox="1"/>
           <p:nvPr/>
         </p:nvSpPr>
         <p:spPr>
           <a:xfrm>
-            <a:off x="457200" y="274320"/>
-            <a:ext cx="10972800" cy="914400"/>
+            <a:off x="5669280" y="1645920"/>
+            <a:ext cx="5943600" cy="5029200"/>
           </a:xfrm>
           <a:prstGeom prst="rect">
             <a:avLst/>
@@ -6142,30 +6020,254 @@
           </a:bodyPr>
           <a:lstStyle/>
           <a:p>
+            <a:pPr algn="l">
+              <a:spcAft>
+                <a:spcPts val="439"/>
+              </a:spcAft>
+              <a:defRPr sz="2200" b="0">
+                <a:solidFill>
+                  <a:srgbClr val="F5F0EB"/>
+                </a:solidFill>
+                <a:latin typeface="Arial"/>
+              </a:defRPr>
+            </a:pPr>
+            <a:r>
+              <a:t>マフィアのボスの息子として、</a:t>
+            </a:r>
+          </a:p>
+          <a:p>
+            <a:pPr algn="l">
+              <a:spcAft>
+                <a:spcPts val="439"/>
+              </a:spcAft>
+              <a:defRPr sz="2200" b="0">
+                <a:solidFill>
+                  <a:srgbClr val="F5F0EB"/>
+                </a:solidFill>
+                <a:latin typeface="Arial"/>
+              </a:defRPr>
+            </a:pPr>
+            <a:r>
+              <a:t>茨の道を歩ませなければならなかった。</a:t>
+            </a:r>
+          </a:p>
+          <a:p>
+            <a:pPr algn="l">
+              <a:spcAft>
+                <a:spcPts val="439"/>
+              </a:spcAft>
+              <a:defRPr sz="2200" b="0">
+                <a:solidFill>
+                  <a:srgbClr val="F5F0EB"/>
+                </a:solidFill>
+                <a:latin typeface="Arial"/>
+              </a:defRPr>
+            </a:pPr>
+          </a:p>
+          <a:p>
+            <a:pPr algn="l">
+              <a:spcAft>
+                <a:spcPts val="439"/>
+              </a:spcAft>
+              <a:defRPr sz="2200" b="0">
+                <a:solidFill>
+                  <a:srgbClr val="F5F0EB"/>
+                </a:solidFill>
+                <a:latin typeface="Arial"/>
+              </a:defRPr>
+            </a:pPr>
+            <a:r>
+              <a:t>「殺らなきゃ殺られる」世界で</a:t>
+            </a:r>
+          </a:p>
+          <a:p>
+            <a:pPr algn="l">
+              <a:spcAft>
+                <a:spcPts val="439"/>
+              </a:spcAft>
+              <a:defRPr sz="2200" b="0">
+                <a:solidFill>
+                  <a:srgbClr val="F5F0EB"/>
+                </a:solidFill>
+                <a:latin typeface="Arial"/>
+              </a:defRPr>
+            </a:pPr>
+            <a:r>
+              <a:t>息子が生き残れるよう厳しく育てた。</a:t>
+            </a:r>
+          </a:p>
+          <a:p>
+            <a:pPr algn="l">
+              <a:spcAft>
+                <a:spcPts val="439"/>
+              </a:spcAft>
+              <a:defRPr sz="2200" b="0">
+                <a:solidFill>
+                  <a:srgbClr val="F5F0EB"/>
+                </a:solidFill>
+                <a:latin typeface="Arial"/>
+              </a:defRPr>
+            </a:pPr>
+          </a:p>
+          <a:p>
+            <a:pPr algn="l">
+              <a:spcAft>
+                <a:spcPts val="439"/>
+              </a:spcAft>
+              <a:defRPr sz="2200" b="0">
+                <a:solidFill>
+                  <a:srgbClr val="F5F0EB"/>
+                </a:solidFill>
+                <a:latin typeface="Arial"/>
+              </a:defRPr>
+            </a:pPr>
+            <a:r>
+              <a:t>家を出て結婚した息子を、</a:t>
+            </a:r>
+          </a:p>
+          <a:p>
+            <a:pPr algn="l">
+              <a:spcAft>
+                <a:spcPts val="439"/>
+              </a:spcAft>
+              <a:defRPr sz="2200" b="0">
+                <a:solidFill>
+                  <a:srgbClr val="F5F0EB"/>
+                </a:solidFill>
+                <a:latin typeface="Arial"/>
+              </a:defRPr>
+            </a:pPr>
+            <a:r>
+              <a:t>すぐに追わず静かに見守っていた。</a:t>
+            </a:r>
+          </a:p>
+          <a:p>
+            <a:pPr algn="l">
+              <a:spcAft>
+                <a:spcPts val="439"/>
+              </a:spcAft>
+              <a:defRPr sz="2200" b="0">
+                <a:solidFill>
+                  <a:srgbClr val="F5F0EB"/>
+                </a:solidFill>
+                <a:latin typeface="Arial"/>
+              </a:defRPr>
+            </a:pPr>
+          </a:p>
+          <a:p>
+            <a:pPr algn="l">
+              <a:spcAft>
+                <a:spcPts val="439"/>
+              </a:spcAft>
+              <a:defRPr sz="2200" b="0">
+                <a:solidFill>
+                  <a:srgbClr val="F5F0EB"/>
+                </a:solidFill>
+                <a:latin typeface="Arial"/>
+              </a:defRPr>
+            </a:pPr>
+            <a:r>
+              <a:t>―― 不器用すぎる、歪んだ父の愛。</a:t>
+            </a:r>
+          </a:p>
+        </p:txBody>
+      </p:sp>
+    </p:spTree>
+  </p:cSld>
+  <p:clrMapOvr>
+    <a:masterClrMapping/>
+  </p:clrMapOvr>
+</p:sld>
+</file>
+
+<file path=ppt/slides/slide8.xml><?xml version="1.0" encoding="utf-8"?>
+<p:sld xmlns:a="http://schemas.openxmlformats.org/drawingml/2006/main" xmlns:p="http://schemas.openxmlformats.org/presentationml/2006/main" xmlns:r="http://schemas.openxmlformats.org/officeDocument/2006/relationships">
+  <p:cSld>
+    <p:bg>
+      <p:bgPr>
+        <a:solidFill>
+          <a:srgbClr val="080505"/>
+        </a:solidFill>
+        <a:effectLst/>
+      </p:bgPr>
+    </p:bg>
+    <p:spTree>
+      <p:nvGrpSpPr>
+        <p:cNvPr id="1" name=""/>
+        <p:cNvGrpSpPr/>
+        <p:nvPr/>
+      </p:nvGrpSpPr>
+      <p:grpSpPr/>
+      <p:pic>
+        <p:nvPicPr>
+          <p:cNvPr id="2" name="Picture 1" descr="_dark_crimson9.jpg"/>
+          <p:cNvPicPr>
+            <a:picLocks noChangeAspect="1"/>
+          </p:cNvPicPr>
+          <p:nvPr/>
+        </p:nvPicPr>
+        <p:blipFill>
+          <a:blip r:embed="rId2"/>
+          <a:stretch>
+            <a:fillRect/>
+          </a:stretch>
+        </p:blipFill>
+        <p:spPr>
+          <a:xfrm>
+            <a:off x="0" y="0"/>
+            <a:ext cx="12191695" cy="7141271"/>
+          </a:xfrm>
+          <a:prstGeom prst="rect">
+            <a:avLst/>
+          </a:prstGeom>
+        </p:spPr>
+      </p:pic>
+      <p:sp>
+        <p:nvSpPr>
+          <p:cNvPr id="3" name="TextBox 2"/>
+          <p:cNvSpPr txBox="1"/>
+          <p:nvPr/>
+        </p:nvSpPr>
+        <p:spPr>
+          <a:xfrm>
+            <a:off x="457200" y="274320"/>
+            <a:ext cx="10972800" cy="914400"/>
+          </a:xfrm>
+          <a:prstGeom prst="rect">
+            <a:avLst/>
+          </a:prstGeom>
+          <a:noFill/>
+        </p:spPr>
+        <p:txBody>
+          <a:bodyPr wrap="square">
+            <a:spAutoFit/>
+          </a:bodyPr>
+          <a:lstStyle/>
+          <a:p>
             <a:pPr algn="ctr">
               <a:defRPr sz="4800" b="1">
                 <a:solidFill>
-                  <a:srgbClr val="D4AF37"/>
-                </a:solidFill>
-                <a:latin typeface="Arial"/>
-              </a:defRPr>
-            </a:pPr>
-            <a:r>
-              <a:t>CRIMSON  &amp;  MOXXIE</a:t>
-            </a:r>
-          </a:p>
-        </p:txBody>
-      </p:sp>
-      <p:sp>
-        <p:nvSpPr>
-          <p:cNvPr id="5" name="Rectangle 4"/>
+                  <a:srgbClr val="B41E1E"/>
+                </a:solidFill>
+                <a:latin typeface="Arial"/>
+              </a:defRPr>
+            </a:pPr>
+            <a:r>
+              <a:t>THE DARK SIDE</a:t>
+            </a:r>
+          </a:p>
+        </p:txBody>
+      </p:sp>
+      <p:sp>
+        <p:nvSpPr>
+          <p:cNvPr id="4" name="Rectangle 3"/>
           <p:cNvSpPr/>
           <p:nvPr/>
         </p:nvSpPr>
         <p:spPr>
           <a:xfrm>
             <a:off x="457200" y="1097280"/>
-            <a:ext cx="5486400" cy="36576"/>
+            <a:ext cx="4572000" cy="36576"/>
           </a:xfrm>
           <a:prstGeom prst="rect">
             <a:avLst/>
@@ -6201,14 +6303,14 @@
       </p:sp>
       <p:sp>
         <p:nvSpPr>
-          <p:cNvPr id="6" name="TextBox 5"/>
+          <p:cNvPr id="5" name="TextBox 4"/>
           <p:cNvSpPr txBox="1"/>
           <p:nvPr/>
         </p:nvSpPr>
         <p:spPr>
           <a:xfrm>
             <a:off x="731520" y="1463040"/>
-            <a:ext cx="5486400" cy="5029200"/>
+            <a:ext cx="7315200" cy="5029200"/>
           </a:xfrm>
           <a:prstGeom prst="rect">
             <a:avLst/>
@@ -6223,9 +6325,9 @@
           <a:p>
             <a:pPr algn="l">
               <a:spcAft>
-                <a:spcPts val="314"/>
+                <a:spcPts val="439"/>
               </a:spcAft>
-              <a:defRPr sz="2100" b="0">
+              <a:defRPr sz="2200" b="1">
                 <a:solidFill>
                   <a:srgbClr val="F5F0EB"/>
                 </a:solidFill>
@@ -6233,60 +6335,57 @@
               </a:defRPr>
             </a:pPr>
             <a:r>
-              <a:t>マフィアのボスの息子として、</a:t>
+              <a:t>◆ 妻を「息子の成長を阻害する存在」として排除した</a:t>
             </a:r>
           </a:p>
           <a:p>
             <a:pPr algn="l">
               <a:spcAft>
-                <a:spcPts val="314"/>
+                <a:spcPts val="439"/>
               </a:spcAft>
-              <a:defRPr sz="2100" b="0">
+              <a:defRPr sz="2200" b="1">
                 <a:solidFill>
                   <a:srgbClr val="F5F0EB"/>
                 </a:solidFill>
                 <a:latin typeface="Arial"/>
               </a:defRPr>
             </a:pPr>
-            <a:r>
-              <a:t>茨の道を歩ませなければならなかった。</a:t>
-            </a:r>
           </a:p>
           <a:p>
             <a:pPr algn="l">
               <a:spcAft>
-                <a:spcPts val="314"/>
+                <a:spcPts val="439"/>
               </a:spcAft>
-              <a:defRPr sz="2100" b="0">
+              <a:defRPr sz="2200" b="1">
                 <a:solidFill>
                   <a:srgbClr val="F5F0EB"/>
                 </a:solidFill>
                 <a:latin typeface="Arial"/>
               </a:defRPr>
             </a:pPr>
+            <a:r>
+              <a:t>◆ モクシーへの身体的・精神的虐待</a:t>
+            </a:r>
           </a:p>
           <a:p>
             <a:pPr algn="l">
               <a:spcAft>
-                <a:spcPts val="314"/>
+                <a:spcPts val="439"/>
               </a:spcAft>
-              <a:defRPr sz="2100" b="0">
+              <a:defRPr sz="2200" b="1">
                 <a:solidFill>
                   <a:srgbClr val="F5F0EB"/>
                 </a:solidFill>
                 <a:latin typeface="Arial"/>
               </a:defRPr>
             </a:pPr>
-            <a:r>
-              <a:t>「殺らなきゃ殺られる」世界で</a:t>
-            </a:r>
           </a:p>
           <a:p>
             <a:pPr algn="l">
               <a:spcAft>
-                <a:spcPts val="314"/>
+                <a:spcPts val="439"/>
               </a:spcAft>
-              <a:defRPr sz="2100" b="0">
+              <a:defRPr sz="2200" b="1">
                 <a:solidFill>
                   <a:srgbClr val="F5F0EB"/>
                 </a:solidFill>
@@ -6294,15 +6393,15 @@
               </a:defRPr>
             </a:pPr>
             <a:r>
-              <a:t>息子が生き残れるよう厳しく育てた。</a:t>
+              <a:t>◆ 組織のためなら息子すら駒として使う冷徹さ</a:t>
             </a:r>
           </a:p>
           <a:p>
             <a:pPr algn="l">
               <a:spcAft>
-                <a:spcPts val="314"/>
+                <a:spcPts val="439"/>
               </a:spcAft>
-              <a:defRPr sz="2100" b="0">
+              <a:defRPr sz="2200" b="1">
                 <a:solidFill>
                   <a:srgbClr val="F5F0EB"/>
                 </a:solidFill>
@@ -6313,9 +6412,9 @@
           <a:p>
             <a:pPr algn="l">
               <a:spcAft>
-                <a:spcPts val="314"/>
+                <a:spcPts val="439"/>
               </a:spcAft>
-              <a:defRPr sz="2100" b="0">
+              <a:defRPr sz="2200" b="1">
                 <a:solidFill>
                   <a:srgbClr val="F5F0EB"/>
                 </a:solidFill>
@@ -6323,15 +6422,15 @@
               </a:defRPr>
             </a:pPr>
             <a:r>
-              <a:t>家を出て結婚した息子を、</a:t>
+              <a:t>◆ フィズロリを人質にし、</a:t>
             </a:r>
           </a:p>
           <a:p>
             <a:pPr algn="l">
               <a:spcAft>
-                <a:spcPts val="314"/>
+                <a:spcPts val="439"/>
               </a:spcAft>
-              <a:defRPr sz="2100" b="0">
+              <a:defRPr sz="2200" b="1">
                 <a:solidFill>
                   <a:srgbClr val="F5F0EB"/>
                 </a:solidFill>
@@ -6339,36 +6438,7 @@
               </a:defRPr>
             </a:pPr>
             <a:r>
-              <a:t>すぐに追わず静かに見守っていた。</a:t>
-            </a:r>
-          </a:p>
-          <a:p>
-            <a:pPr algn="l">
-              <a:spcAft>
-                <a:spcPts val="314"/>
-              </a:spcAft>
-              <a:defRPr sz="2100" b="0">
-                <a:solidFill>
-                  <a:srgbClr val="F5F0EB"/>
-                </a:solidFill>
-                <a:latin typeface="Arial"/>
-              </a:defRPr>
-            </a:pPr>
-          </a:p>
-          <a:p>
-            <a:pPr algn="l">
-              <a:spcAft>
-                <a:spcPts val="314"/>
-              </a:spcAft>
-              <a:defRPr sz="2100" b="0">
-                <a:solidFill>
-                  <a:srgbClr val="F5F0EB"/>
-                </a:solidFill>
-                <a:latin typeface="Arial"/>
-              </a:defRPr>
-            </a:pPr>
-            <a:r>
-              <a:t>不器用すぎる、歪んだ父の愛。</a:t>
+              <a:t>　 七つの大罪の一柱アスモデウスすら脅迫する豪胆さ</a:t>
             </a:r>
           </a:p>
         </p:txBody>
@@ -6381,13 +6451,13 @@
 </p:sld>
 </file>
 
-<file path=ppt/slides/slide8.xml><?xml version="1.0" encoding="utf-8"?>
+<file path=ppt/slides/slide9.xml><?xml version="1.0" encoding="utf-8"?>
 <p:sld xmlns:a="http://schemas.openxmlformats.org/drawingml/2006/main" xmlns:p="http://schemas.openxmlformats.org/presentationml/2006/main" xmlns:r="http://schemas.openxmlformats.org/officeDocument/2006/relationships">
   <p:cSld>
     <p:bg>
       <p:bgPr>
         <a:solidFill>
-          <a:srgbClr val="050303"/>
+          <a:srgbClr val="120C0C"/>
         </a:solidFill>
         <a:effectLst/>
       </p:bgPr>
@@ -6399,48 +6469,22 @@
         <p:nvPr/>
       </p:nvGrpSpPr>
       <p:grpSpPr/>
-      <p:pic>
-        <p:nvPicPr>
-          <p:cNvPr id="2" name="Picture 1" descr="crimson-9.JPG"/>
-          <p:cNvPicPr>
-            <a:picLocks noChangeAspect="1"/>
-          </p:cNvPicPr>
-          <p:nvPr/>
-        </p:nvPicPr>
-        <p:blipFill>
-          <a:blip r:embed="rId2"/>
-          <a:stretch>
-            <a:fillRect/>
-          </a:stretch>
-        </p:blipFill>
-        <p:spPr>
-          <a:xfrm>
-            <a:off x="0" y="0"/>
-            <a:ext cx="12191695" cy="7141271"/>
-          </a:xfrm>
-          <a:prstGeom prst="rect">
-            <a:avLst/>
-          </a:prstGeom>
-        </p:spPr>
-      </p:pic>
-      <p:sp>
-        <p:nvSpPr>
-          <p:cNvPr id="3" name="Rectangle 2"/>
+      <p:sp>
+        <p:nvSpPr>
+          <p:cNvPr id="2" name="Rectangle 1"/>
           <p:cNvSpPr/>
           <p:nvPr/>
         </p:nvSpPr>
         <p:spPr>
           <a:xfrm>
             <a:off x="0" y="0"/>
-            <a:ext cx="12191695" cy="6858000"/>
+            <a:ext cx="12191695" cy="1097280"/>
           </a:xfrm>
           <a:prstGeom prst="rect">
             <a:avLst/>
           </a:prstGeom>
           <a:solidFill>
-            <a:srgbClr val="000000">
-              <a:alpha val="45000"/>
-            </a:srgbClr>
+            <a:srgbClr val="640F0F"/>
           </a:solidFill>
           <a:ln>
             <a:noFill/>
@@ -6470,14 +6514,14 @@
       </p:sp>
       <p:sp>
         <p:nvSpPr>
-          <p:cNvPr id="4" name="TextBox 3"/>
+          <p:cNvPr id="3" name="TextBox 2"/>
           <p:cNvSpPr txBox="1"/>
           <p:nvPr/>
         </p:nvSpPr>
         <p:spPr>
           <a:xfrm>
-            <a:off x="457200" y="274320"/>
-            <a:ext cx="10972800" cy="914400"/>
+            <a:off x="457200" y="137160"/>
+            <a:ext cx="10972800" cy="822960"/>
           </a:xfrm>
           <a:prstGeom prst="rect">
             <a:avLst/>
@@ -6491,29 +6535,29 @@
           <a:lstStyle/>
           <a:p>
             <a:pPr algn="ctr">
-              <a:defRPr sz="4800" b="1">
-                <a:solidFill>
-                  <a:srgbClr val="A51919"/>
-                </a:solidFill>
-                <a:latin typeface="Arial"/>
-              </a:defRPr>
-            </a:pPr>
-            <a:r>
-              <a:t>THE DARK SIDE</a:t>
-            </a:r>
-          </a:p>
-        </p:txBody>
-      </p:sp>
-      <p:sp>
-        <p:nvSpPr>
-          <p:cNvPr id="5" name="Rectangle 4"/>
+              <a:defRPr sz="4200" b="1">
+                <a:solidFill>
+                  <a:srgbClr val="F5F0EB"/>
+                </a:solidFill>
+                <a:latin typeface="Arial"/>
+              </a:defRPr>
+            </a:pPr>
+            <a:r>
+              <a:t>登場エピソード</a:t>
+            </a:r>
+          </a:p>
+        </p:txBody>
+      </p:sp>
+      <p:sp>
+        <p:nvSpPr>
+          <p:cNvPr id="4" name="Rectangle 3"/>
           <p:cNvSpPr/>
           <p:nvPr/>
         </p:nvSpPr>
         <p:spPr>
           <a:xfrm>
             <a:off x="457200" y="1097280"/>
-            <a:ext cx="4572000" cy="36576"/>
+            <a:ext cx="11277295" cy="36576"/>
           </a:xfrm>
           <a:prstGeom prst="rect">
             <a:avLst/>
@@ -6547,296 +6591,6 @@
           </a:p>
         </p:txBody>
       </p:sp>
-      <p:sp>
-        <p:nvSpPr>
-          <p:cNvPr id="6" name="TextBox 5"/>
-          <p:cNvSpPr txBox="1"/>
-          <p:nvPr/>
-        </p:nvSpPr>
-        <p:spPr>
-          <a:xfrm>
-            <a:off x="731520" y="1463040"/>
-            <a:ext cx="6400800" cy="5029200"/>
-          </a:xfrm>
-          <a:prstGeom prst="rect">
-            <a:avLst/>
-          </a:prstGeom>
-          <a:noFill/>
-        </p:spPr>
-        <p:txBody>
-          <a:bodyPr wrap="square">
-            <a:spAutoFit/>
-          </a:bodyPr>
-          <a:lstStyle/>
-          <a:p>
-            <a:pPr algn="l">
-              <a:spcAft>
-                <a:spcPts val="419"/>
-              </a:spcAft>
-              <a:defRPr sz="2100" b="0">
-                <a:solidFill>
-                  <a:srgbClr val="F5F0EB"/>
-                </a:solidFill>
-                <a:latin typeface="Arial"/>
-              </a:defRPr>
-            </a:pPr>
-            <a:r>
-              <a:t>妻を「息子の成長を阻害する存在」として排除</a:t>
-            </a:r>
-          </a:p>
-          <a:p>
-            <a:pPr algn="l">
-              <a:spcAft>
-                <a:spcPts val="419"/>
-              </a:spcAft>
-              <a:defRPr sz="2100" b="0">
-                <a:solidFill>
-                  <a:srgbClr val="F5F0EB"/>
-                </a:solidFill>
-                <a:latin typeface="Arial"/>
-              </a:defRPr>
-            </a:pPr>
-          </a:p>
-          <a:p>
-            <a:pPr algn="l">
-              <a:spcAft>
-                <a:spcPts val="419"/>
-              </a:spcAft>
-              <a:defRPr sz="2100" b="0">
-                <a:solidFill>
-                  <a:srgbClr val="F5F0EB"/>
-                </a:solidFill>
-                <a:latin typeface="Arial"/>
-              </a:defRPr>
-            </a:pPr>
-            <a:r>
-              <a:t>モクシーへの身体的・精神的虐待</a:t>
-            </a:r>
-          </a:p>
-          <a:p>
-            <a:pPr algn="l">
-              <a:spcAft>
-                <a:spcPts val="419"/>
-              </a:spcAft>
-              <a:defRPr sz="2100" b="0">
-                <a:solidFill>
-                  <a:srgbClr val="F5F0EB"/>
-                </a:solidFill>
-                <a:latin typeface="Arial"/>
-              </a:defRPr>
-            </a:pPr>
-          </a:p>
-          <a:p>
-            <a:pPr algn="l">
-              <a:spcAft>
-                <a:spcPts val="419"/>
-              </a:spcAft>
-              <a:defRPr sz="2100" b="0">
-                <a:solidFill>
-                  <a:srgbClr val="F5F0EB"/>
-                </a:solidFill>
-                <a:latin typeface="Arial"/>
-              </a:defRPr>
-            </a:pPr>
-            <a:r>
-              <a:t>組織のためなら息子すら駒として使う冷徹さ</a:t>
-            </a:r>
-          </a:p>
-          <a:p>
-            <a:pPr algn="l">
-              <a:spcAft>
-                <a:spcPts val="419"/>
-              </a:spcAft>
-              <a:defRPr sz="2100" b="0">
-                <a:solidFill>
-                  <a:srgbClr val="F5F0EB"/>
-                </a:solidFill>
-                <a:latin typeface="Arial"/>
-              </a:defRPr>
-            </a:pPr>
-          </a:p>
-          <a:p>
-            <a:pPr algn="l">
-              <a:spcAft>
-                <a:spcPts val="419"/>
-              </a:spcAft>
-              <a:defRPr sz="2100" b="0">
-                <a:solidFill>
-                  <a:srgbClr val="F5F0EB"/>
-                </a:solidFill>
-                <a:latin typeface="Arial"/>
-              </a:defRPr>
-            </a:pPr>
-            <a:r>
-              <a:t>Fizzarolliを人質にし、七つの大罪の一柱</a:t>
-            </a:r>
-          </a:p>
-          <a:p>
-            <a:pPr algn="l">
-              <a:spcAft>
-                <a:spcPts val="419"/>
-              </a:spcAft>
-              <a:defRPr sz="2100" b="0">
-                <a:solidFill>
-                  <a:srgbClr val="F5F0EB"/>
-                </a:solidFill>
-                <a:latin typeface="Arial"/>
-              </a:defRPr>
-            </a:pPr>
-            <a:r>
-              <a:t>Asmoデウスすら脅迫する豪胆さ</a:t>
-            </a:r>
-          </a:p>
-        </p:txBody>
-      </p:sp>
-    </p:spTree>
-  </p:cSld>
-  <p:clrMapOvr>
-    <a:masterClrMapping/>
-  </p:clrMapOvr>
-</p:sld>
-</file>
-
-<file path=ppt/slides/slide9.xml><?xml version="1.0" encoding="utf-8"?>
-<p:sld xmlns:a="http://schemas.openxmlformats.org/drawingml/2006/main" xmlns:p="http://schemas.openxmlformats.org/presentationml/2006/main" xmlns:r="http://schemas.openxmlformats.org/officeDocument/2006/relationships">
-  <p:cSld>
-    <p:bg>
-      <p:bgPr>
-        <a:solidFill>
-          <a:srgbClr val="0F0A0A"/>
-        </a:solidFill>
-        <a:effectLst/>
-      </p:bgPr>
-    </p:bg>
-    <p:spTree>
-      <p:nvGrpSpPr>
-        <p:cNvPr id="1" name=""/>
-        <p:cNvGrpSpPr/>
-        <p:nvPr/>
-      </p:nvGrpSpPr>
-      <p:grpSpPr/>
-      <p:sp>
-        <p:nvSpPr>
-          <p:cNvPr id="2" name="Rectangle 1"/>
-          <p:cNvSpPr/>
-          <p:nvPr/>
-        </p:nvSpPr>
-        <p:spPr>
-          <a:xfrm>
-            <a:off x="0" y="0"/>
-            <a:ext cx="12191695" cy="1097280"/>
-          </a:xfrm>
-          <a:prstGeom prst="rect">
-            <a:avLst/>
-          </a:prstGeom>
-          <a:solidFill>
-            <a:srgbClr val="640F0F"/>
-          </a:solidFill>
-          <a:ln>
-            <a:noFill/>
-          </a:ln>
-        </p:spPr>
-        <p:style>
-          <a:lnRef idx="1">
-            <a:schemeClr val="accent1"/>
-          </a:lnRef>
-          <a:fillRef idx="3">
-            <a:schemeClr val="accent1"/>
-          </a:fillRef>
-          <a:effectRef idx="2">
-            <a:schemeClr val="accent1"/>
-          </a:effectRef>
-          <a:fontRef idx="minor">
-            <a:schemeClr val="lt1"/>
-          </a:fontRef>
-        </p:style>
-        <p:txBody>
-          <a:bodyPr rtlCol="0" anchor="ctr"/>
-          <a:lstStyle/>
-          <a:p>
-            <a:pPr algn="ctr"/>
-          </a:p>
-        </p:txBody>
-      </p:sp>
-      <p:sp>
-        <p:nvSpPr>
-          <p:cNvPr id="3" name="TextBox 2"/>
-          <p:cNvSpPr txBox="1"/>
-          <p:nvPr/>
-        </p:nvSpPr>
-        <p:spPr>
-          <a:xfrm>
-            <a:off x="457200" y="137160"/>
-            <a:ext cx="10972800" cy="822960"/>
-          </a:xfrm>
-          <a:prstGeom prst="rect">
-            <a:avLst/>
-          </a:prstGeom>
-          <a:noFill/>
-        </p:spPr>
-        <p:txBody>
-          <a:bodyPr wrap="square">
-            <a:spAutoFit/>
-          </a:bodyPr>
-          <a:lstStyle/>
-          <a:p>
-            <a:pPr algn="ctr">
-              <a:defRPr sz="4200" b="1">
-                <a:solidFill>
-                  <a:srgbClr val="F5F0EB"/>
-                </a:solidFill>
-                <a:latin typeface="Arial"/>
-              </a:defRPr>
-            </a:pPr>
-            <a:r>
-              <a:t>KEY EPISODES</a:t>
-            </a:r>
-          </a:p>
-        </p:txBody>
-      </p:sp>
-      <p:sp>
-        <p:nvSpPr>
-          <p:cNvPr id="4" name="Rectangle 3"/>
-          <p:cNvSpPr/>
-          <p:nvPr/>
-        </p:nvSpPr>
-        <p:spPr>
-          <a:xfrm>
-            <a:off x="457200" y="1097280"/>
-            <a:ext cx="11277295" cy="36576"/>
-          </a:xfrm>
-          <a:prstGeom prst="rect">
-            <a:avLst/>
-          </a:prstGeom>
-          <a:solidFill>
-            <a:srgbClr val="D4AF37"/>
-          </a:solidFill>
-          <a:ln>
-            <a:noFill/>
-          </a:ln>
-        </p:spPr>
-        <p:style>
-          <a:lnRef idx="1">
-            <a:schemeClr val="accent1"/>
-          </a:lnRef>
-          <a:fillRef idx="3">
-            <a:schemeClr val="accent1"/>
-          </a:fillRef>
-          <a:effectRef idx="2">
-            <a:schemeClr val="accent1"/>
-          </a:effectRef>
-          <a:fontRef idx="minor">
-            <a:schemeClr val="lt1"/>
-          </a:fontRef>
-        </p:style>
-        <p:txBody>
-          <a:bodyPr rtlCol="0" anchor="ctr"/>
-          <a:lstStyle/>
-          <a:p>
-            <a:pPr algn="ctr"/>
-          </a:p>
-        </p:txBody>
-      </p:sp>
       <p:pic>
         <p:nvPicPr>
           <p:cNvPr id="5" name="Picture 4" descr="crimson-5.JPG"/>
@@ -6853,7 +6607,7 @@
         </p:blipFill>
         <p:spPr>
           <a:xfrm>
-            <a:off x="7772400" y="1645920"/>
+            <a:off x="731520" y="1828800"/>
             <a:ext cx="4114800" cy="4114800"/>
           </a:xfrm>
           <a:prstGeom prst="rect">
@@ -6869,8 +6623,8 @@
         </p:nvSpPr>
         <p:spPr>
           <a:xfrm>
-            <a:off x="731520" y="1463040"/>
-            <a:ext cx="6400800" cy="548640"/>
+            <a:off x="5029200" y="1645920"/>
+            <a:ext cx="6675120" cy="640080"/>
           </a:xfrm>
           <a:prstGeom prst="rect">
             <a:avLst/>
@@ -6892,7 +6646,7 @@
               </a:defRPr>
             </a:pPr>
             <a:r>
-              <a:t>Exes and Oohs  (S2E6)</a:t>
+              <a:t>Exes and Oohs（S2E6）</a:t>
             </a:r>
           </a:p>
         </p:txBody>
@@ -6905,8 +6659,8 @@
         </p:nvSpPr>
         <p:spPr>
           <a:xfrm>
-            <a:off x="731520" y="1965960"/>
-            <a:ext cx="6400800" cy="822960"/>
+            <a:off x="5029200" y="2194560"/>
+            <a:ext cx="6675120" cy="822960"/>
           </a:xfrm>
           <a:prstGeom prst="rect">
             <a:avLst/>
@@ -6922,17 +6676,13 @@
             <a:pPr algn="l">
               <a:defRPr sz="1700" b="0">
                 <a:solidFill>
-                  <a:srgbClr val="B4AFAA"/>
-                </a:solidFill>
-                <a:latin typeface="Arial"/>
-              </a:defRPr>
-            </a:pPr>
-            <a:r>
-              <a:t>初登場。モクシーをチャズと</a:t>
-            </a:r>
-            <a:br/>
-            <a:r>
-              <a:t>政略結婚させようと画策。</a:t>
+                  <a:srgbClr val="BEB9B4"/>
+                </a:solidFill>
+                <a:latin typeface="Arial"/>
+              </a:defRPr>
+            </a:pPr>
+            <a:r>
+              <a:t>初登場。モクシーをチャズと政略結婚させようと画策する。</a:t>
             </a:r>
           </a:p>
         </p:txBody>
@@ -6945,8 +6695,8 @@
         </p:nvSpPr>
         <p:spPr>
           <a:xfrm>
-            <a:off x="731520" y="2926080"/>
-            <a:ext cx="6400800" cy="548640"/>
+            <a:off x="5029200" y="3200400"/>
+            <a:ext cx="6675120" cy="640080"/>
           </a:xfrm>
           <a:prstGeom prst="rect">
             <a:avLst/>
@@ -6968,7 +6718,7 @@
               </a:defRPr>
             </a:pPr>
             <a:r>
-              <a:t>Oops  (S2E7)</a:t>
+              <a:t>Oops（S2E7）</a:t>
             </a:r>
           </a:p>
         </p:txBody>
@@ -6981,8 +6731,8 @@
         </p:nvSpPr>
         <p:spPr>
           <a:xfrm>
-            <a:off x="731520" y="3429000"/>
-            <a:ext cx="6400800" cy="822960"/>
+            <a:off x="5029200" y="3749039"/>
+            <a:ext cx="6675120" cy="822960"/>
           </a:xfrm>
           <a:prstGeom prst="rect">
             <a:avLst/>
@@ -6998,17 +6748,17 @@
             <a:pPr algn="l">
               <a:defRPr sz="1700" b="0">
                 <a:solidFill>
-                  <a:srgbClr val="B4AFAA"/>
-                </a:solidFill>
-                <a:latin typeface="Arial"/>
-              </a:defRPr>
-            </a:pPr>
-            <a:r>
-              <a:t>Strikerを雇い、Fizzarolliを</a:t>
+                  <a:srgbClr val="BEB9B4"/>
+                </a:solidFill>
+                <a:latin typeface="Arial"/>
+              </a:defRPr>
+            </a:pPr>
+            <a:r>
+              <a:t>ストライカーを雇い、フィズロリを人質にして</a:t>
             </a:r>
             <a:br/>
             <a:r>
-              <a:t>人質にしてAsmodeusを脅迫。</a:t>
+              <a:t>アスモデウスを脅迫する。</a:t>
             </a:r>
           </a:p>
         </p:txBody>
@@ -7021,8 +6771,8 @@
         </p:nvSpPr>
         <p:spPr>
           <a:xfrm>
-            <a:off x="731520" y="4389120"/>
-            <a:ext cx="6400800" cy="548640"/>
+            <a:off x="5029200" y="4754880"/>
+            <a:ext cx="6675120" cy="640080"/>
           </a:xfrm>
           <a:prstGeom prst="rect">
             <a:avLst/>
@@ -7061,8 +6811,8 @@
         </p:nvSpPr>
         <p:spPr>
           <a:xfrm>
-            <a:off x="731520" y="4892040"/>
-            <a:ext cx="6400800" cy="822960"/>
+            <a:off x="5029200" y="5303520"/>
+            <a:ext cx="6675120" cy="822960"/>
           </a:xfrm>
           <a:prstGeom prst="rect">
             <a:avLst/>
@@ -7078,7 +6828,7 @@
             <a:pPr algn="l">
               <a:defRPr sz="1700" b="0">
                 <a:solidFill>
-                  <a:srgbClr val="B4AFAA"/>
+                  <a:srgbClr val="BEB9B4"/>
                 </a:solidFill>
                 <a:latin typeface="Arial"/>
               </a:defRPr>

</xml_diff>

<commit_message>
Fix slides 3, 4, 8: one image per slide, readable text
- スライド3（外見）: 透過PNG用に暗い背景パネルを敷き、テキスト位置を右にずらして重なり解消
- スライド4（性格）: 背景画像方式→画像右+テキスト左レイアウトに変更
- スライド8（DARK SIDE）: 同様に画像左+テキスト右レイアウトに変更
- darken_image関数を削除（不要になったため）

https://claude.ai/code/session_01Pt9LYytkm79mcRSuRrKMQn
</commit_message>
<xml_diff>
--- a/crimson_presentation.pptx
+++ b/crimson_presentation.pptx
@@ -4412,7 +4412,7 @@
     <p:bg>
       <p:bgPr>
         <a:solidFill>
-          <a:srgbClr val="120F14"/>
+          <a:srgbClr val="120C0C"/>
         </a:solidFill>
         <a:effectLst/>
       </p:bgPr>
@@ -4546,9 +4546,52 @@
           </a:p>
         </p:txBody>
       </p:sp>
+      <p:sp>
+        <p:nvSpPr>
+          <p:cNvPr id="5" name="Rectangle 4"/>
+          <p:cNvSpPr/>
+          <p:nvPr/>
+        </p:nvSpPr>
+        <p:spPr>
+          <a:xfrm>
+            <a:off x="274320" y="1371600"/>
+            <a:ext cx="5029200" cy="5212080"/>
+          </a:xfrm>
+          <a:prstGeom prst="rect">
+            <a:avLst/>
+          </a:prstGeom>
+          <a:solidFill>
+            <a:srgbClr val="120C0C"/>
+          </a:solidFill>
+          <a:ln>
+            <a:noFill/>
+          </a:ln>
+        </p:spPr>
+        <p:style>
+          <a:lnRef idx="1">
+            <a:schemeClr val="accent1"/>
+          </a:lnRef>
+          <a:fillRef idx="3">
+            <a:schemeClr val="accent1"/>
+          </a:fillRef>
+          <a:effectRef idx="2">
+            <a:schemeClr val="accent1"/>
+          </a:effectRef>
+          <a:fontRef idx="minor">
+            <a:schemeClr val="lt1"/>
+          </a:fontRef>
+        </p:style>
+        <p:txBody>
+          <a:bodyPr rtlCol="0" anchor="ctr"/>
+          <a:lstStyle/>
+          <a:p>
+            <a:pPr algn="ctr"/>
+          </a:p>
+        </p:txBody>
+      </p:sp>
       <p:pic>
         <p:nvPicPr>
-          <p:cNvPr id="5" name="Picture 4" descr="crimson-3.PNG"/>
+          <p:cNvPr id="6" name="Picture 5" descr="crimson-3.PNG"/>
           <p:cNvPicPr>
             <a:picLocks noChangeAspect="1"/>
           </p:cNvPicPr>
@@ -4572,14 +4615,14 @@
       </p:pic>
       <p:sp>
         <p:nvSpPr>
-          <p:cNvPr id="6" name="TextBox 5"/>
+          <p:cNvPr id="7" name="TextBox 6"/>
           <p:cNvSpPr txBox="1"/>
           <p:nvPr/>
         </p:nvSpPr>
         <p:spPr>
           <a:xfrm>
-            <a:off x="5943600" y="1645920"/>
-            <a:ext cx="5760720" cy="4572000"/>
+            <a:off x="6217920" y="1645920"/>
+            <a:ext cx="5486400" cy="4572000"/>
           </a:xfrm>
           <a:prstGeom prst="rect">
             <a:avLst/>
@@ -4719,7 +4762,7 @@
     <p:bg>
       <p:bgPr>
         <a:solidFill>
-          <a:srgbClr val="0A0606"/>
+          <a:srgbClr val="120C0C"/>
         </a:solidFill>
         <a:effectLst/>
       </p:bgPr>
@@ -4731,9 +4774,131 @@
         <p:nvPr/>
       </p:nvGrpSpPr>
       <p:grpSpPr/>
+      <p:sp>
+        <p:nvSpPr>
+          <p:cNvPr id="2" name="Rectangle 1"/>
+          <p:cNvSpPr/>
+          <p:nvPr/>
+        </p:nvSpPr>
+        <p:spPr>
+          <a:xfrm>
+            <a:off x="0" y="0"/>
+            <a:ext cx="12191695" cy="1097280"/>
+          </a:xfrm>
+          <a:prstGeom prst="rect">
+            <a:avLst/>
+          </a:prstGeom>
+          <a:solidFill>
+            <a:srgbClr val="640F0F"/>
+          </a:solidFill>
+          <a:ln>
+            <a:noFill/>
+          </a:ln>
+        </p:spPr>
+        <p:style>
+          <a:lnRef idx="1">
+            <a:schemeClr val="accent1"/>
+          </a:lnRef>
+          <a:fillRef idx="3">
+            <a:schemeClr val="accent1"/>
+          </a:fillRef>
+          <a:effectRef idx="2">
+            <a:schemeClr val="accent1"/>
+          </a:effectRef>
+          <a:fontRef idx="minor">
+            <a:schemeClr val="lt1"/>
+          </a:fontRef>
+        </p:style>
+        <p:txBody>
+          <a:bodyPr rtlCol="0" anchor="ctr"/>
+          <a:lstStyle/>
+          <a:p>
+            <a:pPr algn="ctr"/>
+          </a:p>
+        </p:txBody>
+      </p:sp>
+      <p:sp>
+        <p:nvSpPr>
+          <p:cNvPr id="3" name="TextBox 2"/>
+          <p:cNvSpPr txBox="1"/>
+          <p:nvPr/>
+        </p:nvSpPr>
+        <p:spPr>
+          <a:xfrm>
+            <a:off x="457200" y="137160"/>
+            <a:ext cx="10972800" cy="822960"/>
+          </a:xfrm>
+          <a:prstGeom prst="rect">
+            <a:avLst/>
+          </a:prstGeom>
+          <a:noFill/>
+        </p:spPr>
+        <p:txBody>
+          <a:bodyPr wrap="square">
+            <a:spAutoFit/>
+          </a:bodyPr>
+          <a:lstStyle/>
+          <a:p>
+            <a:pPr algn="ctr">
+              <a:defRPr sz="4200" b="1">
+                <a:solidFill>
+                  <a:srgbClr val="F5F0EB"/>
+                </a:solidFill>
+                <a:latin typeface="Arial"/>
+              </a:defRPr>
+            </a:pPr>
+            <a:r>
+              <a:t>性格</a:t>
+            </a:r>
+          </a:p>
+        </p:txBody>
+      </p:sp>
+      <p:sp>
+        <p:nvSpPr>
+          <p:cNvPr id="4" name="Rectangle 3"/>
+          <p:cNvSpPr/>
+          <p:nvPr/>
+        </p:nvSpPr>
+        <p:spPr>
+          <a:xfrm>
+            <a:off x="457200" y="1097280"/>
+            <a:ext cx="11277295" cy="36576"/>
+          </a:xfrm>
+          <a:prstGeom prst="rect">
+            <a:avLst/>
+          </a:prstGeom>
+          <a:solidFill>
+            <a:srgbClr val="D4AF37"/>
+          </a:solidFill>
+          <a:ln>
+            <a:noFill/>
+          </a:ln>
+        </p:spPr>
+        <p:style>
+          <a:lnRef idx="1">
+            <a:schemeClr val="accent1"/>
+          </a:lnRef>
+          <a:fillRef idx="3">
+            <a:schemeClr val="accent1"/>
+          </a:fillRef>
+          <a:effectRef idx="2">
+            <a:schemeClr val="accent1"/>
+          </a:effectRef>
+          <a:fontRef idx="minor">
+            <a:schemeClr val="lt1"/>
+          </a:fontRef>
+        </p:style>
+        <p:txBody>
+          <a:bodyPr rtlCol="0" anchor="ctr"/>
+          <a:lstStyle/>
+          <a:p>
+            <a:pPr algn="ctr"/>
+          </a:p>
+        </p:txBody>
+      </p:sp>
       <p:pic>
         <p:nvPicPr>
-          <p:cNvPr id="2" name="Picture 1" descr="_dark_crimson7.jpg"/>
+          <p:cNvPr id="5" name="Picture 4" descr="crimson-7.JPG"/>
           <p:cNvPicPr>
             <a:picLocks noChangeAspect="1"/>
           </p:cNvPicPr>
@@ -4747,8 +4912,8 @@
         </p:blipFill>
         <p:spPr>
           <a:xfrm>
-            <a:off x="0" y="0"/>
-            <a:ext cx="12191695" cy="12191695"/>
+            <a:off x="7315200" y="1645920"/>
+            <a:ext cx="4572000" cy="4572000"/>
           </a:xfrm>
           <a:prstGeom prst="rect">
             <a:avLst/>
@@ -4757,14 +4922,14 @@
       </p:pic>
       <p:sp>
         <p:nvSpPr>
-          <p:cNvPr id="3" name="TextBox 2"/>
+          <p:cNvPr id="6" name="TextBox 5"/>
           <p:cNvSpPr txBox="1"/>
           <p:nvPr/>
         </p:nvSpPr>
         <p:spPr>
           <a:xfrm>
-            <a:off x="457200" y="365760"/>
-            <a:ext cx="10972800" cy="914400"/>
+            <a:off x="731520" y="1828800"/>
+            <a:ext cx="6217920" cy="4572000"/>
           </a:xfrm>
           <a:prstGeom prst="rect">
             <a:avLst/>
@@ -4777,90 +4942,11 @@
           </a:bodyPr>
           <a:lstStyle/>
           <a:p>
-            <a:pPr algn="ctr">
-              <a:defRPr sz="4800" b="1">
-                <a:solidFill>
-                  <a:srgbClr val="B41E1E"/>
-                </a:solidFill>
-                <a:latin typeface="Arial"/>
-              </a:defRPr>
-            </a:pPr>
-            <a:r>
-              <a:t>性格</a:t>
-            </a:r>
-          </a:p>
-        </p:txBody>
-      </p:sp>
-      <p:sp>
-        <p:nvSpPr>
-          <p:cNvPr id="4" name="Rectangle 3"/>
-          <p:cNvSpPr/>
-          <p:nvPr/>
-        </p:nvSpPr>
-        <p:spPr>
-          <a:xfrm>
-            <a:off x="457200" y="1188720"/>
-            <a:ext cx="4572000" cy="36576"/>
-          </a:xfrm>
-          <a:prstGeom prst="rect">
-            <a:avLst/>
-          </a:prstGeom>
-          <a:solidFill>
-            <a:srgbClr val="D4AF37"/>
-          </a:solidFill>
-          <a:ln>
-            <a:noFill/>
-          </a:ln>
-        </p:spPr>
-        <p:style>
-          <a:lnRef idx="1">
-            <a:schemeClr val="accent1"/>
-          </a:lnRef>
-          <a:fillRef idx="3">
-            <a:schemeClr val="accent1"/>
-          </a:fillRef>
-          <a:effectRef idx="2">
-            <a:schemeClr val="accent1"/>
-          </a:effectRef>
-          <a:fontRef idx="minor">
-            <a:schemeClr val="lt1"/>
-          </a:fontRef>
-        </p:style>
-        <p:txBody>
-          <a:bodyPr rtlCol="0" anchor="ctr"/>
-          <a:lstStyle/>
-          <a:p>
-            <a:pPr algn="ctr"/>
-          </a:p>
-        </p:txBody>
-      </p:sp>
-      <p:sp>
-        <p:nvSpPr>
-          <p:cNvPr id="5" name="TextBox 4"/>
-          <p:cNvSpPr txBox="1"/>
-          <p:nvPr/>
-        </p:nvSpPr>
-        <p:spPr>
-          <a:xfrm>
-            <a:off x="731520" y="1645920"/>
-            <a:ext cx="6858000" cy="4572000"/>
-          </a:xfrm>
-          <a:prstGeom prst="rect">
-            <a:avLst/>
-          </a:prstGeom>
-          <a:noFill/>
-        </p:spPr>
-        <p:txBody>
-          <a:bodyPr wrap="square">
-            <a:spAutoFit/>
-          </a:bodyPr>
-          <a:lstStyle/>
-          <a:p>
             <a:pPr algn="l">
               <a:spcAft>
-                <a:spcPts val="1200"/>
+                <a:spcPts val="1100"/>
               </a:spcAft>
-              <a:defRPr sz="2400" b="1">
+              <a:defRPr sz="2200" b="1">
                 <a:solidFill>
                   <a:srgbClr val="F5F0EB"/>
                 </a:solidFill>
@@ -4874,9 +4960,9 @@
           <a:p>
             <a:pPr algn="l">
               <a:spcAft>
-                <a:spcPts val="1200"/>
+                <a:spcPts val="1100"/>
               </a:spcAft>
-              <a:defRPr sz="2400" b="1">
+              <a:defRPr sz="2200" b="1">
                 <a:solidFill>
                   <a:srgbClr val="F5F0EB"/>
                 </a:solidFill>
@@ -4890,9 +4976,9 @@
           <a:p>
             <a:pPr algn="l">
               <a:spcAft>
-                <a:spcPts val="1200"/>
+                <a:spcPts val="1100"/>
               </a:spcAft>
-              <a:defRPr sz="2400" b="1">
+              <a:defRPr sz="2200" b="1">
                 <a:solidFill>
                   <a:srgbClr val="F5F0EB"/>
                 </a:solidFill>
@@ -4900,15 +4986,15 @@
               </a:defRPr>
             </a:pPr>
             <a:r>
-              <a:t>◆ しかし必要な時には魅力的で温厚な顔も見せる</a:t>
+              <a:t>◆ 必要な時には魅力的で温厚な顔も見せる</a:t>
             </a:r>
           </a:p>
           <a:p>
             <a:pPr algn="l">
               <a:spcAft>
-                <a:spcPts val="1200"/>
+                <a:spcPts val="1100"/>
               </a:spcAft>
-              <a:defRPr sz="2400" b="1">
+              <a:defRPr sz="2200" b="1">
                 <a:solidFill>
                   <a:srgbClr val="F5F0EB"/>
                 </a:solidFill>
@@ -4922,9 +5008,9 @@
           <a:p>
             <a:pPr algn="l">
               <a:spcAft>
-                <a:spcPts val="1200"/>
+                <a:spcPts val="1100"/>
               </a:spcAft>
-              <a:defRPr sz="2400" b="1">
+              <a:defRPr sz="2200" b="1">
                 <a:solidFill>
                   <a:srgbClr val="F5F0EB"/>
                 </a:solidFill>
@@ -4938,9 +5024,9 @@
           <a:p>
             <a:pPr algn="l">
               <a:spcAft>
-                <a:spcPts val="1200"/>
+                <a:spcPts val="1100"/>
               </a:spcAft>
-              <a:defRPr sz="2400" b="1">
+              <a:defRPr sz="2200" b="1">
                 <a:solidFill>
                   <a:srgbClr val="F5F0EB"/>
                 </a:solidFill>
@@ -6186,7 +6272,7 @@
     <p:bg>
       <p:bgPr>
         <a:solidFill>
-          <a:srgbClr val="080505"/>
+          <a:srgbClr val="120C0C"/>
         </a:solidFill>
         <a:effectLst/>
       </p:bgPr>
@@ -6198,9 +6284,131 @@
         <p:nvPr/>
       </p:nvGrpSpPr>
       <p:grpSpPr/>
+      <p:sp>
+        <p:nvSpPr>
+          <p:cNvPr id="2" name="Rectangle 1"/>
+          <p:cNvSpPr/>
+          <p:nvPr/>
+        </p:nvSpPr>
+        <p:spPr>
+          <a:xfrm>
+            <a:off x="0" y="0"/>
+            <a:ext cx="12191695" cy="1097280"/>
+          </a:xfrm>
+          <a:prstGeom prst="rect">
+            <a:avLst/>
+          </a:prstGeom>
+          <a:solidFill>
+            <a:srgbClr val="640F0F"/>
+          </a:solidFill>
+          <a:ln>
+            <a:noFill/>
+          </a:ln>
+        </p:spPr>
+        <p:style>
+          <a:lnRef idx="1">
+            <a:schemeClr val="accent1"/>
+          </a:lnRef>
+          <a:fillRef idx="3">
+            <a:schemeClr val="accent1"/>
+          </a:fillRef>
+          <a:effectRef idx="2">
+            <a:schemeClr val="accent1"/>
+          </a:effectRef>
+          <a:fontRef idx="minor">
+            <a:schemeClr val="lt1"/>
+          </a:fontRef>
+        </p:style>
+        <p:txBody>
+          <a:bodyPr rtlCol="0" anchor="ctr"/>
+          <a:lstStyle/>
+          <a:p>
+            <a:pPr algn="ctr"/>
+          </a:p>
+        </p:txBody>
+      </p:sp>
+      <p:sp>
+        <p:nvSpPr>
+          <p:cNvPr id="3" name="TextBox 2"/>
+          <p:cNvSpPr txBox="1"/>
+          <p:nvPr/>
+        </p:nvSpPr>
+        <p:spPr>
+          <a:xfrm>
+            <a:off x="457200" y="137160"/>
+            <a:ext cx="10972800" cy="822960"/>
+          </a:xfrm>
+          <a:prstGeom prst="rect">
+            <a:avLst/>
+          </a:prstGeom>
+          <a:noFill/>
+        </p:spPr>
+        <p:txBody>
+          <a:bodyPr wrap="square">
+            <a:spAutoFit/>
+          </a:bodyPr>
+          <a:lstStyle/>
+          <a:p>
+            <a:pPr algn="ctr">
+              <a:defRPr sz="4200" b="1">
+                <a:solidFill>
+                  <a:srgbClr val="F5F0EB"/>
+                </a:solidFill>
+                <a:latin typeface="Arial"/>
+              </a:defRPr>
+            </a:pPr>
+            <a:r>
+              <a:t>THE DARK SIDE</a:t>
+            </a:r>
+          </a:p>
+        </p:txBody>
+      </p:sp>
+      <p:sp>
+        <p:nvSpPr>
+          <p:cNvPr id="4" name="Rectangle 3"/>
+          <p:cNvSpPr/>
+          <p:nvPr/>
+        </p:nvSpPr>
+        <p:spPr>
+          <a:xfrm>
+            <a:off x="457200" y="1097280"/>
+            <a:ext cx="11277295" cy="36576"/>
+          </a:xfrm>
+          <a:prstGeom prst="rect">
+            <a:avLst/>
+          </a:prstGeom>
+          <a:solidFill>
+            <a:srgbClr val="D4AF37"/>
+          </a:solidFill>
+          <a:ln>
+            <a:noFill/>
+          </a:ln>
+        </p:spPr>
+        <p:style>
+          <a:lnRef idx="1">
+            <a:schemeClr val="accent1"/>
+          </a:lnRef>
+          <a:fillRef idx="3">
+            <a:schemeClr val="accent1"/>
+          </a:fillRef>
+          <a:effectRef idx="2">
+            <a:schemeClr val="accent1"/>
+          </a:effectRef>
+          <a:fontRef idx="minor">
+            <a:schemeClr val="lt1"/>
+          </a:fontRef>
+        </p:style>
+        <p:txBody>
+          <a:bodyPr rtlCol="0" anchor="ctr"/>
+          <a:lstStyle/>
+          <a:p>
+            <a:pPr algn="ctr"/>
+          </a:p>
+        </p:txBody>
+      </p:sp>
       <p:pic>
         <p:nvPicPr>
-          <p:cNvPr id="2" name="Picture 1" descr="_dark_crimson9.jpg"/>
+          <p:cNvPr id="5" name="Picture 4" descr="crimson-9.JPG"/>
           <p:cNvPicPr>
             <a:picLocks noChangeAspect="1"/>
           </p:cNvPicPr>
@@ -6214,8 +6422,8 @@
         </p:blipFill>
         <p:spPr>
           <a:xfrm>
-            <a:off x="0" y="0"/>
-            <a:ext cx="12191695" cy="7141271"/>
+            <a:off x="457200" y="1645920"/>
+            <a:ext cx="7805394" cy="4572000"/>
           </a:xfrm>
           <a:prstGeom prst="rect">
             <a:avLst/>
@@ -6224,14 +6432,14 @@
       </p:pic>
       <p:sp>
         <p:nvSpPr>
-          <p:cNvPr id="3" name="TextBox 2"/>
+          <p:cNvPr id="6" name="TextBox 5"/>
           <p:cNvSpPr txBox="1"/>
           <p:nvPr/>
         </p:nvSpPr>
         <p:spPr>
           <a:xfrm>
-            <a:off x="457200" y="274320"/>
-            <a:ext cx="10972800" cy="914400"/>
+            <a:off x="5943600" y="1645920"/>
+            <a:ext cx="5760720" cy="5029200"/>
           </a:xfrm>
           <a:prstGeom prst="rect">
             <a:avLst/>
@@ -6244,90 +6452,11 @@
           </a:bodyPr>
           <a:lstStyle/>
           <a:p>
-            <a:pPr algn="ctr">
-              <a:defRPr sz="4800" b="1">
-                <a:solidFill>
-                  <a:srgbClr val="B41E1E"/>
-                </a:solidFill>
-                <a:latin typeface="Arial"/>
-              </a:defRPr>
-            </a:pPr>
-            <a:r>
-              <a:t>THE DARK SIDE</a:t>
-            </a:r>
-          </a:p>
-        </p:txBody>
-      </p:sp>
-      <p:sp>
-        <p:nvSpPr>
-          <p:cNvPr id="4" name="Rectangle 3"/>
-          <p:cNvSpPr/>
-          <p:nvPr/>
-        </p:nvSpPr>
-        <p:spPr>
-          <a:xfrm>
-            <a:off x="457200" y="1097280"/>
-            <a:ext cx="4572000" cy="36576"/>
-          </a:xfrm>
-          <a:prstGeom prst="rect">
-            <a:avLst/>
-          </a:prstGeom>
-          <a:solidFill>
-            <a:srgbClr val="D4AF37"/>
-          </a:solidFill>
-          <a:ln>
-            <a:noFill/>
-          </a:ln>
-        </p:spPr>
-        <p:style>
-          <a:lnRef idx="1">
-            <a:schemeClr val="accent1"/>
-          </a:lnRef>
-          <a:fillRef idx="3">
-            <a:schemeClr val="accent1"/>
-          </a:fillRef>
-          <a:effectRef idx="2">
-            <a:schemeClr val="accent1"/>
-          </a:effectRef>
-          <a:fontRef idx="minor">
-            <a:schemeClr val="lt1"/>
-          </a:fontRef>
-        </p:style>
-        <p:txBody>
-          <a:bodyPr rtlCol="0" anchor="ctr"/>
-          <a:lstStyle/>
-          <a:p>
-            <a:pPr algn="ctr"/>
-          </a:p>
-        </p:txBody>
-      </p:sp>
-      <p:sp>
-        <p:nvSpPr>
-          <p:cNvPr id="5" name="TextBox 4"/>
-          <p:cNvSpPr txBox="1"/>
-          <p:nvPr/>
-        </p:nvSpPr>
-        <p:spPr>
-          <a:xfrm>
-            <a:off x="731520" y="1463040"/>
-            <a:ext cx="7315200" cy="5029200"/>
-          </a:xfrm>
-          <a:prstGeom prst="rect">
-            <a:avLst/>
-          </a:prstGeom>
-          <a:noFill/>
-        </p:spPr>
-        <p:txBody>
-          <a:bodyPr wrap="square">
-            <a:spAutoFit/>
-          </a:bodyPr>
-          <a:lstStyle/>
-          <a:p>
             <a:pPr algn="l">
               <a:spcAft>
-                <a:spcPts val="439"/>
+                <a:spcPts val="210"/>
               </a:spcAft>
-              <a:defRPr sz="2200" b="1">
+              <a:defRPr sz="2100" b="1">
                 <a:solidFill>
                   <a:srgbClr val="F5F0EB"/>
                 </a:solidFill>
@@ -6335,34 +6464,50 @@
               </a:defRPr>
             </a:pPr>
             <a:r>
-              <a:t>◆ 妻を「息子の成長を阻害する存在」として排除した</a:t>
+              <a:t>◆ 妻を「息子の成長を阻害する存在」</a:t>
             </a:r>
           </a:p>
           <a:p>
             <a:pPr algn="l">
               <a:spcAft>
-                <a:spcPts val="439"/>
+                <a:spcPts val="210"/>
               </a:spcAft>
-              <a:defRPr sz="2200" b="1">
+              <a:defRPr sz="2100" b="1">
                 <a:solidFill>
                   <a:srgbClr val="F5F0EB"/>
                 </a:solidFill>
                 <a:latin typeface="Arial"/>
               </a:defRPr>
             </a:pPr>
+            <a:r>
+              <a:t>　 として排除した</a:t>
+            </a:r>
           </a:p>
           <a:p>
             <a:pPr algn="l">
               <a:spcAft>
-                <a:spcPts val="439"/>
+                <a:spcPts val="210"/>
               </a:spcAft>
-              <a:defRPr sz="2200" b="1">
+              <a:defRPr sz="2100" b="1">
                 <a:solidFill>
                   <a:srgbClr val="F5F0EB"/>
                 </a:solidFill>
                 <a:latin typeface="Arial"/>
               </a:defRPr>
             </a:pPr>
+          </a:p>
+          <a:p>
+            <a:pPr algn="l">
+              <a:spcAft>
+                <a:spcPts val="210"/>
+              </a:spcAft>
+              <a:defRPr sz="2100" b="1">
+                <a:solidFill>
+                  <a:srgbClr val="F5F0EB"/>
+                </a:solidFill>
+                <a:latin typeface="Arial"/>
+              </a:defRPr>
+            </a:pPr>
             <a:r>
               <a:t>◆ モクシーへの身体的・精神的虐待</a:t>
             </a:r>
@@ -6370,9 +6515,9 @@
           <a:p>
             <a:pPr algn="l">
               <a:spcAft>
-                <a:spcPts val="439"/>
+                <a:spcPts val="210"/>
               </a:spcAft>
-              <a:defRPr sz="2200" b="1">
+              <a:defRPr sz="2100" b="1">
                 <a:solidFill>
                   <a:srgbClr val="F5F0EB"/>
                 </a:solidFill>
@@ -6383,9 +6528,9 @@
           <a:p>
             <a:pPr algn="l">
               <a:spcAft>
-                <a:spcPts val="439"/>
+                <a:spcPts val="210"/>
               </a:spcAft>
-              <a:defRPr sz="2200" b="1">
+              <a:defRPr sz="2100" b="1">
                 <a:solidFill>
                   <a:srgbClr val="F5F0EB"/>
                 </a:solidFill>
@@ -6393,34 +6538,50 @@
               </a:defRPr>
             </a:pPr>
             <a:r>
-              <a:t>◆ 組織のためなら息子すら駒として使う冷徹さ</a:t>
+              <a:t>◆ 組織のためなら息子すら</a:t>
             </a:r>
           </a:p>
           <a:p>
             <a:pPr algn="l">
               <a:spcAft>
-                <a:spcPts val="439"/>
+                <a:spcPts val="210"/>
               </a:spcAft>
-              <a:defRPr sz="2200" b="1">
+              <a:defRPr sz="2100" b="1">
                 <a:solidFill>
                   <a:srgbClr val="F5F0EB"/>
                 </a:solidFill>
                 <a:latin typeface="Arial"/>
               </a:defRPr>
             </a:pPr>
+            <a:r>
+              <a:t>　 駒として使う冷徹さ</a:t>
+            </a:r>
           </a:p>
           <a:p>
             <a:pPr algn="l">
               <a:spcAft>
-                <a:spcPts val="439"/>
+                <a:spcPts val="210"/>
               </a:spcAft>
-              <a:defRPr sz="2200" b="1">
+              <a:defRPr sz="2100" b="1">
                 <a:solidFill>
                   <a:srgbClr val="F5F0EB"/>
                 </a:solidFill>
                 <a:latin typeface="Arial"/>
               </a:defRPr>
             </a:pPr>
+          </a:p>
+          <a:p>
+            <a:pPr algn="l">
+              <a:spcAft>
+                <a:spcPts val="210"/>
+              </a:spcAft>
+              <a:defRPr sz="2100" b="1">
+                <a:solidFill>
+                  <a:srgbClr val="F5F0EB"/>
+                </a:solidFill>
+                <a:latin typeface="Arial"/>
+              </a:defRPr>
+            </a:pPr>
             <a:r>
               <a:t>◆ フィズロリを人質にし、</a:t>
             </a:r>
@@ -6428,9 +6589,9 @@
           <a:p>
             <a:pPr algn="l">
               <a:spcAft>
-                <a:spcPts val="439"/>
+                <a:spcPts val="210"/>
               </a:spcAft>
-              <a:defRPr sz="2200" b="1">
+              <a:defRPr sz="2100" b="1">
                 <a:solidFill>
                   <a:srgbClr val="F5F0EB"/>
                 </a:solidFill>
@@ -6438,7 +6599,23 @@
               </a:defRPr>
             </a:pPr>
             <a:r>
-              <a:t>　 七つの大罪の一柱アスモデウスすら脅迫する豪胆さ</a:t>
+              <a:t>　 七つの大罪の一柱アスモデウス</a:t>
+            </a:r>
+          </a:p>
+          <a:p>
+            <a:pPr algn="l">
+              <a:spcAft>
+                <a:spcPts val="210"/>
+              </a:spcAft>
+              <a:defRPr sz="2100" b="1">
+                <a:solidFill>
+                  <a:srgbClr val="F5F0EB"/>
+                </a:solidFill>
+                <a:latin typeface="Arial"/>
+              </a:defRPr>
+            </a:pPr>
+            <a:r>
+              <a:t>　 すら脅迫する豪胆さ</a:t>
             </a:r>
           </a:p>
         </p:txBody>

</xml_diff>

<commit_message>
Fix layout: image positioning, text overlap across all slides
- スライド1: 画像を右側中央に配置、テキストを左側に移動
- スライド2: 画像サイズ縮小、テキスト間隔調整で重なり解消
- スライド6(能力): 画像位置を下げてヘッダー線との重なり解消
- スライド9(エピソード): 画像を右側に移動
- スライド10(WHY WE LOVE HIM): 画像を小さくし暗いパネル追加、
  テキスト開始位置を右にずらして重なり完全解消
- 全スライドで画像とテキストの配置領域を明確に分離

https://claude.ai/code/session_01Pt9LYytkm79mcRSuRrKMQn
</commit_message>
<xml_diff>
--- a/crimson_presentation.pptx
+++ b/crimson_presentation.pptx
@@ -3106,9 +3106,282 @@
         <p:nvPr/>
       </p:nvGrpSpPr>
       <p:grpSpPr/>
+      <p:sp>
+        <p:nvSpPr>
+          <p:cNvPr id="2" name="Rectangle 1"/>
+          <p:cNvSpPr/>
+          <p:nvPr/>
+        </p:nvSpPr>
+        <p:spPr>
+          <a:xfrm>
+            <a:off x="914400" y="1828800"/>
+            <a:ext cx="4572000" cy="36576"/>
+          </a:xfrm>
+          <a:prstGeom prst="rect">
+            <a:avLst/>
+          </a:prstGeom>
+          <a:solidFill>
+            <a:srgbClr val="D4AF37"/>
+          </a:solidFill>
+          <a:ln>
+            <a:noFill/>
+          </a:ln>
+        </p:spPr>
+        <p:style>
+          <a:lnRef idx="1">
+            <a:schemeClr val="accent1"/>
+          </a:lnRef>
+          <a:fillRef idx="3">
+            <a:schemeClr val="accent1"/>
+          </a:fillRef>
+          <a:effectRef idx="2">
+            <a:schemeClr val="accent1"/>
+          </a:effectRef>
+          <a:fontRef idx="minor">
+            <a:schemeClr val="lt1"/>
+          </a:fontRef>
+        </p:style>
+        <p:txBody>
+          <a:bodyPr rtlCol="0" anchor="ctr"/>
+          <a:lstStyle/>
+          <a:p>
+            <a:pPr algn="ctr"/>
+          </a:p>
+        </p:txBody>
+      </p:sp>
+      <p:sp>
+        <p:nvSpPr>
+          <p:cNvPr id="3" name="TextBox 2"/>
+          <p:cNvSpPr txBox="1"/>
+          <p:nvPr/>
+        </p:nvSpPr>
+        <p:spPr>
+          <a:xfrm>
+            <a:off x="914400" y="2103120"/>
+            <a:ext cx="5029200" cy="1371600"/>
+          </a:xfrm>
+          <a:prstGeom prst="rect">
+            <a:avLst/>
+          </a:prstGeom>
+          <a:noFill/>
+        </p:spPr>
+        <p:txBody>
+          <a:bodyPr wrap="square">
+            <a:spAutoFit/>
+          </a:bodyPr>
+          <a:lstStyle/>
+          <a:p>
+            <a:pPr algn="ctr">
+              <a:defRPr sz="7600" b="1">
+                <a:solidFill>
+                  <a:srgbClr val="B41E1E"/>
+                </a:solidFill>
+                <a:latin typeface="Arial"/>
+              </a:defRPr>
+            </a:pPr>
+            <a:r>
+              <a:t>CRIMSON</a:t>
+            </a:r>
+          </a:p>
+        </p:txBody>
+      </p:sp>
+      <p:sp>
+        <p:nvSpPr>
+          <p:cNvPr id="4" name="TextBox 3"/>
+          <p:cNvSpPr txBox="1"/>
+          <p:nvPr/>
+        </p:nvSpPr>
+        <p:spPr>
+          <a:xfrm>
+            <a:off x="914400" y="3383280"/>
+            <a:ext cx="5029200" cy="640080"/>
+          </a:xfrm>
+          <a:prstGeom prst="rect">
+            <a:avLst/>
+          </a:prstGeom>
+          <a:noFill/>
+        </p:spPr>
+        <p:txBody>
+          <a:bodyPr wrap="square">
+            <a:spAutoFit/>
+          </a:bodyPr>
+          <a:lstStyle/>
+          <a:p>
+            <a:pPr algn="ctr">
+              <a:defRPr sz="3600" b="0">
+                <a:solidFill>
+                  <a:srgbClr val="D4AF37"/>
+                </a:solidFill>
+                <a:latin typeface="Arial"/>
+              </a:defRPr>
+            </a:pPr>
+            <a:r>
+              <a:t>Knolastname</a:t>
+            </a:r>
+          </a:p>
+        </p:txBody>
+      </p:sp>
+      <p:sp>
+        <p:nvSpPr>
+          <p:cNvPr id="5" name="TextBox 4"/>
+          <p:cNvSpPr txBox="1"/>
+          <p:nvPr/>
+        </p:nvSpPr>
+        <p:spPr>
+          <a:xfrm>
+            <a:off x="914400" y="4114800"/>
+            <a:ext cx="5029200" cy="640080"/>
+          </a:xfrm>
+          <a:prstGeom prst="rect">
+            <a:avLst/>
+          </a:prstGeom>
+          <a:noFill/>
+        </p:spPr>
+        <p:txBody>
+          <a:bodyPr wrap="square">
+            <a:spAutoFit/>
+          </a:bodyPr>
+          <a:lstStyle/>
+          <a:p>
+            <a:pPr algn="ctr">
+              <a:defRPr sz="2000" b="0">
+                <a:solidFill>
+                  <a:srgbClr val="BEB9B4"/>
+                </a:solidFill>
+                <a:latin typeface="Arial"/>
+              </a:defRPr>
+            </a:pPr>
+            <a:r>
+              <a:t>Greed Ring's Most Feared Mafia Boss</a:t>
+            </a:r>
+          </a:p>
+        </p:txBody>
+      </p:sp>
+      <p:sp>
+        <p:nvSpPr>
+          <p:cNvPr id="6" name="Rectangle 5"/>
+          <p:cNvSpPr/>
+          <p:nvPr/>
+        </p:nvSpPr>
+        <p:spPr>
+          <a:xfrm>
+            <a:off x="914400" y="4937760"/>
+            <a:ext cx="4572000" cy="36576"/>
+          </a:xfrm>
+          <a:prstGeom prst="rect">
+            <a:avLst/>
+          </a:prstGeom>
+          <a:solidFill>
+            <a:srgbClr val="D4AF37"/>
+          </a:solidFill>
+          <a:ln>
+            <a:noFill/>
+          </a:ln>
+        </p:spPr>
+        <p:style>
+          <a:lnRef idx="1">
+            <a:schemeClr val="accent1"/>
+          </a:lnRef>
+          <a:fillRef idx="3">
+            <a:schemeClr val="accent1"/>
+          </a:fillRef>
+          <a:effectRef idx="2">
+            <a:schemeClr val="accent1"/>
+          </a:effectRef>
+          <a:fontRef idx="minor">
+            <a:schemeClr val="lt1"/>
+          </a:fontRef>
+        </p:style>
+        <p:txBody>
+          <a:bodyPr rtlCol="0" anchor="ctr"/>
+          <a:lstStyle/>
+          <a:p>
+            <a:pPr algn="ctr"/>
+          </a:p>
+        </p:txBody>
+      </p:sp>
+      <p:sp>
+        <p:nvSpPr>
+          <p:cNvPr id="7" name="TextBox 6"/>
+          <p:cNvSpPr txBox="1"/>
+          <p:nvPr/>
+        </p:nvSpPr>
+        <p:spPr>
+          <a:xfrm>
+            <a:off x="914400" y="5669280"/>
+            <a:ext cx="5029200" cy="457200"/>
+          </a:xfrm>
+          <a:prstGeom prst="rect">
+            <a:avLst/>
+          </a:prstGeom>
+          <a:noFill/>
+        </p:spPr>
+        <p:txBody>
+          <a:bodyPr wrap="square">
+            <a:spAutoFit/>
+          </a:bodyPr>
+          <a:lstStyle/>
+          <a:p>
+            <a:pPr algn="ctr">
+              <a:defRPr sz="1400" b="0">
+                <a:solidFill>
+                  <a:srgbClr val="A08228"/>
+                </a:solidFill>
+                <a:latin typeface="Arial"/>
+              </a:defRPr>
+            </a:pPr>
+            <a:r>
+              <a:t>HELLUVA BOSS  |  Character Presentation</a:t>
+            </a:r>
+          </a:p>
+        </p:txBody>
+      </p:sp>
+      <p:sp>
+        <p:nvSpPr>
+          <p:cNvPr id="8" name="Rectangle 7"/>
+          <p:cNvSpPr/>
+          <p:nvPr/>
+        </p:nvSpPr>
+        <p:spPr>
+          <a:xfrm>
+            <a:off x="6217920" y="457200"/>
+            <a:ext cx="45720" cy="5943600"/>
+          </a:xfrm>
+          <a:prstGeom prst="rect">
+            <a:avLst/>
+          </a:prstGeom>
+          <a:solidFill>
+            <a:srgbClr val="D4AF37"/>
+          </a:solidFill>
+          <a:ln>
+            <a:noFill/>
+          </a:ln>
+        </p:spPr>
+        <p:style>
+          <a:lnRef idx="1">
+            <a:schemeClr val="accent1"/>
+          </a:lnRef>
+          <a:fillRef idx="3">
+            <a:schemeClr val="accent1"/>
+          </a:fillRef>
+          <a:effectRef idx="2">
+            <a:schemeClr val="accent1"/>
+          </a:effectRef>
+          <a:fontRef idx="minor">
+            <a:schemeClr val="lt1"/>
+          </a:fontRef>
+        </p:style>
+        <p:txBody>
+          <a:bodyPr rtlCol="0" anchor="ctr"/>
+          <a:lstStyle/>
+          <a:p>
+            <a:pPr algn="ctr"/>
+          </a:p>
+        </p:txBody>
+      </p:sp>
       <p:pic>
         <p:nvPicPr>
-          <p:cNvPr id="2" name="Picture 1" descr="crimson-1.JPG"/>
+          <p:cNvPr id="9" name="Picture 8" descr="crimson-1.JPG"/>
           <p:cNvPicPr>
             <a:picLocks noChangeAspect="1"/>
           </p:cNvPicPr>
@@ -3122,287 +3395,14 @@
         </p:blipFill>
         <p:spPr>
           <a:xfrm>
-            <a:off x="731520" y="731520"/>
-            <a:ext cx="5420855" cy="5303520"/>
+            <a:off x="6858000" y="1143000"/>
+            <a:ext cx="4673150" cy="4572000"/>
           </a:xfrm>
           <a:prstGeom prst="rect">
             <a:avLst/>
           </a:prstGeom>
         </p:spPr>
       </p:pic>
-      <p:sp>
-        <p:nvSpPr>
-          <p:cNvPr id="3" name="Rectangle 2"/>
-          <p:cNvSpPr/>
-          <p:nvPr/>
-        </p:nvSpPr>
-        <p:spPr>
-          <a:xfrm>
-            <a:off x="5303520" y="457200"/>
-            <a:ext cx="45720" cy="5943600"/>
-          </a:xfrm>
-          <a:prstGeom prst="rect">
-            <a:avLst/>
-          </a:prstGeom>
-          <a:solidFill>
-            <a:srgbClr val="D4AF37"/>
-          </a:solidFill>
-          <a:ln>
-            <a:noFill/>
-          </a:ln>
-        </p:spPr>
-        <p:style>
-          <a:lnRef idx="1">
-            <a:schemeClr val="accent1"/>
-          </a:lnRef>
-          <a:fillRef idx="3">
-            <a:schemeClr val="accent1"/>
-          </a:fillRef>
-          <a:effectRef idx="2">
-            <a:schemeClr val="accent1"/>
-          </a:effectRef>
-          <a:fontRef idx="minor">
-            <a:schemeClr val="lt1"/>
-          </a:fontRef>
-        </p:style>
-        <p:txBody>
-          <a:bodyPr rtlCol="0" anchor="ctr"/>
-          <a:lstStyle/>
-          <a:p>
-            <a:pPr algn="ctr"/>
-          </a:p>
-        </p:txBody>
-      </p:sp>
-      <p:sp>
-        <p:nvSpPr>
-          <p:cNvPr id="4" name="Rectangle 3"/>
-          <p:cNvSpPr/>
-          <p:nvPr/>
-        </p:nvSpPr>
-        <p:spPr>
-          <a:xfrm>
-            <a:off x="5760720" y="1828800"/>
-            <a:ext cx="5029200" cy="36576"/>
-          </a:xfrm>
-          <a:prstGeom prst="rect">
-            <a:avLst/>
-          </a:prstGeom>
-          <a:solidFill>
-            <a:srgbClr val="D4AF37"/>
-          </a:solidFill>
-          <a:ln>
-            <a:noFill/>
-          </a:ln>
-        </p:spPr>
-        <p:style>
-          <a:lnRef idx="1">
-            <a:schemeClr val="accent1"/>
-          </a:lnRef>
-          <a:fillRef idx="3">
-            <a:schemeClr val="accent1"/>
-          </a:fillRef>
-          <a:effectRef idx="2">
-            <a:schemeClr val="accent1"/>
-          </a:effectRef>
-          <a:fontRef idx="minor">
-            <a:schemeClr val="lt1"/>
-          </a:fontRef>
-        </p:style>
-        <p:txBody>
-          <a:bodyPr rtlCol="0" anchor="ctr"/>
-          <a:lstStyle/>
-          <a:p>
-            <a:pPr algn="ctr"/>
-          </a:p>
-        </p:txBody>
-      </p:sp>
-      <p:sp>
-        <p:nvSpPr>
-          <p:cNvPr id="5" name="TextBox 4"/>
-          <p:cNvSpPr txBox="1"/>
-          <p:nvPr/>
-        </p:nvSpPr>
-        <p:spPr>
-          <a:xfrm>
-            <a:off x="5760720" y="2103120"/>
-            <a:ext cx="5486400" cy="1371600"/>
-          </a:xfrm>
-          <a:prstGeom prst="rect">
-            <a:avLst/>
-          </a:prstGeom>
-          <a:noFill/>
-        </p:spPr>
-        <p:txBody>
-          <a:bodyPr wrap="square">
-            <a:spAutoFit/>
-          </a:bodyPr>
-          <a:lstStyle/>
-          <a:p>
-            <a:pPr algn="ctr">
-              <a:defRPr sz="7600" b="1">
-                <a:solidFill>
-                  <a:srgbClr val="B41E1E"/>
-                </a:solidFill>
-                <a:latin typeface="Arial"/>
-              </a:defRPr>
-            </a:pPr>
-            <a:r>
-              <a:t>CRIMSON</a:t>
-            </a:r>
-          </a:p>
-        </p:txBody>
-      </p:sp>
-      <p:sp>
-        <p:nvSpPr>
-          <p:cNvPr id="6" name="TextBox 5"/>
-          <p:cNvSpPr txBox="1"/>
-          <p:nvPr/>
-        </p:nvSpPr>
-        <p:spPr>
-          <a:xfrm>
-            <a:off x="5760720" y="3291840"/>
-            <a:ext cx="5486400" cy="640080"/>
-          </a:xfrm>
-          <a:prstGeom prst="rect">
-            <a:avLst/>
-          </a:prstGeom>
-          <a:noFill/>
-        </p:spPr>
-        <p:txBody>
-          <a:bodyPr wrap="square">
-            <a:spAutoFit/>
-          </a:bodyPr>
-          <a:lstStyle/>
-          <a:p>
-            <a:pPr algn="ctr">
-              <a:defRPr sz="3600" b="0">
-                <a:solidFill>
-                  <a:srgbClr val="D4AF37"/>
-                </a:solidFill>
-                <a:latin typeface="Arial"/>
-              </a:defRPr>
-            </a:pPr>
-            <a:r>
-              <a:t>Knolastname</a:t>
-            </a:r>
-          </a:p>
-        </p:txBody>
-      </p:sp>
-      <p:sp>
-        <p:nvSpPr>
-          <p:cNvPr id="7" name="TextBox 6"/>
-          <p:cNvSpPr txBox="1"/>
-          <p:nvPr/>
-        </p:nvSpPr>
-        <p:spPr>
-          <a:xfrm>
-            <a:off x="5760720" y="4023360"/>
-            <a:ext cx="5486400" cy="640080"/>
-          </a:xfrm>
-          <a:prstGeom prst="rect">
-            <a:avLst/>
-          </a:prstGeom>
-          <a:noFill/>
-        </p:spPr>
-        <p:txBody>
-          <a:bodyPr wrap="square">
-            <a:spAutoFit/>
-          </a:bodyPr>
-          <a:lstStyle/>
-          <a:p>
-            <a:pPr algn="ctr">
-              <a:defRPr sz="2000" b="0">
-                <a:solidFill>
-                  <a:srgbClr val="BEB9B4"/>
-                </a:solidFill>
-                <a:latin typeface="Arial"/>
-              </a:defRPr>
-            </a:pPr>
-            <a:r>
-              <a:t>Greed Ring's Most Feared Mafia Boss</a:t>
-            </a:r>
-          </a:p>
-        </p:txBody>
-      </p:sp>
-      <p:sp>
-        <p:nvSpPr>
-          <p:cNvPr id="8" name="Rectangle 7"/>
-          <p:cNvSpPr/>
-          <p:nvPr/>
-        </p:nvSpPr>
-        <p:spPr>
-          <a:xfrm>
-            <a:off x="5760720" y="4846320"/>
-            <a:ext cx="5029200" cy="36576"/>
-          </a:xfrm>
-          <a:prstGeom prst="rect">
-            <a:avLst/>
-          </a:prstGeom>
-          <a:solidFill>
-            <a:srgbClr val="D4AF37"/>
-          </a:solidFill>
-          <a:ln>
-            <a:noFill/>
-          </a:ln>
-        </p:spPr>
-        <p:style>
-          <a:lnRef idx="1">
-            <a:schemeClr val="accent1"/>
-          </a:lnRef>
-          <a:fillRef idx="3">
-            <a:schemeClr val="accent1"/>
-          </a:fillRef>
-          <a:effectRef idx="2">
-            <a:schemeClr val="accent1"/>
-          </a:effectRef>
-          <a:fontRef idx="minor">
-            <a:schemeClr val="lt1"/>
-          </a:fontRef>
-        </p:style>
-        <p:txBody>
-          <a:bodyPr rtlCol="0" anchor="ctr"/>
-          <a:lstStyle/>
-          <a:p>
-            <a:pPr algn="ctr"/>
-          </a:p>
-        </p:txBody>
-      </p:sp>
-      <p:sp>
-        <p:nvSpPr>
-          <p:cNvPr id="9" name="TextBox 8"/>
-          <p:cNvSpPr txBox="1"/>
-          <p:nvPr/>
-        </p:nvSpPr>
-        <p:spPr>
-          <a:xfrm>
-            <a:off x="5760720" y="5669280"/>
-            <a:ext cx="5486400" cy="457200"/>
-          </a:xfrm>
-          <a:prstGeom prst="rect">
-            <a:avLst/>
-          </a:prstGeom>
-          <a:noFill/>
-        </p:spPr>
-        <p:txBody>
-          <a:bodyPr wrap="square">
-            <a:spAutoFit/>
-          </a:bodyPr>
-          <a:lstStyle/>
-          <a:p>
-            <a:pPr algn="ctr">
-              <a:defRPr sz="1400" b="0">
-                <a:solidFill>
-                  <a:srgbClr val="A08228"/>
-                </a:solidFill>
-                <a:latin typeface="Arial"/>
-              </a:defRPr>
-            </a:pPr>
-            <a:r>
-              <a:t>HELLUVA BOSS  |  Character Presentation</a:t>
-            </a:r>
-          </a:p>
-        </p:txBody>
-      </p:sp>
     </p:spTree>
   </p:cSld>
   <p:clrMapOvr>
@@ -3417,7 +3417,7 @@
     <p:bg>
       <p:bgPr>
         <a:solidFill>
-          <a:srgbClr val="120C12"/>
+          <a:srgbClr val="120C0C"/>
         </a:solidFill>
         <a:effectLst/>
       </p:bgPr>
@@ -3429,9 +3429,52 @@
         <p:nvPr/>
       </p:nvGrpSpPr>
       <p:grpSpPr/>
+      <p:sp>
+        <p:nvSpPr>
+          <p:cNvPr id="2" name="Rectangle 1"/>
+          <p:cNvSpPr/>
+          <p:nvPr/>
+        </p:nvSpPr>
+        <p:spPr>
+          <a:xfrm>
+            <a:off x="457200" y="731520"/>
+            <a:ext cx="4114800" cy="5486400"/>
+          </a:xfrm>
+          <a:prstGeom prst="rect">
+            <a:avLst/>
+          </a:prstGeom>
+          <a:solidFill>
+            <a:srgbClr val="120C0C"/>
+          </a:solidFill>
+          <a:ln>
+            <a:noFill/>
+          </a:ln>
+        </p:spPr>
+        <p:style>
+          <a:lnRef idx="1">
+            <a:schemeClr val="accent1"/>
+          </a:lnRef>
+          <a:fillRef idx="3">
+            <a:schemeClr val="accent1"/>
+          </a:fillRef>
+          <a:effectRef idx="2">
+            <a:schemeClr val="accent1"/>
+          </a:effectRef>
+          <a:fontRef idx="minor">
+            <a:schemeClr val="lt1"/>
+          </a:fontRef>
+        </p:style>
+        <p:txBody>
+          <a:bodyPr rtlCol="0" anchor="ctr"/>
+          <a:lstStyle/>
+          <a:p>
+            <a:pPr algn="ctr"/>
+          </a:p>
+        </p:txBody>
+      </p:sp>
       <p:pic>
         <p:nvPicPr>
-          <p:cNvPr id="2" name="Picture 1" descr="crimson-2.PNG"/>
+          <p:cNvPr id="3" name="Picture 2" descr="crimson-2.PNG"/>
           <p:cNvPicPr>
             <a:picLocks noChangeAspect="1"/>
           </p:cNvPicPr>
@@ -3445,8 +3488,8 @@
         </p:blipFill>
         <p:spPr>
           <a:xfrm>
-            <a:off x="457200" y="914400"/>
-            <a:ext cx="5899355" cy="5486400"/>
+            <a:off x="731520" y="1371600"/>
+            <a:ext cx="4424516" cy="4114800"/>
           </a:xfrm>
           <a:prstGeom prst="rect">
             <a:avLst/>
@@ -3455,13 +3498,13 @@
       </p:pic>
       <p:sp>
         <p:nvSpPr>
-          <p:cNvPr id="3" name="Rectangle 2"/>
+          <p:cNvPr id="4" name="Rectangle 3"/>
           <p:cNvSpPr/>
           <p:nvPr/>
         </p:nvSpPr>
         <p:spPr>
           <a:xfrm>
-            <a:off x="4389120" y="0"/>
+            <a:off x="4846320" y="0"/>
             <a:ext cx="45720" cy="6858000"/>
           </a:xfrm>
           <a:prstGeom prst="rect">
@@ -3498,14 +3541,14 @@
       </p:sp>
       <p:sp>
         <p:nvSpPr>
-          <p:cNvPr id="4" name="TextBox 3"/>
+          <p:cNvPr id="5" name="TextBox 4"/>
           <p:cNvSpPr txBox="1"/>
           <p:nvPr/>
         </p:nvSpPr>
         <p:spPr>
           <a:xfrm>
-            <a:off x="4846320" y="457200"/>
-            <a:ext cx="6858000" cy="548640"/>
+            <a:off x="5303520" y="457200"/>
+            <a:ext cx="6400800" cy="548640"/>
           </a:xfrm>
           <a:prstGeom prst="rect">
             <a:avLst/>
@@ -3534,14 +3577,14 @@
       </p:sp>
       <p:sp>
         <p:nvSpPr>
-          <p:cNvPr id="5" name="TextBox 4"/>
+          <p:cNvPr id="6" name="TextBox 5"/>
           <p:cNvSpPr txBox="1"/>
           <p:nvPr/>
         </p:nvSpPr>
         <p:spPr>
           <a:xfrm>
-            <a:off x="4846320" y="914400"/>
-            <a:ext cx="6858000" cy="822960"/>
+            <a:off x="5303520" y="914400"/>
+            <a:ext cx="6400800" cy="822960"/>
           </a:xfrm>
           <a:prstGeom prst="rect">
             <a:avLst/>
@@ -3570,14 +3613,14 @@
       </p:sp>
       <p:sp>
         <p:nvSpPr>
-          <p:cNvPr id="6" name="Rectangle 5"/>
+          <p:cNvPr id="7" name="Rectangle 6"/>
           <p:cNvSpPr/>
           <p:nvPr/>
         </p:nvSpPr>
         <p:spPr>
           <a:xfrm>
-            <a:off x="4846320" y="1737360"/>
-            <a:ext cx="5029200" cy="36576"/>
+            <a:off x="5303520" y="1737360"/>
+            <a:ext cx="4572000" cy="36576"/>
           </a:xfrm>
           <a:prstGeom prst="rect">
             <a:avLst/>
@@ -3613,14 +3656,14 @@
       </p:sp>
       <p:sp>
         <p:nvSpPr>
-          <p:cNvPr id="7" name="TextBox 6"/>
+          <p:cNvPr id="8" name="TextBox 7"/>
           <p:cNvSpPr txBox="1"/>
           <p:nvPr/>
         </p:nvSpPr>
         <p:spPr>
           <a:xfrm>
-            <a:off x="5029200" y="2103120"/>
-            <a:ext cx="5943600" cy="4572000"/>
+            <a:off x="5486400" y="2103120"/>
+            <a:ext cx="6217920" cy="4572000"/>
           </a:xfrm>
           <a:prstGeom prst="rect">
             <a:avLst/>
@@ -4219,8 +4262,8 @@
         </p:blipFill>
         <p:spPr>
           <a:xfrm>
-            <a:off x="731520" y="1645920"/>
-            <a:ext cx="3478913" cy="4572000"/>
+            <a:off x="914400" y="1645920"/>
+            <a:ext cx="3131021" cy="4114800"/>
           </a:xfrm>
           <a:prstGeom prst="rect">
             <a:avLst/>
@@ -4235,8 +4278,8 @@
         </p:nvSpPr>
         <p:spPr>
           <a:xfrm>
-            <a:off x="5029200" y="1828800"/>
-            <a:ext cx="6400800" cy="4114800"/>
+            <a:off x="5029200" y="1645920"/>
+            <a:ext cx="6675120" cy="3657600"/>
           </a:xfrm>
           <a:prstGeom prst="rect">
             <a:avLst/>
@@ -4251,7 +4294,7 @@
           <a:p>
             <a:pPr algn="l">
               <a:spcAft>
-                <a:spcPts val="1760"/>
+                <a:spcPts val="1100"/>
               </a:spcAft>
               <a:defRPr sz="2200" b="0">
                 <a:solidFill>
@@ -4267,7 +4310,7 @@
           <a:p>
             <a:pPr algn="l">
               <a:spcAft>
-                <a:spcPts val="1760"/>
+                <a:spcPts val="1100"/>
               </a:spcAft>
               <a:defRPr sz="2200" b="0">
                 <a:solidFill>
@@ -4283,7 +4326,7 @@
           <a:p>
             <a:pPr algn="l">
               <a:spcAft>
-                <a:spcPts val="1760"/>
+                <a:spcPts val="1100"/>
               </a:spcAft>
               <a:defRPr sz="2200" b="0">
                 <a:solidFill>
@@ -4299,7 +4342,7 @@
           <a:p>
             <a:pPr algn="l">
               <a:spcAft>
-                <a:spcPts val="1760"/>
+                <a:spcPts val="1100"/>
               </a:spcAft>
               <a:defRPr sz="2200" b="0">
                 <a:solidFill>
@@ -4315,7 +4358,7 @@
           <a:p>
             <a:pPr algn="l">
               <a:spcAft>
-                <a:spcPts val="1760"/>
+                <a:spcPts val="1100"/>
               </a:spcAft>
               <a:defRPr sz="2200" b="0">
                 <a:solidFill>
@@ -4331,7 +4374,7 @@
           <a:p>
             <a:pPr algn="l">
               <a:spcAft>
-                <a:spcPts val="1760"/>
+                <a:spcPts val="1100"/>
               </a:spcAft>
               <a:defRPr sz="2200" b="0">
                 <a:solidFill>
@@ -4347,7 +4390,7 @@
           <a:p>
             <a:pPr algn="l">
               <a:spcAft>
-                <a:spcPts val="1760"/>
+                <a:spcPts val="1100"/>
               </a:spcAft>
               <a:defRPr sz="2200" b="0">
                 <a:solidFill>
@@ -4370,8 +4413,8 @@
         </p:nvSpPr>
         <p:spPr>
           <a:xfrm>
-            <a:off x="5029200" y="5669280"/>
-            <a:ext cx="6400800" cy="548640"/>
+            <a:off x="5029200" y="5943600"/>
+            <a:ext cx="6675120" cy="457200"/>
           </a:xfrm>
           <a:prstGeom prst="rect">
             <a:avLst/>
@@ -4385,7 +4428,7 @@
           <a:lstStyle/>
           <a:p>
             <a:pPr algn="l">
-              <a:defRPr sz="1600" b="0">
+              <a:defRPr sz="1500" b="0">
                 <a:solidFill>
                   <a:srgbClr val="BEB9B4"/>
                 </a:solidFill>
@@ -4554,8 +4597,8 @@
         </p:nvSpPr>
         <p:spPr>
           <a:xfrm>
-            <a:off x="274320" y="1371600"/>
-            <a:ext cx="5029200" cy="5212080"/>
+            <a:off x="457200" y="1371600"/>
+            <a:ext cx="4572000" cy="5212080"/>
           </a:xfrm>
           <a:prstGeom prst="rect">
             <a:avLst/>
@@ -4605,7 +4648,7 @@
         </p:blipFill>
         <p:spPr>
           <a:xfrm>
-            <a:off x="457200" y="1371600"/>
+            <a:off x="731520" y="1371600"/>
             <a:ext cx="5852160" cy="5029200"/>
           </a:xfrm>
           <a:prstGeom prst="rect">
@@ -4621,8 +4664,8 @@
         </p:nvSpPr>
         <p:spPr>
           <a:xfrm>
-            <a:off x="6217920" y="1645920"/>
-            <a:ext cx="5486400" cy="4572000"/>
+            <a:off x="6400800" y="1645920"/>
+            <a:ext cx="5303520" cy="4572000"/>
           </a:xfrm>
           <a:prstGeom prst="rect">
             <a:avLst/>
@@ -4913,7 +4956,7 @@
         <p:spPr>
           <a:xfrm>
             <a:off x="7315200" y="1645920"/>
-            <a:ext cx="4572000" cy="4572000"/>
+            <a:ext cx="4389120" cy="4389120"/>
           </a:xfrm>
           <a:prstGeom prst="rect">
             <a:avLst/>
@@ -5167,8 +5210,8 @@
         </p:blipFill>
         <p:spPr>
           <a:xfrm>
-            <a:off x="6217920" y="274320"/>
-            <a:ext cx="7420598" cy="6309360"/>
+            <a:off x="6217920" y="457200"/>
+            <a:ext cx="6990418" cy="5943600"/>
           </a:xfrm>
           <a:prstGeom prst="rect">
             <a:avLst/>
@@ -5608,8 +5651,8 @@
         </p:blipFill>
         <p:spPr>
           <a:xfrm>
-            <a:off x="6858000" y="1371600"/>
-            <a:ext cx="4846320" cy="2724693"/>
+            <a:off x="7132320" y="2286000"/>
+            <a:ext cx="4572000" cy="2570465"/>
           </a:xfrm>
           <a:prstGeom prst="rect">
             <a:avLst/>
@@ -5624,8 +5667,8 @@
         </p:nvSpPr>
         <p:spPr>
           <a:xfrm>
-            <a:off x="731520" y="1463040"/>
-            <a:ext cx="5486400" cy="457200"/>
+            <a:off x="731520" y="1554480"/>
+            <a:ext cx="5943600" cy="457200"/>
           </a:xfrm>
           <a:prstGeom prst="rect">
             <a:avLst/>
@@ -5660,8 +5703,8 @@
         </p:nvSpPr>
         <p:spPr>
           <a:xfrm>
-            <a:off x="731520" y="1874520"/>
-            <a:ext cx="5486400" cy="731520"/>
+            <a:off x="731520" y="2011680"/>
+            <a:ext cx="5943600" cy="731520"/>
           </a:xfrm>
           <a:prstGeom prst="rect">
             <a:avLst/>
@@ -5696,8 +5739,8 @@
         </p:nvSpPr>
         <p:spPr>
           <a:xfrm>
-            <a:off x="731520" y="2697480"/>
-            <a:ext cx="5486400" cy="457200"/>
+            <a:off x="731520" y="2834639"/>
+            <a:ext cx="5943600" cy="457200"/>
           </a:xfrm>
           <a:prstGeom prst="rect">
             <a:avLst/>
@@ -5732,8 +5775,8 @@
         </p:nvSpPr>
         <p:spPr>
           <a:xfrm>
-            <a:off x="731520" y="3108960"/>
-            <a:ext cx="5486400" cy="731520"/>
+            <a:off x="731520" y="3291839"/>
+            <a:ext cx="5943600" cy="731520"/>
           </a:xfrm>
           <a:prstGeom prst="rect">
             <a:avLst/>
@@ -5772,8 +5815,8 @@
         </p:nvSpPr>
         <p:spPr>
           <a:xfrm>
-            <a:off x="731520" y="3931920"/>
-            <a:ext cx="5486400" cy="457200"/>
+            <a:off x="731520" y="4114800"/>
+            <a:ext cx="5943600" cy="457200"/>
           </a:xfrm>
           <a:prstGeom prst="rect">
             <a:avLst/>
@@ -5808,8 +5851,8 @@
         </p:nvSpPr>
         <p:spPr>
           <a:xfrm>
-            <a:off x="731520" y="4343400"/>
-            <a:ext cx="5486400" cy="731520"/>
+            <a:off x="731520" y="4572000"/>
+            <a:ext cx="5943600" cy="731520"/>
           </a:xfrm>
           <a:prstGeom prst="rect">
             <a:avLst/>
@@ -5844,8 +5887,8 @@
         </p:nvSpPr>
         <p:spPr>
           <a:xfrm>
-            <a:off x="731520" y="5166360"/>
-            <a:ext cx="5486400" cy="457200"/>
+            <a:off x="731520" y="5394960"/>
+            <a:ext cx="5943600" cy="457200"/>
           </a:xfrm>
           <a:prstGeom prst="rect">
             <a:avLst/>
@@ -5880,8 +5923,8 @@
         </p:nvSpPr>
         <p:spPr>
           <a:xfrm>
-            <a:off x="731520" y="5577840"/>
-            <a:ext cx="5486400" cy="731520"/>
+            <a:off x="731520" y="5852160"/>
+            <a:ext cx="5943600" cy="731520"/>
           </a:xfrm>
           <a:prstGeom prst="rect">
             <a:avLst/>
@@ -5926,7 +5969,7 @@
     <p:bg>
       <p:bgPr>
         <a:solidFill>
-          <a:srgbClr val="12120F"/>
+          <a:srgbClr val="120C0C"/>
         </a:solidFill>
         <a:effectLst/>
       </p:bgPr>
@@ -6076,8 +6119,8 @@
         </p:blipFill>
         <p:spPr>
           <a:xfrm>
-            <a:off x="548640" y="1463040"/>
-            <a:ext cx="5160630" cy="4754880"/>
+            <a:off x="731520" y="1645920"/>
+            <a:ext cx="4763658" cy="4389120"/>
           </a:xfrm>
           <a:prstGeom prst="rect">
             <a:avLst/>
@@ -6092,8 +6135,8 @@
         </p:nvSpPr>
         <p:spPr>
           <a:xfrm>
-            <a:off x="5669280" y="1645920"/>
-            <a:ext cx="5943600" cy="5029200"/>
+            <a:off x="5943600" y="1645920"/>
+            <a:ext cx="5760720" cy="5029200"/>
           </a:xfrm>
           <a:prstGeom prst="rect">
             <a:avLst/>
@@ -6422,8 +6465,8 @@
         </p:blipFill>
         <p:spPr>
           <a:xfrm>
-            <a:off x="457200" y="1645920"/>
-            <a:ext cx="7805394" cy="4572000"/>
+            <a:off x="457200" y="1828800"/>
+            <a:ext cx="6244315" cy="3657600"/>
           </a:xfrm>
           <a:prstGeom prst="rect">
             <a:avLst/>
@@ -6438,8 +6481,8 @@
         </p:nvSpPr>
         <p:spPr>
           <a:xfrm>
-            <a:off x="5943600" y="1645920"/>
-            <a:ext cx="5760720" cy="5029200"/>
+            <a:off x="6400800" y="1645920"/>
+            <a:ext cx="5303520" cy="5029200"/>
           </a:xfrm>
           <a:prstGeom prst="rect">
             <a:avLst/>
@@ -6784,7 +6827,7 @@
         </p:blipFill>
         <p:spPr>
           <a:xfrm>
-            <a:off x="731520" y="1828800"/>
+            <a:off x="7589520" y="1828800"/>
             <a:ext cx="4114800" cy="4114800"/>
           </a:xfrm>
           <a:prstGeom prst="rect">
@@ -6800,8 +6843,8 @@
         </p:nvSpPr>
         <p:spPr>
           <a:xfrm>
-            <a:off x="5029200" y="1645920"/>
-            <a:ext cx="6675120" cy="640080"/>
+            <a:off x="731520" y="1645920"/>
+            <a:ext cx="6400800" cy="640080"/>
           </a:xfrm>
           <a:prstGeom prst="rect">
             <a:avLst/>
@@ -6836,8 +6879,8 @@
         </p:nvSpPr>
         <p:spPr>
           <a:xfrm>
-            <a:off x="5029200" y="2194560"/>
-            <a:ext cx="6675120" cy="822960"/>
+            <a:off x="731520" y="2148840"/>
+            <a:ext cx="6400800" cy="822960"/>
           </a:xfrm>
           <a:prstGeom prst="rect">
             <a:avLst/>
@@ -6859,7 +6902,11 @@
               </a:defRPr>
             </a:pPr>
             <a:r>
-              <a:t>初登場。モクシーをチャズと政略結婚させようと画策する。</a:t>
+              <a:t>初登場。モクシーをチャズと</a:t>
+            </a:r>
+            <a:br/>
+            <a:r>
+              <a:t>政略結婚させようと画策する。</a:t>
             </a:r>
           </a:p>
         </p:txBody>
@@ -6872,8 +6919,8 @@
         </p:nvSpPr>
         <p:spPr>
           <a:xfrm>
-            <a:off x="5029200" y="3200400"/>
-            <a:ext cx="6675120" cy="640080"/>
+            <a:off x="731520" y="3200400"/>
+            <a:ext cx="6400800" cy="640080"/>
           </a:xfrm>
           <a:prstGeom prst="rect">
             <a:avLst/>
@@ -6908,8 +6955,8 @@
         </p:nvSpPr>
         <p:spPr>
           <a:xfrm>
-            <a:off x="5029200" y="3749039"/>
-            <a:ext cx="6675120" cy="822960"/>
+            <a:off x="731520" y="3703320"/>
+            <a:ext cx="6400800" cy="822960"/>
           </a:xfrm>
           <a:prstGeom prst="rect">
             <a:avLst/>
@@ -6931,11 +6978,11 @@
               </a:defRPr>
             </a:pPr>
             <a:r>
-              <a:t>ストライカーを雇い、フィズロリを人質にして</a:t>
+              <a:t>ストライカーを雇い、フィズロリを</a:t>
             </a:r>
             <a:br/>
             <a:r>
-              <a:t>アスモデウスを脅迫する。</a:t>
+              <a:t>人質にしてアスモデウスを脅迫する。</a:t>
             </a:r>
           </a:p>
         </p:txBody>
@@ -6948,8 +6995,8 @@
         </p:nvSpPr>
         <p:spPr>
           <a:xfrm>
-            <a:off x="5029200" y="4754880"/>
-            <a:ext cx="6675120" cy="640080"/>
+            <a:off x="731520" y="4754880"/>
+            <a:ext cx="6400800" cy="640080"/>
           </a:xfrm>
           <a:prstGeom prst="rect">
             <a:avLst/>
@@ -6973,10 +7020,6 @@
             <a:r>
               <a:t>Mammon's Magnificent Musical</a:t>
             </a:r>
-            <a:br/>
-            <a:r>
-              <a:t>Mid-Season Special</a:t>
-            </a:r>
           </a:p>
         </p:txBody>
       </p:sp>
@@ -6988,8 +7031,8 @@
         </p:nvSpPr>
         <p:spPr>
           <a:xfrm>
-            <a:off x="5029200" y="5303520"/>
-            <a:ext cx="6675120" cy="822960"/>
+            <a:off x="731520" y="5257800"/>
+            <a:ext cx="6400800" cy="822960"/>
           </a:xfrm>
           <a:prstGeom prst="rect">
             <a:avLst/>

</xml_diff>

<commit_message>
Fix WHY WE LOVE HIM slide: remove dark panel, enlarge image
画像を左端から大きく配置し、暗いパネルを削除。
2枚目スクショのレイアウトに合わせた。

https://claude.ai/code/session_01Pt9LYytkm79mcRSuRrKMQn
</commit_message>
<xml_diff>
--- a/crimson_presentation.pptx
+++ b/crimson_presentation.pptx
@@ -3429,52 +3429,9 @@
         <p:nvPr/>
       </p:nvGrpSpPr>
       <p:grpSpPr/>
-      <p:sp>
-        <p:nvSpPr>
-          <p:cNvPr id="2" name="Rectangle 1"/>
-          <p:cNvSpPr/>
-          <p:nvPr/>
-        </p:nvSpPr>
-        <p:spPr>
-          <a:xfrm>
-            <a:off x="457200" y="731520"/>
-            <a:ext cx="4114800" cy="5486400"/>
-          </a:xfrm>
-          <a:prstGeom prst="rect">
-            <a:avLst/>
-          </a:prstGeom>
-          <a:solidFill>
-            <a:srgbClr val="120C0C"/>
-          </a:solidFill>
-          <a:ln>
-            <a:noFill/>
-          </a:ln>
-        </p:spPr>
-        <p:style>
-          <a:lnRef idx="1">
-            <a:schemeClr val="accent1"/>
-          </a:lnRef>
-          <a:fillRef idx="3">
-            <a:schemeClr val="accent1"/>
-          </a:fillRef>
-          <a:effectRef idx="2">
-            <a:schemeClr val="accent1"/>
-          </a:effectRef>
-          <a:fontRef idx="minor">
-            <a:schemeClr val="lt1"/>
-          </a:fontRef>
-        </p:style>
-        <p:txBody>
-          <a:bodyPr rtlCol="0" anchor="ctr"/>
-          <a:lstStyle/>
-          <a:p>
-            <a:pPr algn="ctr"/>
-          </a:p>
-        </p:txBody>
-      </p:sp>
       <p:pic>
         <p:nvPicPr>
-          <p:cNvPr id="3" name="Picture 2" descr="crimson-2.PNG"/>
+          <p:cNvPr id="2" name="Picture 1" descr="crimson-2.PNG"/>
           <p:cNvPicPr>
             <a:picLocks noChangeAspect="1"/>
           </p:cNvPicPr>
@@ -3488,8 +3445,8 @@
         </p:blipFill>
         <p:spPr>
           <a:xfrm>
-            <a:off x="731520" y="1371600"/>
-            <a:ext cx="4424516" cy="4114800"/>
+            <a:off x="0" y="274320"/>
+            <a:ext cx="6882581" cy="6400800"/>
           </a:xfrm>
           <a:prstGeom prst="rect">
             <a:avLst/>
@@ -3498,14 +3455,14 @@
       </p:pic>
       <p:sp>
         <p:nvSpPr>
-          <p:cNvPr id="4" name="Rectangle 3"/>
+          <p:cNvPr id="3" name="Rectangle 2"/>
           <p:cNvSpPr/>
           <p:nvPr/>
         </p:nvSpPr>
         <p:spPr>
           <a:xfrm>
-            <a:off x="4846320" y="0"/>
-            <a:ext cx="45720" cy="6858000"/>
+            <a:off x="4983480" y="0"/>
+            <a:ext cx="36576" cy="6858000"/>
           </a:xfrm>
           <a:prstGeom prst="rect">
             <a:avLst/>
@@ -3541,14 +3498,14 @@
       </p:sp>
       <p:sp>
         <p:nvSpPr>
-          <p:cNvPr id="5" name="TextBox 4"/>
+          <p:cNvPr id="4" name="TextBox 3"/>
           <p:cNvSpPr txBox="1"/>
           <p:nvPr/>
         </p:nvSpPr>
         <p:spPr>
           <a:xfrm>
-            <a:off x="5303520" y="457200"/>
-            <a:ext cx="6400800" cy="548640"/>
+            <a:off x="5486400" y="457200"/>
+            <a:ext cx="6035040" cy="548640"/>
           </a:xfrm>
           <a:prstGeom prst="rect">
             <a:avLst/>
@@ -3577,14 +3534,14 @@
       </p:sp>
       <p:sp>
         <p:nvSpPr>
-          <p:cNvPr id="6" name="TextBox 5"/>
+          <p:cNvPr id="5" name="TextBox 4"/>
           <p:cNvSpPr txBox="1"/>
           <p:nvPr/>
         </p:nvSpPr>
         <p:spPr>
           <a:xfrm>
-            <a:off x="5303520" y="914400"/>
-            <a:ext cx="6400800" cy="822960"/>
+            <a:off x="5486400" y="914400"/>
+            <a:ext cx="6035040" cy="822960"/>
           </a:xfrm>
           <a:prstGeom prst="rect">
             <a:avLst/>
@@ -3613,14 +3570,14 @@
       </p:sp>
       <p:sp>
         <p:nvSpPr>
-          <p:cNvPr id="7" name="Rectangle 6"/>
+          <p:cNvPr id="6" name="Rectangle 5"/>
           <p:cNvSpPr/>
           <p:nvPr/>
         </p:nvSpPr>
         <p:spPr>
           <a:xfrm>
-            <a:off x="5303520" y="1737360"/>
-            <a:ext cx="4572000" cy="36576"/>
+            <a:off x="5486400" y="1737360"/>
+            <a:ext cx="4434840" cy="36576"/>
           </a:xfrm>
           <a:prstGeom prst="rect">
             <a:avLst/>
@@ -3656,14 +3613,14 @@
       </p:sp>
       <p:sp>
         <p:nvSpPr>
-          <p:cNvPr id="8" name="TextBox 7"/>
+          <p:cNvPr id="7" name="TextBox 6"/>
           <p:cNvSpPr txBox="1"/>
           <p:nvPr/>
         </p:nvSpPr>
         <p:spPr>
           <a:xfrm>
-            <a:off x="5486400" y="2103120"/>
-            <a:ext cx="6217920" cy="4572000"/>
+            <a:off x="5623560" y="2148840"/>
+            <a:ext cx="5897880" cy="4526280"/>
           </a:xfrm>
           <a:prstGeom prst="rect">
             <a:avLst/>

</xml_diff>

<commit_message>
Fix WHY WE LOVE HIM: constrain image width to prevent overlap
画像をwidth=5.0に制限し、ゴールドライン(x=5.45)・テキスト(x=6.0)と
重ならないよう修正。

https://claude.ai/code/session_01Pt9LYytkm79mcRSuRrKMQn
</commit_message>
<xml_diff>
--- a/crimson_presentation.pptx
+++ b/crimson_presentation.pptx
@@ -3445,8 +3445,8 @@
         </p:blipFill>
         <p:spPr>
           <a:xfrm>
-            <a:off x="0" y="274320"/>
-            <a:ext cx="6882581" cy="6400800"/>
+            <a:off x="91440" y="1280160"/>
+            <a:ext cx="4572000" cy="4251960"/>
           </a:xfrm>
           <a:prstGeom prst="rect">
             <a:avLst/>

</xml_diff>

<commit_message>
Fix WHY WE LOVE HIM: shrink image, move text/line to right half
画像をwidth=3.8に縮小し左寄せ、ゴールドラインをx=7.0、
テキストをx=7.5に移動して画像との重なりを完全解消。

https://claude.ai/code/session_01Pt9LYytkm79mcRSuRrKMQn
</commit_message>
<xml_diff>
--- a/crimson_presentation.pptx
+++ b/crimson_presentation.pptx
@@ -3445,8 +3445,8 @@
         </p:blipFill>
         <p:spPr>
           <a:xfrm>
-            <a:off x="91440" y="1280160"/>
-            <a:ext cx="4572000" cy="4251960"/>
+            <a:off x="182880" y="1645920"/>
+            <a:ext cx="3474720" cy="3231490"/>
           </a:xfrm>
           <a:prstGeom prst="rect">
             <a:avLst/>
@@ -3461,7 +3461,7 @@
         </p:nvSpPr>
         <p:spPr>
           <a:xfrm>
-            <a:off x="4983480" y="0"/>
+            <a:off x="6400800" y="0"/>
             <a:ext cx="36576" cy="6858000"/>
           </a:xfrm>
           <a:prstGeom prst="rect">
@@ -3504,8 +3504,8 @@
         </p:nvSpPr>
         <p:spPr>
           <a:xfrm>
-            <a:off x="5486400" y="457200"/>
-            <a:ext cx="6035040" cy="548640"/>
+            <a:off x="6858000" y="457200"/>
+            <a:ext cx="4846320" cy="548640"/>
           </a:xfrm>
           <a:prstGeom prst="rect">
             <a:avLst/>
@@ -3540,8 +3540,8 @@
         </p:nvSpPr>
         <p:spPr>
           <a:xfrm>
-            <a:off x="5486400" y="914400"/>
-            <a:ext cx="6035040" cy="822960"/>
+            <a:off x="6858000" y="914400"/>
+            <a:ext cx="4846320" cy="822960"/>
           </a:xfrm>
           <a:prstGeom prst="rect">
             <a:avLst/>
@@ -3576,8 +3576,8 @@
         </p:nvSpPr>
         <p:spPr>
           <a:xfrm>
-            <a:off x="5486400" y="1737360"/>
-            <a:ext cx="4434840" cy="36576"/>
+            <a:off x="6858000" y="1737360"/>
+            <a:ext cx="4114800" cy="36576"/>
           </a:xfrm>
           <a:prstGeom prst="rect">
             <a:avLst/>
@@ -3619,8 +3619,8 @@
         </p:nvSpPr>
         <p:spPr>
           <a:xfrm>
-            <a:off x="5623560" y="2148840"/>
-            <a:ext cx="5897880" cy="4526280"/>
+            <a:off x="6858000" y="2103120"/>
+            <a:ext cx="4846320" cy="4572000"/>
           </a:xfrm>
           <a:prstGeom prst="rect">
             <a:avLst/>

</xml_diff>

<commit_message>
Fix WHY WE LOVE HIM: enlarge image, center in left half
画像をwidth=6.0に拡大し左半分の中央に配置。
ゴールドラインをx=6.6、テキストをx=7.1に調整。

https://claude.ai/code/session_01Pt9LYytkm79mcRSuRrKMQn
</commit_message>
<xml_diff>
--- a/crimson_presentation.pptx
+++ b/crimson_presentation.pptx
@@ -3445,8 +3445,8 @@
         </p:blipFill>
         <p:spPr>
           <a:xfrm>
-            <a:off x="182880" y="1645920"/>
-            <a:ext cx="3474720" cy="3231490"/>
+            <a:off x="274320" y="914400"/>
+            <a:ext cx="5486400" cy="5102352"/>
           </a:xfrm>
           <a:prstGeom prst="rect">
             <a:avLst/>
@@ -3461,7 +3461,7 @@
         </p:nvSpPr>
         <p:spPr>
           <a:xfrm>
-            <a:off x="6400800" y="0"/>
+            <a:off x="6035040" y="0"/>
             <a:ext cx="36576" cy="6858000"/>
           </a:xfrm>
           <a:prstGeom prst="rect">
@@ -3504,8 +3504,8 @@
         </p:nvSpPr>
         <p:spPr>
           <a:xfrm>
-            <a:off x="6858000" y="457200"/>
-            <a:ext cx="4846320" cy="548640"/>
+            <a:off x="6492240" y="457200"/>
+            <a:ext cx="5212080" cy="548640"/>
           </a:xfrm>
           <a:prstGeom prst="rect">
             <a:avLst/>
@@ -3540,8 +3540,8 @@
         </p:nvSpPr>
         <p:spPr>
           <a:xfrm>
-            <a:off x="6858000" y="914400"/>
-            <a:ext cx="4846320" cy="822960"/>
+            <a:off x="6492240" y="914400"/>
+            <a:ext cx="5212080" cy="822960"/>
           </a:xfrm>
           <a:prstGeom prst="rect">
             <a:avLst/>
@@ -3576,8 +3576,8 @@
         </p:nvSpPr>
         <p:spPr>
           <a:xfrm>
-            <a:off x="6858000" y="1737360"/>
-            <a:ext cx="4114800" cy="36576"/>
+            <a:off x="6492240" y="1737360"/>
+            <a:ext cx="4572000" cy="36576"/>
           </a:xfrm>
           <a:prstGeom prst="rect">
             <a:avLst/>
@@ -3619,8 +3619,8 @@
         </p:nvSpPr>
         <p:spPr>
           <a:xfrm>
-            <a:off x="6858000" y="2103120"/>
-            <a:ext cx="4846320" cy="4572000"/>
+            <a:off x="6492240" y="2103120"/>
+            <a:ext cx="5212080" cy="4572000"/>
           </a:xfrm>
           <a:prstGeom prst="rect">
             <a:avLst/>

</xml_diff>

<commit_message>
Regenerate pptx with updated image layout (width=11.0, x=0.5)
https://claude.ai/code/session_01Pt9LYytkm79mcRSuRrKMQn
</commit_message>
<xml_diff>
--- a/crimson_presentation.pptx
+++ b/crimson_presentation.pptx
@@ -3445,8 +3445,8 @@
         </p:blipFill>
         <p:spPr>
           <a:xfrm>
-            <a:off x="274320" y="914400"/>
-            <a:ext cx="5486400" cy="5102352"/>
+            <a:off x="457200" y="914400"/>
+            <a:ext cx="10058400" cy="9354312"/>
           </a:xfrm>
           <a:prstGeom prst="rect">
             <a:avLst/>

</xml_diff>

<commit_message>
Match ideal layout: image width=5.5 left-aligned, text from x=6.2
https://claude.ai/code/session_01Pt9LYytkm79mcRSuRrKMQn
</commit_message>
<xml_diff>
--- a/crimson_presentation.pptx
+++ b/crimson_presentation.pptx
@@ -3445,8 +3445,8 @@
         </p:blipFill>
         <p:spPr>
           <a:xfrm>
-            <a:off x="457200" y="914400"/>
-            <a:ext cx="10058400" cy="9354312"/>
+            <a:off x="0" y="914400"/>
+            <a:ext cx="5029200" cy="4677156"/>
           </a:xfrm>
           <a:prstGeom prst="rect">
             <a:avLst/>
@@ -3461,7 +3461,7 @@
         </p:nvSpPr>
         <p:spPr>
           <a:xfrm>
-            <a:off x="6035040" y="0"/>
+            <a:off x="5303520" y="0"/>
             <a:ext cx="36576" cy="6858000"/>
           </a:xfrm>
           <a:prstGeom prst="rect">
@@ -3504,8 +3504,8 @@
         </p:nvSpPr>
         <p:spPr>
           <a:xfrm>
-            <a:off x="6492240" y="457200"/>
-            <a:ext cx="5212080" cy="548640"/>
+            <a:off x="5669280" y="457200"/>
+            <a:ext cx="6035040" cy="548640"/>
           </a:xfrm>
           <a:prstGeom prst="rect">
             <a:avLst/>
@@ -3540,8 +3540,8 @@
         </p:nvSpPr>
         <p:spPr>
           <a:xfrm>
-            <a:off x="6492240" y="914400"/>
-            <a:ext cx="5212080" cy="822960"/>
+            <a:off x="5669280" y="914400"/>
+            <a:ext cx="6035040" cy="822960"/>
           </a:xfrm>
           <a:prstGeom prst="rect">
             <a:avLst/>
@@ -3576,8 +3576,8 @@
         </p:nvSpPr>
         <p:spPr>
           <a:xfrm>
-            <a:off x="6492240" y="1737360"/>
-            <a:ext cx="4572000" cy="36576"/>
+            <a:off x="5669280" y="1737360"/>
+            <a:ext cx="5029200" cy="36576"/>
           </a:xfrm>
           <a:prstGeom prst="rect">
             <a:avLst/>
@@ -3619,8 +3619,8 @@
         </p:nvSpPr>
         <p:spPr>
           <a:xfrm>
-            <a:off x="6492240" y="2103120"/>
-            <a:ext cx="5212080" cy="4572000"/>
+            <a:off x="5669280" y="2103120"/>
+            <a:ext cx="6035040" cy="4572000"/>
           </a:xfrm>
           <a:prstGeom prst="rect">
             <a:avLst/>

</xml_diff>